<commit_message>
chore: update presenter name to Dev Vashisht across web and PowerPoint decks
- Updated presenter name on Slide 1 points and highlight banner in src/components/gandhiData.ts
- Updated PowerPoint generation scripts (build_gandhi_presentation_com.py, build_gandhi_presentation_pptx.py)
- Rebuilt native PowerPoint deck (gandhi-presentation.pptx) and public distribution assets
- Updated slide preview render for Slide 1

Co-Authored-By: Claude Code <noreply@anthropic.com>
</commit_message>
<xml_diff>
--- a/gandhi-presentation.pptx
+++ b/gandhi-presentation.pptx
@@ -138,7 +138,7 @@
           <p:cNvPr id="2" name="Title 1">
             <a:extLst>
               <a:ext uri="{FF2B5EF4-FFF2-40B4-BE49-F238E27FC236}">
-                <a16:creationId xmlns:a16="http://schemas.microsoft.com/office/drawing/2014/main" id="{DB7A582B-A542-AE62-9A54-9F8202A96E18}"/>
+                <a16:creationId xmlns:a16="http://schemas.microsoft.com/office/drawing/2014/main" id="{622638F4-85A3-95DE-DB4C-06A2CB0A5134}"/>
               </a:ext>
             </a:extLst>
           </p:cNvPr>
@@ -176,7 +176,7 @@
           <p:cNvPr id="3" name="Subtitle 2">
             <a:extLst>
               <a:ext uri="{FF2B5EF4-FFF2-40B4-BE49-F238E27FC236}">
-                <a16:creationId xmlns:a16="http://schemas.microsoft.com/office/drawing/2014/main" id="{A3CA7B8D-3EBC-EF8B-AF19-8449F838A909}"/>
+                <a16:creationId xmlns:a16="http://schemas.microsoft.com/office/drawing/2014/main" id="{1ED3430C-BAD6-A4E3-3290-809CFA09D26F}"/>
               </a:ext>
             </a:extLst>
           </p:cNvPr>
@@ -247,7 +247,7 @@
           <p:cNvPr id="4" name="Date Placeholder 3">
             <a:extLst>
               <a:ext uri="{FF2B5EF4-FFF2-40B4-BE49-F238E27FC236}">
-                <a16:creationId xmlns:a16="http://schemas.microsoft.com/office/drawing/2014/main" id="{011E6E51-8963-5C55-FF7A-52D1EEC69D60}"/>
+                <a16:creationId xmlns:a16="http://schemas.microsoft.com/office/drawing/2014/main" id="{E621892A-3835-0566-1D22-EF0B2D93FE73}"/>
               </a:ext>
             </a:extLst>
           </p:cNvPr>
@@ -263,7 +263,7 @@
           <a:bodyPr/>
           <a:lstStyle/>
           <a:p>
-            <a:fld id="{D33CEBF9-7057-4F18-9884-6A642D3B3D67}" type="datetimeFigureOut">
+            <a:fld id="{D20ADFCE-DC36-4646-BC3E-9394D137F47F}" type="datetimeFigureOut">
               <a:rPr lang="en-ID" smtClean="0"/>
               <a:t>30/09/2026</a:t>
             </a:fld>
@@ -276,7 +276,7 @@
           <p:cNvPr id="5" name="Footer Placeholder 4">
             <a:extLst>
               <a:ext uri="{FF2B5EF4-FFF2-40B4-BE49-F238E27FC236}">
-                <a16:creationId xmlns:a16="http://schemas.microsoft.com/office/drawing/2014/main" id="{B46D0F1C-9086-C680-B742-1DD62B37EF38}"/>
+                <a16:creationId xmlns:a16="http://schemas.microsoft.com/office/drawing/2014/main" id="{84C93A7F-4695-F0EF-00EC-243397D3617A}"/>
               </a:ext>
             </a:extLst>
           </p:cNvPr>
@@ -301,7 +301,7 @@
           <p:cNvPr id="6" name="Slide Number Placeholder 5">
             <a:extLst>
               <a:ext uri="{FF2B5EF4-FFF2-40B4-BE49-F238E27FC236}">
-                <a16:creationId xmlns:a16="http://schemas.microsoft.com/office/drawing/2014/main" id="{C200AC35-99E5-1013-C6A0-66EFEEAE5B5D}"/>
+                <a16:creationId xmlns:a16="http://schemas.microsoft.com/office/drawing/2014/main" id="{317AC32D-920A-A393-A90B-48716E4C439B}"/>
               </a:ext>
             </a:extLst>
           </p:cNvPr>
@@ -317,7 +317,7 @@
           <a:bodyPr/>
           <a:lstStyle/>
           <a:p>
-            <a:fld id="{B551C156-570F-4AF2-839B-8A2692BCD67F}" type="slidenum">
+            <a:fld id="{F794BB37-C24F-4E3A-92B2-696A79320F39}" type="slidenum">
               <a:rPr lang="en-ID" smtClean="0"/>
               <a:t>‹#›</a:t>
             </a:fld>
@@ -328,7 +328,7 @@
     </p:spTree>
     <p:extLst>
       <p:ext uri="{BB962C8B-B14F-4D97-AF65-F5344CB8AC3E}">
-        <p14:creationId xmlns:p14="http://schemas.microsoft.com/office/powerpoint/2010/main" val="511730701"/>
+        <p14:creationId xmlns:p14="http://schemas.microsoft.com/office/powerpoint/2010/main" val="1719823613"/>
       </p:ext>
     </p:extLst>
   </p:cSld>
@@ -360,7 +360,7 @@
           <p:cNvPr id="2" name="Title 1">
             <a:extLst>
               <a:ext uri="{FF2B5EF4-FFF2-40B4-BE49-F238E27FC236}">
-                <a16:creationId xmlns:a16="http://schemas.microsoft.com/office/drawing/2014/main" id="{47CFE8E0-252D-F4D5-2BD5-AFE443A4DB87}"/>
+                <a16:creationId xmlns:a16="http://schemas.microsoft.com/office/drawing/2014/main" id="{691BCC6A-475F-40CE-41A4-41DB3096A7AC}"/>
               </a:ext>
             </a:extLst>
           </p:cNvPr>
@@ -389,7 +389,7 @@
           <p:cNvPr id="3" name="Vertical Text Placeholder 2">
             <a:extLst>
               <a:ext uri="{FF2B5EF4-FFF2-40B4-BE49-F238E27FC236}">
-                <a16:creationId xmlns:a16="http://schemas.microsoft.com/office/drawing/2014/main" id="{9A1B2386-393B-9B95-6DEC-F1E42259BAA9}"/>
+                <a16:creationId xmlns:a16="http://schemas.microsoft.com/office/drawing/2014/main" id="{5710FD37-8647-EC99-7A06-CFE0BF32B144}"/>
               </a:ext>
             </a:extLst>
           </p:cNvPr>
@@ -447,7 +447,7 @@
           <p:cNvPr id="4" name="Date Placeholder 3">
             <a:extLst>
               <a:ext uri="{FF2B5EF4-FFF2-40B4-BE49-F238E27FC236}">
-                <a16:creationId xmlns:a16="http://schemas.microsoft.com/office/drawing/2014/main" id="{F5D0239D-5A78-1A0A-2409-63C5A0A9BAC8}"/>
+                <a16:creationId xmlns:a16="http://schemas.microsoft.com/office/drawing/2014/main" id="{75C0AA1F-9D29-CAFF-F3F6-C862FD9DA0B8}"/>
               </a:ext>
             </a:extLst>
           </p:cNvPr>
@@ -463,7 +463,7 @@
           <a:bodyPr/>
           <a:lstStyle/>
           <a:p>
-            <a:fld id="{D33CEBF9-7057-4F18-9884-6A642D3B3D67}" type="datetimeFigureOut">
+            <a:fld id="{D20ADFCE-DC36-4646-BC3E-9394D137F47F}" type="datetimeFigureOut">
               <a:rPr lang="en-ID" smtClean="0"/>
               <a:t>30/09/2026</a:t>
             </a:fld>
@@ -476,7 +476,7 @@
           <p:cNvPr id="5" name="Footer Placeholder 4">
             <a:extLst>
               <a:ext uri="{FF2B5EF4-FFF2-40B4-BE49-F238E27FC236}">
-                <a16:creationId xmlns:a16="http://schemas.microsoft.com/office/drawing/2014/main" id="{D8E71F14-7B6F-837B-D116-5CFE98121903}"/>
+                <a16:creationId xmlns:a16="http://schemas.microsoft.com/office/drawing/2014/main" id="{04245384-E280-3091-B601-C20BB8F850B1}"/>
               </a:ext>
             </a:extLst>
           </p:cNvPr>
@@ -501,7 +501,7 @@
           <p:cNvPr id="6" name="Slide Number Placeholder 5">
             <a:extLst>
               <a:ext uri="{FF2B5EF4-FFF2-40B4-BE49-F238E27FC236}">
-                <a16:creationId xmlns:a16="http://schemas.microsoft.com/office/drawing/2014/main" id="{C551F601-CAE2-E874-FC97-09ECE9095F7E}"/>
+                <a16:creationId xmlns:a16="http://schemas.microsoft.com/office/drawing/2014/main" id="{299D0EBA-8B5B-9FB1-0C37-7A8ECB96A77C}"/>
               </a:ext>
             </a:extLst>
           </p:cNvPr>
@@ -517,7 +517,7 @@
           <a:bodyPr/>
           <a:lstStyle/>
           <a:p>
-            <a:fld id="{B551C156-570F-4AF2-839B-8A2692BCD67F}" type="slidenum">
+            <a:fld id="{F794BB37-C24F-4E3A-92B2-696A79320F39}" type="slidenum">
               <a:rPr lang="en-ID" smtClean="0"/>
               <a:t>‹#›</a:t>
             </a:fld>
@@ -528,7 +528,7 @@
     </p:spTree>
     <p:extLst>
       <p:ext uri="{BB962C8B-B14F-4D97-AF65-F5344CB8AC3E}">
-        <p14:creationId xmlns:p14="http://schemas.microsoft.com/office/powerpoint/2010/main" val="4152559355"/>
+        <p14:creationId xmlns:p14="http://schemas.microsoft.com/office/powerpoint/2010/main" val="1412543911"/>
       </p:ext>
     </p:extLst>
   </p:cSld>
@@ -560,7 +560,7 @@
           <p:cNvPr id="2" name="Vertical Title 1">
             <a:extLst>
               <a:ext uri="{FF2B5EF4-FFF2-40B4-BE49-F238E27FC236}">
-                <a16:creationId xmlns:a16="http://schemas.microsoft.com/office/drawing/2014/main" id="{4903F9DC-D299-93F2-1985-314D7A683ED6}"/>
+                <a16:creationId xmlns:a16="http://schemas.microsoft.com/office/drawing/2014/main" id="{32E931CC-1007-5DD0-EC8D-801A162272EC}"/>
               </a:ext>
             </a:extLst>
           </p:cNvPr>
@@ -594,7 +594,7 @@
           <p:cNvPr id="3" name="Vertical Text Placeholder 2">
             <a:extLst>
               <a:ext uri="{FF2B5EF4-FFF2-40B4-BE49-F238E27FC236}">
-                <a16:creationId xmlns:a16="http://schemas.microsoft.com/office/drawing/2014/main" id="{B92548F0-DAD9-9DB0-B79B-E7004D5A7CA5}"/>
+                <a16:creationId xmlns:a16="http://schemas.microsoft.com/office/drawing/2014/main" id="{0A8B9F72-25FA-954A-9652-78F4056D98A6}"/>
               </a:ext>
             </a:extLst>
           </p:cNvPr>
@@ -657,7 +657,7 @@
           <p:cNvPr id="4" name="Date Placeholder 3">
             <a:extLst>
               <a:ext uri="{FF2B5EF4-FFF2-40B4-BE49-F238E27FC236}">
-                <a16:creationId xmlns:a16="http://schemas.microsoft.com/office/drawing/2014/main" id="{0636EA93-88BB-FB20-DBC3-071FD6923D21}"/>
+                <a16:creationId xmlns:a16="http://schemas.microsoft.com/office/drawing/2014/main" id="{48ED4A22-5C39-B982-672E-85D097DA941B}"/>
               </a:ext>
             </a:extLst>
           </p:cNvPr>
@@ -673,7 +673,7 @@
           <a:bodyPr/>
           <a:lstStyle/>
           <a:p>
-            <a:fld id="{D33CEBF9-7057-4F18-9884-6A642D3B3D67}" type="datetimeFigureOut">
+            <a:fld id="{D20ADFCE-DC36-4646-BC3E-9394D137F47F}" type="datetimeFigureOut">
               <a:rPr lang="en-ID" smtClean="0"/>
               <a:t>30/09/2026</a:t>
             </a:fld>
@@ -686,7 +686,7 @@
           <p:cNvPr id="5" name="Footer Placeholder 4">
             <a:extLst>
               <a:ext uri="{FF2B5EF4-FFF2-40B4-BE49-F238E27FC236}">
-                <a16:creationId xmlns:a16="http://schemas.microsoft.com/office/drawing/2014/main" id="{F314D6D2-580F-0A69-A832-5B798006CA26}"/>
+                <a16:creationId xmlns:a16="http://schemas.microsoft.com/office/drawing/2014/main" id="{9BD4975F-AE4E-2CAD-D79A-681929F7FBE2}"/>
               </a:ext>
             </a:extLst>
           </p:cNvPr>
@@ -711,7 +711,7 @@
           <p:cNvPr id="6" name="Slide Number Placeholder 5">
             <a:extLst>
               <a:ext uri="{FF2B5EF4-FFF2-40B4-BE49-F238E27FC236}">
-                <a16:creationId xmlns:a16="http://schemas.microsoft.com/office/drawing/2014/main" id="{1B6B5137-0EC5-DE61-69E9-F0DC3A0A0FF7}"/>
+                <a16:creationId xmlns:a16="http://schemas.microsoft.com/office/drawing/2014/main" id="{C21CF532-815C-2F3B-F6FD-694CCB4D03F4}"/>
               </a:ext>
             </a:extLst>
           </p:cNvPr>
@@ -727,7 +727,7 @@
           <a:bodyPr/>
           <a:lstStyle/>
           <a:p>
-            <a:fld id="{B551C156-570F-4AF2-839B-8A2692BCD67F}" type="slidenum">
+            <a:fld id="{F794BB37-C24F-4E3A-92B2-696A79320F39}" type="slidenum">
               <a:rPr lang="en-ID" smtClean="0"/>
               <a:t>‹#›</a:t>
             </a:fld>
@@ -738,7 +738,7 @@
     </p:spTree>
     <p:extLst>
       <p:ext uri="{BB962C8B-B14F-4D97-AF65-F5344CB8AC3E}">
-        <p14:creationId xmlns:p14="http://schemas.microsoft.com/office/powerpoint/2010/main" val="396794435"/>
+        <p14:creationId xmlns:p14="http://schemas.microsoft.com/office/powerpoint/2010/main" val="3379708396"/>
       </p:ext>
     </p:extLst>
   </p:cSld>
@@ -770,7 +770,7 @@
           <p:cNvPr id="2" name="Title 1">
             <a:extLst>
               <a:ext uri="{FF2B5EF4-FFF2-40B4-BE49-F238E27FC236}">
-                <a16:creationId xmlns:a16="http://schemas.microsoft.com/office/drawing/2014/main" id="{A5DEA2D8-9365-FDBD-16E1-6F13B71C73BF}"/>
+                <a16:creationId xmlns:a16="http://schemas.microsoft.com/office/drawing/2014/main" id="{AA9DC258-E65A-79DB-9C66-0D42DF520BB4}"/>
               </a:ext>
             </a:extLst>
           </p:cNvPr>
@@ -799,7 +799,7 @@
           <p:cNvPr id="3" name="Content Placeholder 2">
             <a:extLst>
               <a:ext uri="{FF2B5EF4-FFF2-40B4-BE49-F238E27FC236}">
-                <a16:creationId xmlns:a16="http://schemas.microsoft.com/office/drawing/2014/main" id="{89D58DFA-48CA-7DDC-BC05-6E83804EA20B}"/>
+                <a16:creationId xmlns:a16="http://schemas.microsoft.com/office/drawing/2014/main" id="{F56CC6E3-1E76-7E51-2192-8FA6DFED5901}"/>
               </a:ext>
             </a:extLst>
           </p:cNvPr>
@@ -857,7 +857,7 @@
           <p:cNvPr id="4" name="Date Placeholder 3">
             <a:extLst>
               <a:ext uri="{FF2B5EF4-FFF2-40B4-BE49-F238E27FC236}">
-                <a16:creationId xmlns:a16="http://schemas.microsoft.com/office/drawing/2014/main" id="{E80BE769-52C3-8E43-E6C8-3DC29D915E8C}"/>
+                <a16:creationId xmlns:a16="http://schemas.microsoft.com/office/drawing/2014/main" id="{850BFE1D-549F-BA18-C7EA-51DE4D1367B1}"/>
               </a:ext>
             </a:extLst>
           </p:cNvPr>
@@ -873,7 +873,7 @@
           <a:bodyPr/>
           <a:lstStyle/>
           <a:p>
-            <a:fld id="{D33CEBF9-7057-4F18-9884-6A642D3B3D67}" type="datetimeFigureOut">
+            <a:fld id="{D20ADFCE-DC36-4646-BC3E-9394D137F47F}" type="datetimeFigureOut">
               <a:rPr lang="en-ID" smtClean="0"/>
               <a:t>30/09/2026</a:t>
             </a:fld>
@@ -886,7 +886,7 @@
           <p:cNvPr id="5" name="Footer Placeholder 4">
             <a:extLst>
               <a:ext uri="{FF2B5EF4-FFF2-40B4-BE49-F238E27FC236}">
-                <a16:creationId xmlns:a16="http://schemas.microsoft.com/office/drawing/2014/main" id="{38027F83-44A5-CBF4-57BB-79A59ED88FB5}"/>
+                <a16:creationId xmlns:a16="http://schemas.microsoft.com/office/drawing/2014/main" id="{DD025768-2B2A-FA98-ECCF-F529DE2F3D0B}"/>
               </a:ext>
             </a:extLst>
           </p:cNvPr>
@@ -911,7 +911,7 @@
           <p:cNvPr id="6" name="Slide Number Placeholder 5">
             <a:extLst>
               <a:ext uri="{FF2B5EF4-FFF2-40B4-BE49-F238E27FC236}">
-                <a16:creationId xmlns:a16="http://schemas.microsoft.com/office/drawing/2014/main" id="{14876CEC-64A0-CEA5-717E-95A14A6B1F70}"/>
+                <a16:creationId xmlns:a16="http://schemas.microsoft.com/office/drawing/2014/main" id="{C2250A66-9012-8BFD-F74D-B595051E029A}"/>
               </a:ext>
             </a:extLst>
           </p:cNvPr>
@@ -927,7 +927,7 @@
           <a:bodyPr/>
           <a:lstStyle/>
           <a:p>
-            <a:fld id="{B551C156-570F-4AF2-839B-8A2692BCD67F}" type="slidenum">
+            <a:fld id="{F794BB37-C24F-4E3A-92B2-696A79320F39}" type="slidenum">
               <a:rPr lang="en-ID" smtClean="0"/>
               <a:t>‹#›</a:t>
             </a:fld>
@@ -938,7 +938,7 @@
     </p:spTree>
     <p:extLst>
       <p:ext uri="{BB962C8B-B14F-4D97-AF65-F5344CB8AC3E}">
-        <p14:creationId xmlns:p14="http://schemas.microsoft.com/office/powerpoint/2010/main" val="3003459271"/>
+        <p14:creationId xmlns:p14="http://schemas.microsoft.com/office/powerpoint/2010/main" val="3204957417"/>
       </p:ext>
     </p:extLst>
   </p:cSld>
@@ -970,7 +970,7 @@
           <p:cNvPr id="2" name="Title 1">
             <a:extLst>
               <a:ext uri="{FF2B5EF4-FFF2-40B4-BE49-F238E27FC236}">
-                <a16:creationId xmlns:a16="http://schemas.microsoft.com/office/drawing/2014/main" id="{B38FC6C6-2FD0-F8D1-3E6A-16F6BB556A8D}"/>
+                <a16:creationId xmlns:a16="http://schemas.microsoft.com/office/drawing/2014/main" id="{A0E6229A-7E05-462A-5BF4-BAE686AE987B}"/>
               </a:ext>
             </a:extLst>
           </p:cNvPr>
@@ -1008,7 +1008,7 @@
           <p:cNvPr id="3" name="Text Placeholder 2">
             <a:extLst>
               <a:ext uri="{FF2B5EF4-FFF2-40B4-BE49-F238E27FC236}">
-                <a16:creationId xmlns:a16="http://schemas.microsoft.com/office/drawing/2014/main" id="{18295C89-E355-04B9-ADD1-07F87BDCB5EF}"/>
+                <a16:creationId xmlns:a16="http://schemas.microsoft.com/office/drawing/2014/main" id="{6906D68D-5821-9AC6-8DAC-3A85BA1D91E8}"/>
               </a:ext>
             </a:extLst>
           </p:cNvPr>
@@ -1133,7 +1133,7 @@
           <p:cNvPr id="4" name="Date Placeholder 3">
             <a:extLst>
               <a:ext uri="{FF2B5EF4-FFF2-40B4-BE49-F238E27FC236}">
-                <a16:creationId xmlns:a16="http://schemas.microsoft.com/office/drawing/2014/main" id="{7C577DC2-0DF1-AEA0-B1D3-C24A2B7B1F1C}"/>
+                <a16:creationId xmlns:a16="http://schemas.microsoft.com/office/drawing/2014/main" id="{84F3CAEF-C0CB-DBBE-B4CC-22CA69862F25}"/>
               </a:ext>
             </a:extLst>
           </p:cNvPr>
@@ -1149,7 +1149,7 @@
           <a:bodyPr/>
           <a:lstStyle/>
           <a:p>
-            <a:fld id="{D33CEBF9-7057-4F18-9884-6A642D3B3D67}" type="datetimeFigureOut">
+            <a:fld id="{D20ADFCE-DC36-4646-BC3E-9394D137F47F}" type="datetimeFigureOut">
               <a:rPr lang="en-ID" smtClean="0"/>
               <a:t>30/09/2026</a:t>
             </a:fld>
@@ -1162,7 +1162,7 @@
           <p:cNvPr id="5" name="Footer Placeholder 4">
             <a:extLst>
               <a:ext uri="{FF2B5EF4-FFF2-40B4-BE49-F238E27FC236}">
-                <a16:creationId xmlns:a16="http://schemas.microsoft.com/office/drawing/2014/main" id="{141011EB-8BCD-4F99-62AF-5D3E15606772}"/>
+                <a16:creationId xmlns:a16="http://schemas.microsoft.com/office/drawing/2014/main" id="{683A6D06-77D5-5A2B-4F48-EEEA11FEC3A9}"/>
               </a:ext>
             </a:extLst>
           </p:cNvPr>
@@ -1187,7 +1187,7 @@
           <p:cNvPr id="6" name="Slide Number Placeholder 5">
             <a:extLst>
               <a:ext uri="{FF2B5EF4-FFF2-40B4-BE49-F238E27FC236}">
-                <a16:creationId xmlns:a16="http://schemas.microsoft.com/office/drawing/2014/main" id="{71E564C6-73A5-57A2-DA39-F761FB30AB43}"/>
+                <a16:creationId xmlns:a16="http://schemas.microsoft.com/office/drawing/2014/main" id="{502340F2-8445-4B60-C40C-AE201A6EB5E1}"/>
               </a:ext>
             </a:extLst>
           </p:cNvPr>
@@ -1203,7 +1203,7 @@
           <a:bodyPr/>
           <a:lstStyle/>
           <a:p>
-            <a:fld id="{B551C156-570F-4AF2-839B-8A2692BCD67F}" type="slidenum">
+            <a:fld id="{F794BB37-C24F-4E3A-92B2-696A79320F39}" type="slidenum">
               <a:rPr lang="en-ID" smtClean="0"/>
               <a:t>‹#›</a:t>
             </a:fld>
@@ -1214,7 +1214,7 @@
     </p:spTree>
     <p:extLst>
       <p:ext uri="{BB962C8B-B14F-4D97-AF65-F5344CB8AC3E}">
-        <p14:creationId xmlns:p14="http://schemas.microsoft.com/office/powerpoint/2010/main" val="1654441085"/>
+        <p14:creationId xmlns:p14="http://schemas.microsoft.com/office/powerpoint/2010/main" val="2179475139"/>
       </p:ext>
     </p:extLst>
   </p:cSld>
@@ -1246,7 +1246,7 @@
           <p:cNvPr id="2" name="Title 1">
             <a:extLst>
               <a:ext uri="{FF2B5EF4-FFF2-40B4-BE49-F238E27FC236}">
-                <a16:creationId xmlns:a16="http://schemas.microsoft.com/office/drawing/2014/main" id="{8D4BE478-BA4B-BF60-E56D-46F5C931D3D8}"/>
+                <a16:creationId xmlns:a16="http://schemas.microsoft.com/office/drawing/2014/main" id="{2D1C5270-591D-B4EE-14F6-DD9A850C6B80}"/>
               </a:ext>
             </a:extLst>
           </p:cNvPr>
@@ -1275,7 +1275,7 @@
           <p:cNvPr id="3" name="Content Placeholder 2">
             <a:extLst>
               <a:ext uri="{FF2B5EF4-FFF2-40B4-BE49-F238E27FC236}">
-                <a16:creationId xmlns:a16="http://schemas.microsoft.com/office/drawing/2014/main" id="{A76FACAD-70B9-EBF9-D58F-0FD065903A16}"/>
+                <a16:creationId xmlns:a16="http://schemas.microsoft.com/office/drawing/2014/main" id="{7BD5F629-A641-C0CC-BFDF-2413F13D51C4}"/>
               </a:ext>
             </a:extLst>
           </p:cNvPr>
@@ -1338,7 +1338,7 @@
           <p:cNvPr id="4" name="Content Placeholder 3">
             <a:extLst>
               <a:ext uri="{FF2B5EF4-FFF2-40B4-BE49-F238E27FC236}">
-                <a16:creationId xmlns:a16="http://schemas.microsoft.com/office/drawing/2014/main" id="{0609D059-A1F2-5AEE-A20A-69EE542A955A}"/>
+                <a16:creationId xmlns:a16="http://schemas.microsoft.com/office/drawing/2014/main" id="{8B01F578-EC49-1C62-66D2-F02D4212ABA9}"/>
               </a:ext>
             </a:extLst>
           </p:cNvPr>
@@ -1401,7 +1401,7 @@
           <p:cNvPr id="5" name="Date Placeholder 4">
             <a:extLst>
               <a:ext uri="{FF2B5EF4-FFF2-40B4-BE49-F238E27FC236}">
-                <a16:creationId xmlns:a16="http://schemas.microsoft.com/office/drawing/2014/main" id="{94C97B8E-3DEF-287E-FD7D-2E46A7883AED}"/>
+                <a16:creationId xmlns:a16="http://schemas.microsoft.com/office/drawing/2014/main" id="{30DEE269-A53A-C50E-DE22-BD9464D4DA85}"/>
               </a:ext>
             </a:extLst>
           </p:cNvPr>
@@ -1417,7 +1417,7 @@
           <a:bodyPr/>
           <a:lstStyle/>
           <a:p>
-            <a:fld id="{D33CEBF9-7057-4F18-9884-6A642D3B3D67}" type="datetimeFigureOut">
+            <a:fld id="{D20ADFCE-DC36-4646-BC3E-9394D137F47F}" type="datetimeFigureOut">
               <a:rPr lang="en-ID" smtClean="0"/>
               <a:t>30/09/2026</a:t>
             </a:fld>
@@ -1430,7 +1430,7 @@
           <p:cNvPr id="6" name="Footer Placeholder 5">
             <a:extLst>
               <a:ext uri="{FF2B5EF4-FFF2-40B4-BE49-F238E27FC236}">
-                <a16:creationId xmlns:a16="http://schemas.microsoft.com/office/drawing/2014/main" id="{E27E8CE7-9B27-88F5-DBCF-7FDE800BE948}"/>
+                <a16:creationId xmlns:a16="http://schemas.microsoft.com/office/drawing/2014/main" id="{378F4AFE-8CA9-D4A2-B292-DEEC7E231464}"/>
               </a:ext>
             </a:extLst>
           </p:cNvPr>
@@ -1455,7 +1455,7 @@
           <p:cNvPr id="7" name="Slide Number Placeholder 6">
             <a:extLst>
               <a:ext uri="{FF2B5EF4-FFF2-40B4-BE49-F238E27FC236}">
-                <a16:creationId xmlns:a16="http://schemas.microsoft.com/office/drawing/2014/main" id="{A74B9F9C-E0F2-8FCA-E3BE-0F71C079B075}"/>
+                <a16:creationId xmlns:a16="http://schemas.microsoft.com/office/drawing/2014/main" id="{F02C0B70-2F39-C9E1-A2C8-DA2825751377}"/>
               </a:ext>
             </a:extLst>
           </p:cNvPr>
@@ -1471,7 +1471,7 @@
           <a:bodyPr/>
           <a:lstStyle/>
           <a:p>
-            <a:fld id="{B551C156-570F-4AF2-839B-8A2692BCD67F}" type="slidenum">
+            <a:fld id="{F794BB37-C24F-4E3A-92B2-696A79320F39}" type="slidenum">
               <a:rPr lang="en-ID" smtClean="0"/>
               <a:t>‹#›</a:t>
             </a:fld>
@@ -1482,7 +1482,7 @@
     </p:spTree>
     <p:extLst>
       <p:ext uri="{BB962C8B-B14F-4D97-AF65-F5344CB8AC3E}">
-        <p14:creationId xmlns:p14="http://schemas.microsoft.com/office/powerpoint/2010/main" val="793456872"/>
+        <p14:creationId xmlns:p14="http://schemas.microsoft.com/office/powerpoint/2010/main" val="3974692107"/>
       </p:ext>
     </p:extLst>
   </p:cSld>
@@ -1514,7 +1514,7 @@
           <p:cNvPr id="2" name="Title 1">
             <a:extLst>
               <a:ext uri="{FF2B5EF4-FFF2-40B4-BE49-F238E27FC236}">
-                <a16:creationId xmlns:a16="http://schemas.microsoft.com/office/drawing/2014/main" id="{5DA783CB-4B84-2B5F-06DF-869E9BEDFA2C}"/>
+                <a16:creationId xmlns:a16="http://schemas.microsoft.com/office/drawing/2014/main" id="{DE8044DF-B335-488D-391A-518855BA47E8}"/>
               </a:ext>
             </a:extLst>
           </p:cNvPr>
@@ -1548,7 +1548,7 @@
           <p:cNvPr id="3" name="Text Placeholder 2">
             <a:extLst>
               <a:ext uri="{FF2B5EF4-FFF2-40B4-BE49-F238E27FC236}">
-                <a16:creationId xmlns:a16="http://schemas.microsoft.com/office/drawing/2014/main" id="{DAA7BEC4-91AE-62BC-281E-72E8ED59C1CC}"/>
+                <a16:creationId xmlns:a16="http://schemas.microsoft.com/office/drawing/2014/main" id="{8C3DB028-486B-C5E1-9606-2EE792EC7240}"/>
               </a:ext>
             </a:extLst>
           </p:cNvPr>
@@ -1619,7 +1619,7 @@
           <p:cNvPr id="4" name="Content Placeholder 3">
             <a:extLst>
               <a:ext uri="{FF2B5EF4-FFF2-40B4-BE49-F238E27FC236}">
-                <a16:creationId xmlns:a16="http://schemas.microsoft.com/office/drawing/2014/main" id="{081256B8-B520-3C66-DF9B-EDA57132E389}"/>
+                <a16:creationId xmlns:a16="http://schemas.microsoft.com/office/drawing/2014/main" id="{81C794DE-B0D9-4AAF-A3EC-3DAED7EB8FDB}"/>
               </a:ext>
             </a:extLst>
           </p:cNvPr>
@@ -1682,7 +1682,7 @@
           <p:cNvPr id="5" name="Text Placeholder 4">
             <a:extLst>
               <a:ext uri="{FF2B5EF4-FFF2-40B4-BE49-F238E27FC236}">
-                <a16:creationId xmlns:a16="http://schemas.microsoft.com/office/drawing/2014/main" id="{D07F874E-B8DB-CB53-9F95-BCED84E5B6A6}"/>
+                <a16:creationId xmlns:a16="http://schemas.microsoft.com/office/drawing/2014/main" id="{21ED7006-9D90-897B-3C17-A197E48F29B7}"/>
               </a:ext>
             </a:extLst>
           </p:cNvPr>
@@ -1753,7 +1753,7 @@
           <p:cNvPr id="6" name="Content Placeholder 5">
             <a:extLst>
               <a:ext uri="{FF2B5EF4-FFF2-40B4-BE49-F238E27FC236}">
-                <a16:creationId xmlns:a16="http://schemas.microsoft.com/office/drawing/2014/main" id="{16AFD31C-9E96-F66E-7BB0-41F26EFDA008}"/>
+                <a16:creationId xmlns:a16="http://schemas.microsoft.com/office/drawing/2014/main" id="{220EC63F-8154-634D-1641-41CD885D9227}"/>
               </a:ext>
             </a:extLst>
           </p:cNvPr>
@@ -1816,7 +1816,7 @@
           <p:cNvPr id="7" name="Date Placeholder 6">
             <a:extLst>
               <a:ext uri="{FF2B5EF4-FFF2-40B4-BE49-F238E27FC236}">
-                <a16:creationId xmlns:a16="http://schemas.microsoft.com/office/drawing/2014/main" id="{4751C3A4-2AF5-7D27-326F-0DC93C7FD9F9}"/>
+                <a16:creationId xmlns:a16="http://schemas.microsoft.com/office/drawing/2014/main" id="{BBFB7D71-34B6-CDA7-1E7E-1283E9778B64}"/>
               </a:ext>
             </a:extLst>
           </p:cNvPr>
@@ -1832,7 +1832,7 @@
           <a:bodyPr/>
           <a:lstStyle/>
           <a:p>
-            <a:fld id="{D33CEBF9-7057-4F18-9884-6A642D3B3D67}" type="datetimeFigureOut">
+            <a:fld id="{D20ADFCE-DC36-4646-BC3E-9394D137F47F}" type="datetimeFigureOut">
               <a:rPr lang="en-ID" smtClean="0"/>
               <a:t>30/09/2026</a:t>
             </a:fld>
@@ -1845,7 +1845,7 @@
           <p:cNvPr id="8" name="Footer Placeholder 7">
             <a:extLst>
               <a:ext uri="{FF2B5EF4-FFF2-40B4-BE49-F238E27FC236}">
-                <a16:creationId xmlns:a16="http://schemas.microsoft.com/office/drawing/2014/main" id="{D8B641E8-B6C7-6263-689F-8346EBC55350}"/>
+                <a16:creationId xmlns:a16="http://schemas.microsoft.com/office/drawing/2014/main" id="{55FF8915-8188-D03F-BC16-3EA3051E71F1}"/>
               </a:ext>
             </a:extLst>
           </p:cNvPr>
@@ -1870,7 +1870,7 @@
           <p:cNvPr id="9" name="Slide Number Placeholder 8">
             <a:extLst>
               <a:ext uri="{FF2B5EF4-FFF2-40B4-BE49-F238E27FC236}">
-                <a16:creationId xmlns:a16="http://schemas.microsoft.com/office/drawing/2014/main" id="{B892E0A6-6169-35FC-7F9E-D1082B2DCE88}"/>
+                <a16:creationId xmlns:a16="http://schemas.microsoft.com/office/drawing/2014/main" id="{D9BC073E-EEDF-70D0-3073-EF48F9FB0A20}"/>
               </a:ext>
             </a:extLst>
           </p:cNvPr>
@@ -1886,7 +1886,7 @@
           <a:bodyPr/>
           <a:lstStyle/>
           <a:p>
-            <a:fld id="{B551C156-570F-4AF2-839B-8A2692BCD67F}" type="slidenum">
+            <a:fld id="{F794BB37-C24F-4E3A-92B2-696A79320F39}" type="slidenum">
               <a:rPr lang="en-ID" smtClean="0"/>
               <a:t>‹#›</a:t>
             </a:fld>
@@ -1897,7 +1897,7 @@
     </p:spTree>
     <p:extLst>
       <p:ext uri="{BB962C8B-B14F-4D97-AF65-F5344CB8AC3E}">
-        <p14:creationId xmlns:p14="http://schemas.microsoft.com/office/powerpoint/2010/main" val="3809116869"/>
+        <p14:creationId xmlns:p14="http://schemas.microsoft.com/office/powerpoint/2010/main" val="781670378"/>
       </p:ext>
     </p:extLst>
   </p:cSld>
@@ -1929,7 +1929,7 @@
           <p:cNvPr id="2" name="Title 1">
             <a:extLst>
               <a:ext uri="{FF2B5EF4-FFF2-40B4-BE49-F238E27FC236}">
-                <a16:creationId xmlns:a16="http://schemas.microsoft.com/office/drawing/2014/main" id="{548A5056-787F-53A8-8576-4C844A7C7C1E}"/>
+                <a16:creationId xmlns:a16="http://schemas.microsoft.com/office/drawing/2014/main" id="{E9BB68BB-3990-8BFD-5C43-8E4AE6B4898F}"/>
               </a:ext>
             </a:extLst>
           </p:cNvPr>
@@ -1958,7 +1958,7 @@
           <p:cNvPr id="3" name="Date Placeholder 2">
             <a:extLst>
               <a:ext uri="{FF2B5EF4-FFF2-40B4-BE49-F238E27FC236}">
-                <a16:creationId xmlns:a16="http://schemas.microsoft.com/office/drawing/2014/main" id="{84DCAE80-E95D-EA67-1723-50E6D871669A}"/>
+                <a16:creationId xmlns:a16="http://schemas.microsoft.com/office/drawing/2014/main" id="{4B3B6820-D741-D156-86C9-1A04961FD709}"/>
               </a:ext>
             </a:extLst>
           </p:cNvPr>
@@ -1974,7 +1974,7 @@
           <a:bodyPr/>
           <a:lstStyle/>
           <a:p>
-            <a:fld id="{D33CEBF9-7057-4F18-9884-6A642D3B3D67}" type="datetimeFigureOut">
+            <a:fld id="{D20ADFCE-DC36-4646-BC3E-9394D137F47F}" type="datetimeFigureOut">
               <a:rPr lang="en-ID" smtClean="0"/>
               <a:t>30/09/2026</a:t>
             </a:fld>
@@ -1987,7 +1987,7 @@
           <p:cNvPr id="4" name="Footer Placeholder 3">
             <a:extLst>
               <a:ext uri="{FF2B5EF4-FFF2-40B4-BE49-F238E27FC236}">
-                <a16:creationId xmlns:a16="http://schemas.microsoft.com/office/drawing/2014/main" id="{45FB20A3-89FE-AEDE-1DEF-A8BAC9CD9B6E}"/>
+                <a16:creationId xmlns:a16="http://schemas.microsoft.com/office/drawing/2014/main" id="{4D85701A-631F-698E-8640-DACF93F2847D}"/>
               </a:ext>
             </a:extLst>
           </p:cNvPr>
@@ -2012,7 +2012,7 @@
           <p:cNvPr id="5" name="Slide Number Placeholder 4">
             <a:extLst>
               <a:ext uri="{FF2B5EF4-FFF2-40B4-BE49-F238E27FC236}">
-                <a16:creationId xmlns:a16="http://schemas.microsoft.com/office/drawing/2014/main" id="{161717CA-C5BD-B965-3360-3105EA66343E}"/>
+                <a16:creationId xmlns:a16="http://schemas.microsoft.com/office/drawing/2014/main" id="{143B7F00-E34F-6AC1-E482-4D4FCBA4147F}"/>
               </a:ext>
             </a:extLst>
           </p:cNvPr>
@@ -2028,7 +2028,7 @@
           <a:bodyPr/>
           <a:lstStyle/>
           <a:p>
-            <a:fld id="{B551C156-570F-4AF2-839B-8A2692BCD67F}" type="slidenum">
+            <a:fld id="{F794BB37-C24F-4E3A-92B2-696A79320F39}" type="slidenum">
               <a:rPr lang="en-ID" smtClean="0"/>
               <a:t>‹#›</a:t>
             </a:fld>
@@ -2039,7 +2039,7 @@
     </p:spTree>
     <p:extLst>
       <p:ext uri="{BB962C8B-B14F-4D97-AF65-F5344CB8AC3E}">
-        <p14:creationId xmlns:p14="http://schemas.microsoft.com/office/powerpoint/2010/main" val="3366744188"/>
+        <p14:creationId xmlns:p14="http://schemas.microsoft.com/office/powerpoint/2010/main" val="3391518458"/>
       </p:ext>
     </p:extLst>
   </p:cSld>
@@ -2071,7 +2071,7 @@
           <p:cNvPr id="2" name="Date Placeholder 1">
             <a:extLst>
               <a:ext uri="{FF2B5EF4-FFF2-40B4-BE49-F238E27FC236}">
-                <a16:creationId xmlns:a16="http://schemas.microsoft.com/office/drawing/2014/main" id="{B86D29F0-6672-95AF-920C-C72F3BBA4F38}"/>
+                <a16:creationId xmlns:a16="http://schemas.microsoft.com/office/drawing/2014/main" id="{BAED7A0A-BF26-A3B8-8471-16CA5A21A5CE}"/>
               </a:ext>
             </a:extLst>
           </p:cNvPr>
@@ -2087,7 +2087,7 @@
           <a:bodyPr/>
           <a:lstStyle/>
           <a:p>
-            <a:fld id="{D33CEBF9-7057-4F18-9884-6A642D3B3D67}" type="datetimeFigureOut">
+            <a:fld id="{D20ADFCE-DC36-4646-BC3E-9394D137F47F}" type="datetimeFigureOut">
               <a:rPr lang="en-ID" smtClean="0"/>
               <a:t>30/09/2026</a:t>
             </a:fld>
@@ -2100,7 +2100,7 @@
           <p:cNvPr id="3" name="Footer Placeholder 2">
             <a:extLst>
               <a:ext uri="{FF2B5EF4-FFF2-40B4-BE49-F238E27FC236}">
-                <a16:creationId xmlns:a16="http://schemas.microsoft.com/office/drawing/2014/main" id="{A08AF4C0-EDB5-EF16-8770-6F324C1F9A7E}"/>
+                <a16:creationId xmlns:a16="http://schemas.microsoft.com/office/drawing/2014/main" id="{FE32FD23-1775-944A-A8FE-8B3DFD326C63}"/>
               </a:ext>
             </a:extLst>
           </p:cNvPr>
@@ -2125,7 +2125,7 @@
           <p:cNvPr id="4" name="Slide Number Placeholder 3">
             <a:extLst>
               <a:ext uri="{FF2B5EF4-FFF2-40B4-BE49-F238E27FC236}">
-                <a16:creationId xmlns:a16="http://schemas.microsoft.com/office/drawing/2014/main" id="{AEF6B4AF-ADE1-81CF-E760-A1F129023DE9}"/>
+                <a16:creationId xmlns:a16="http://schemas.microsoft.com/office/drawing/2014/main" id="{F12A4BFF-C078-EDAD-B29C-812F135D2A98}"/>
               </a:ext>
             </a:extLst>
           </p:cNvPr>
@@ -2141,7 +2141,7 @@
           <a:bodyPr/>
           <a:lstStyle/>
           <a:p>
-            <a:fld id="{B551C156-570F-4AF2-839B-8A2692BCD67F}" type="slidenum">
+            <a:fld id="{F794BB37-C24F-4E3A-92B2-696A79320F39}" type="slidenum">
               <a:rPr lang="en-ID" smtClean="0"/>
               <a:t>‹#›</a:t>
             </a:fld>
@@ -2152,7 +2152,7 @@
     </p:spTree>
     <p:extLst>
       <p:ext uri="{BB962C8B-B14F-4D97-AF65-F5344CB8AC3E}">
-        <p14:creationId xmlns:p14="http://schemas.microsoft.com/office/powerpoint/2010/main" val="1345324411"/>
+        <p14:creationId xmlns:p14="http://schemas.microsoft.com/office/powerpoint/2010/main" val="2676142956"/>
       </p:ext>
     </p:extLst>
   </p:cSld>
@@ -2184,7 +2184,7 @@
           <p:cNvPr id="2" name="Title 1">
             <a:extLst>
               <a:ext uri="{FF2B5EF4-FFF2-40B4-BE49-F238E27FC236}">
-                <a16:creationId xmlns:a16="http://schemas.microsoft.com/office/drawing/2014/main" id="{AB2628D6-10DB-107F-060C-BA6E1D005006}"/>
+                <a16:creationId xmlns:a16="http://schemas.microsoft.com/office/drawing/2014/main" id="{0B165287-E20E-F78B-53C5-4EAA1AE2D9B9}"/>
               </a:ext>
             </a:extLst>
           </p:cNvPr>
@@ -2222,7 +2222,7 @@
           <p:cNvPr id="3" name="Content Placeholder 2">
             <a:extLst>
               <a:ext uri="{FF2B5EF4-FFF2-40B4-BE49-F238E27FC236}">
-                <a16:creationId xmlns:a16="http://schemas.microsoft.com/office/drawing/2014/main" id="{516853AA-59FA-B3E8-E0D4-CA5E3F850FEC}"/>
+                <a16:creationId xmlns:a16="http://schemas.microsoft.com/office/drawing/2014/main" id="{17C1FAFB-8C62-B589-6AA0-1F02447D3A6B}"/>
               </a:ext>
             </a:extLst>
           </p:cNvPr>
@@ -2313,7 +2313,7 @@
           <p:cNvPr id="4" name="Text Placeholder 3">
             <a:extLst>
               <a:ext uri="{FF2B5EF4-FFF2-40B4-BE49-F238E27FC236}">
-                <a16:creationId xmlns:a16="http://schemas.microsoft.com/office/drawing/2014/main" id="{EB0468EB-D75F-E601-11B6-95F2A16BCA9B}"/>
+                <a16:creationId xmlns:a16="http://schemas.microsoft.com/office/drawing/2014/main" id="{FC451D3C-0E11-5EB7-3551-B47137ABD954}"/>
               </a:ext>
             </a:extLst>
           </p:cNvPr>
@@ -2384,7 +2384,7 @@
           <p:cNvPr id="5" name="Date Placeholder 4">
             <a:extLst>
               <a:ext uri="{FF2B5EF4-FFF2-40B4-BE49-F238E27FC236}">
-                <a16:creationId xmlns:a16="http://schemas.microsoft.com/office/drawing/2014/main" id="{994CF3A0-9879-817C-1F19-4080BF49C995}"/>
+                <a16:creationId xmlns:a16="http://schemas.microsoft.com/office/drawing/2014/main" id="{6B19C1EB-965E-3348-D0FA-016B66154D73}"/>
               </a:ext>
             </a:extLst>
           </p:cNvPr>
@@ -2400,7 +2400,7 @@
           <a:bodyPr/>
           <a:lstStyle/>
           <a:p>
-            <a:fld id="{D33CEBF9-7057-4F18-9884-6A642D3B3D67}" type="datetimeFigureOut">
+            <a:fld id="{D20ADFCE-DC36-4646-BC3E-9394D137F47F}" type="datetimeFigureOut">
               <a:rPr lang="en-ID" smtClean="0"/>
               <a:t>30/09/2026</a:t>
             </a:fld>
@@ -2413,7 +2413,7 @@
           <p:cNvPr id="6" name="Footer Placeholder 5">
             <a:extLst>
               <a:ext uri="{FF2B5EF4-FFF2-40B4-BE49-F238E27FC236}">
-                <a16:creationId xmlns:a16="http://schemas.microsoft.com/office/drawing/2014/main" id="{277C8B7C-764D-7CBE-0FA1-50EFD3FBC8CF}"/>
+                <a16:creationId xmlns:a16="http://schemas.microsoft.com/office/drawing/2014/main" id="{0D259480-D040-1628-00AA-95D5241D9B98}"/>
               </a:ext>
             </a:extLst>
           </p:cNvPr>
@@ -2438,7 +2438,7 @@
           <p:cNvPr id="7" name="Slide Number Placeholder 6">
             <a:extLst>
               <a:ext uri="{FF2B5EF4-FFF2-40B4-BE49-F238E27FC236}">
-                <a16:creationId xmlns:a16="http://schemas.microsoft.com/office/drawing/2014/main" id="{C1BFEC01-C389-1325-A288-5A545E2BF0A0}"/>
+                <a16:creationId xmlns:a16="http://schemas.microsoft.com/office/drawing/2014/main" id="{83508D0E-347F-5143-18BB-69652D4B7746}"/>
               </a:ext>
             </a:extLst>
           </p:cNvPr>
@@ -2454,7 +2454,7 @@
           <a:bodyPr/>
           <a:lstStyle/>
           <a:p>
-            <a:fld id="{B551C156-570F-4AF2-839B-8A2692BCD67F}" type="slidenum">
+            <a:fld id="{F794BB37-C24F-4E3A-92B2-696A79320F39}" type="slidenum">
               <a:rPr lang="en-ID" smtClean="0"/>
               <a:t>‹#›</a:t>
             </a:fld>
@@ -2465,7 +2465,7 @@
     </p:spTree>
     <p:extLst>
       <p:ext uri="{BB962C8B-B14F-4D97-AF65-F5344CB8AC3E}">
-        <p14:creationId xmlns:p14="http://schemas.microsoft.com/office/powerpoint/2010/main" val="3003881808"/>
+        <p14:creationId xmlns:p14="http://schemas.microsoft.com/office/powerpoint/2010/main" val="1905136066"/>
       </p:ext>
     </p:extLst>
   </p:cSld>
@@ -2497,7 +2497,7 @@
           <p:cNvPr id="2" name="Title 1">
             <a:extLst>
               <a:ext uri="{FF2B5EF4-FFF2-40B4-BE49-F238E27FC236}">
-                <a16:creationId xmlns:a16="http://schemas.microsoft.com/office/drawing/2014/main" id="{BEACFA26-15F1-F68A-2BBE-05E345892E59}"/>
+                <a16:creationId xmlns:a16="http://schemas.microsoft.com/office/drawing/2014/main" id="{B5BAB9B0-8960-305C-A278-51AF98E10390}"/>
               </a:ext>
             </a:extLst>
           </p:cNvPr>
@@ -2535,7 +2535,7 @@
           <p:cNvPr id="3" name="Picture Placeholder 2">
             <a:extLst>
               <a:ext uri="{FF2B5EF4-FFF2-40B4-BE49-F238E27FC236}">
-                <a16:creationId xmlns:a16="http://schemas.microsoft.com/office/drawing/2014/main" id="{0D404587-75FA-F9E8-072B-2DB0ADDE4540}"/>
+                <a16:creationId xmlns:a16="http://schemas.microsoft.com/office/drawing/2014/main" id="{E887B6CA-F775-394F-EE8B-954ACF5CB550}"/>
               </a:ext>
             </a:extLst>
           </p:cNvPr>
@@ -2602,7 +2602,7 @@
           <p:cNvPr id="4" name="Text Placeholder 3">
             <a:extLst>
               <a:ext uri="{FF2B5EF4-FFF2-40B4-BE49-F238E27FC236}">
-                <a16:creationId xmlns:a16="http://schemas.microsoft.com/office/drawing/2014/main" id="{08109789-3C28-B0FA-C886-017D05166BD0}"/>
+                <a16:creationId xmlns:a16="http://schemas.microsoft.com/office/drawing/2014/main" id="{F327E41C-5A5A-34A7-8AE3-8858D72BDE0C}"/>
               </a:ext>
             </a:extLst>
           </p:cNvPr>
@@ -2673,7 +2673,7 @@
           <p:cNvPr id="5" name="Date Placeholder 4">
             <a:extLst>
               <a:ext uri="{FF2B5EF4-FFF2-40B4-BE49-F238E27FC236}">
-                <a16:creationId xmlns:a16="http://schemas.microsoft.com/office/drawing/2014/main" id="{85685ADE-1D6C-8DA0-7E9A-0C17D532B24E}"/>
+                <a16:creationId xmlns:a16="http://schemas.microsoft.com/office/drawing/2014/main" id="{561C49D1-F3DC-5BFB-8A9B-5CD20635BC16}"/>
               </a:ext>
             </a:extLst>
           </p:cNvPr>
@@ -2689,7 +2689,7 @@
           <a:bodyPr/>
           <a:lstStyle/>
           <a:p>
-            <a:fld id="{D33CEBF9-7057-4F18-9884-6A642D3B3D67}" type="datetimeFigureOut">
+            <a:fld id="{D20ADFCE-DC36-4646-BC3E-9394D137F47F}" type="datetimeFigureOut">
               <a:rPr lang="en-ID" smtClean="0"/>
               <a:t>30/09/2026</a:t>
             </a:fld>
@@ -2702,7 +2702,7 @@
           <p:cNvPr id="6" name="Footer Placeholder 5">
             <a:extLst>
               <a:ext uri="{FF2B5EF4-FFF2-40B4-BE49-F238E27FC236}">
-                <a16:creationId xmlns:a16="http://schemas.microsoft.com/office/drawing/2014/main" id="{98F7A68C-C413-ADD1-D2F2-AB4BC870F5CC}"/>
+                <a16:creationId xmlns:a16="http://schemas.microsoft.com/office/drawing/2014/main" id="{645D87E9-2C08-2856-14A2-2487EC3FC6C6}"/>
               </a:ext>
             </a:extLst>
           </p:cNvPr>
@@ -2727,7 +2727,7 @@
           <p:cNvPr id="7" name="Slide Number Placeholder 6">
             <a:extLst>
               <a:ext uri="{FF2B5EF4-FFF2-40B4-BE49-F238E27FC236}">
-                <a16:creationId xmlns:a16="http://schemas.microsoft.com/office/drawing/2014/main" id="{11A0D09A-0413-00A7-3E75-D30E07786ED9}"/>
+                <a16:creationId xmlns:a16="http://schemas.microsoft.com/office/drawing/2014/main" id="{5785E598-9A78-CCA9-9B1F-928342853D56}"/>
               </a:ext>
             </a:extLst>
           </p:cNvPr>
@@ -2743,7 +2743,7 @@
           <a:bodyPr/>
           <a:lstStyle/>
           <a:p>
-            <a:fld id="{B551C156-570F-4AF2-839B-8A2692BCD67F}" type="slidenum">
+            <a:fld id="{F794BB37-C24F-4E3A-92B2-696A79320F39}" type="slidenum">
               <a:rPr lang="en-ID" smtClean="0"/>
               <a:t>‹#›</a:t>
             </a:fld>
@@ -2754,7 +2754,7 @@
     </p:spTree>
     <p:extLst>
       <p:ext uri="{BB962C8B-B14F-4D97-AF65-F5344CB8AC3E}">
-        <p14:creationId xmlns:p14="http://schemas.microsoft.com/office/powerpoint/2010/main" val="1645232076"/>
+        <p14:creationId xmlns:p14="http://schemas.microsoft.com/office/powerpoint/2010/main" val="3916972268"/>
       </p:ext>
     </p:extLst>
   </p:cSld>
@@ -2791,7 +2791,7 @@
           <p:cNvPr id="2" name="Title Placeholder 1">
             <a:extLst>
               <a:ext uri="{FF2B5EF4-FFF2-40B4-BE49-F238E27FC236}">
-                <a16:creationId xmlns:a16="http://schemas.microsoft.com/office/drawing/2014/main" id="{9497C3F3-F938-F365-54C5-5CD180DABA00}"/>
+                <a16:creationId xmlns:a16="http://schemas.microsoft.com/office/drawing/2014/main" id="{088E44FE-BB99-A7EA-2325-52762E79D448}"/>
               </a:ext>
             </a:extLst>
           </p:cNvPr>
@@ -2830,7 +2830,7 @@
           <p:cNvPr id="3" name="Text Placeholder 2">
             <a:extLst>
               <a:ext uri="{FF2B5EF4-FFF2-40B4-BE49-F238E27FC236}">
-                <a16:creationId xmlns:a16="http://schemas.microsoft.com/office/drawing/2014/main" id="{BC0BB018-337C-EB93-76EA-EE1D16714A2C}"/>
+                <a16:creationId xmlns:a16="http://schemas.microsoft.com/office/drawing/2014/main" id="{CE681E63-BADF-AEBC-824E-740F835C7B99}"/>
               </a:ext>
             </a:extLst>
           </p:cNvPr>
@@ -2898,7 +2898,7 @@
           <p:cNvPr id="4" name="Date Placeholder 3">
             <a:extLst>
               <a:ext uri="{FF2B5EF4-FFF2-40B4-BE49-F238E27FC236}">
-                <a16:creationId xmlns:a16="http://schemas.microsoft.com/office/drawing/2014/main" id="{08A7D4E3-55F9-A0AA-1450-E1B3FB6A3AD7}"/>
+                <a16:creationId xmlns:a16="http://schemas.microsoft.com/office/drawing/2014/main" id="{B7E3E05A-1179-7AE7-DF8E-C79E5038A1B0}"/>
               </a:ext>
             </a:extLst>
           </p:cNvPr>
@@ -2932,7 +2932,7 @@
             </a:lvl1pPr>
           </a:lstStyle>
           <a:p>
-            <a:fld id="{D33CEBF9-7057-4F18-9884-6A642D3B3D67}" type="datetimeFigureOut">
+            <a:fld id="{D20ADFCE-DC36-4646-BC3E-9394D137F47F}" type="datetimeFigureOut">
               <a:rPr lang="en-ID" smtClean="0"/>
               <a:t>30/09/2026</a:t>
             </a:fld>
@@ -2945,7 +2945,7 @@
           <p:cNvPr id="5" name="Footer Placeholder 4">
             <a:extLst>
               <a:ext uri="{FF2B5EF4-FFF2-40B4-BE49-F238E27FC236}">
-                <a16:creationId xmlns:a16="http://schemas.microsoft.com/office/drawing/2014/main" id="{94EBD0A5-0E74-5ED0-C2AC-76B257AF46CA}"/>
+                <a16:creationId xmlns:a16="http://schemas.microsoft.com/office/drawing/2014/main" id="{D780B2CD-4E49-E762-22FF-4CBE99C69B09}"/>
               </a:ext>
             </a:extLst>
           </p:cNvPr>
@@ -2988,7 +2988,7 @@
           <p:cNvPr id="6" name="Slide Number Placeholder 5">
             <a:extLst>
               <a:ext uri="{FF2B5EF4-FFF2-40B4-BE49-F238E27FC236}">
-                <a16:creationId xmlns:a16="http://schemas.microsoft.com/office/drawing/2014/main" id="{A77D3AA4-4F1D-3609-584F-251CE2526251}"/>
+                <a16:creationId xmlns:a16="http://schemas.microsoft.com/office/drawing/2014/main" id="{95D46840-84AA-DEB3-5BBC-40932B72CA79}"/>
               </a:ext>
             </a:extLst>
           </p:cNvPr>
@@ -3022,7 +3022,7 @@
             </a:lvl1pPr>
           </a:lstStyle>
           <a:p>
-            <a:fld id="{B551C156-570F-4AF2-839B-8A2692BCD67F}" type="slidenum">
+            <a:fld id="{F794BB37-C24F-4E3A-92B2-696A79320F39}" type="slidenum">
               <a:rPr lang="en-ID" smtClean="0"/>
               <a:t>‹#›</a:t>
             </a:fld>
@@ -3033,7 +3033,7 @@
     </p:spTree>
     <p:extLst>
       <p:ext uri="{BB962C8B-B14F-4D97-AF65-F5344CB8AC3E}">
-        <p14:creationId xmlns:p14="http://schemas.microsoft.com/office/powerpoint/2010/main" val="222937623"/>
+        <p14:creationId xmlns:p14="http://schemas.microsoft.com/office/powerpoint/2010/main" val="1544536637"/>
       </p:ext>
     </p:extLst>
   </p:cSld>
@@ -3356,7 +3356,7 @@
           <p:cNvPr id="2" name="Rectangle 1">
             <a:extLst>
               <a:ext uri="{FF2B5EF4-FFF2-40B4-BE49-F238E27FC236}">
-                <a16:creationId xmlns:a16="http://schemas.microsoft.com/office/drawing/2014/main" id="{60A21AC8-B85F-AC23-84D4-F7DA5E0A0974}"/>
+                <a16:creationId xmlns:a16="http://schemas.microsoft.com/office/drawing/2014/main" id="{6ED550A4-C8CC-8889-3182-A588DE87E2AD}"/>
               </a:ext>
             </a:extLst>
           </p:cNvPr>
@@ -3424,7 +3424,7 @@
           <p:cNvPr id="3" name="Rectangle: Rounded Corners 2">
             <a:extLst>
               <a:ext uri="{FF2B5EF4-FFF2-40B4-BE49-F238E27FC236}">
-                <a16:creationId xmlns:a16="http://schemas.microsoft.com/office/drawing/2014/main" id="{F6A35423-B7F2-162D-C60A-34E6876F67B1}"/>
+                <a16:creationId xmlns:a16="http://schemas.microsoft.com/office/drawing/2014/main" id="{18C322C2-139E-7C11-7804-9497AF8B18F9}"/>
               </a:ext>
             </a:extLst>
           </p:cNvPr>
@@ -3478,7 +3478,7 @@
           <p:cNvPr id="4" name="Rectangle: Rounded Corners 3">
             <a:extLst>
               <a:ext uri="{FF2B5EF4-FFF2-40B4-BE49-F238E27FC236}">
-                <a16:creationId xmlns:a16="http://schemas.microsoft.com/office/drawing/2014/main" id="{FC3BA6C5-3849-724D-D7B2-3D5251367EA7}"/>
+                <a16:creationId xmlns:a16="http://schemas.microsoft.com/office/drawing/2014/main" id="{DB172FFD-A1D1-A680-AD5F-11123BF03699}"/>
               </a:ext>
             </a:extLst>
           </p:cNvPr>
@@ -3529,7 +3529,7 @@
           <p:cNvPr id="5" name="TextBox 4">
             <a:extLst>
               <a:ext uri="{FF2B5EF4-FFF2-40B4-BE49-F238E27FC236}">
-                <a16:creationId xmlns:a16="http://schemas.microsoft.com/office/drawing/2014/main" id="{8D6EC903-F07D-F74D-D1F4-709F144F5051}"/>
+                <a16:creationId xmlns:a16="http://schemas.microsoft.com/office/drawing/2014/main" id="{1AF6094C-E95E-7A15-F17D-6B8FA1458BCE}"/>
               </a:ext>
             </a:extLst>
           </p:cNvPr>
@@ -3569,7 +3569,7 @@
           <p:cNvPr id="6" name="TextBox 5">
             <a:extLst>
               <a:ext uri="{FF2B5EF4-FFF2-40B4-BE49-F238E27FC236}">
-                <a16:creationId xmlns:a16="http://schemas.microsoft.com/office/drawing/2014/main" id="{2DE3B4E2-5651-D745-AFC4-5CC3A1190549}"/>
+                <a16:creationId xmlns:a16="http://schemas.microsoft.com/office/drawing/2014/main" id="{517D546A-C1C8-DEA1-ABD3-0810EDE3590A}"/>
               </a:ext>
             </a:extLst>
           </p:cNvPr>
@@ -3609,7 +3609,7 @@
           <p:cNvPr id="7" name="TextBox 6">
             <a:extLst>
               <a:ext uri="{FF2B5EF4-FFF2-40B4-BE49-F238E27FC236}">
-                <a16:creationId xmlns:a16="http://schemas.microsoft.com/office/drawing/2014/main" id="{8656EB39-E7CA-001A-EE6F-3D091FC87C2D}"/>
+                <a16:creationId xmlns:a16="http://schemas.microsoft.com/office/drawing/2014/main" id="{A1E0B143-043A-C6CD-5D90-C4B796447F78}"/>
               </a:ext>
             </a:extLst>
           </p:cNvPr>
@@ -3649,7 +3649,7 @@
           <p:cNvPr id="8" name="TextBox 7">
             <a:extLst>
               <a:ext uri="{FF2B5EF4-FFF2-40B4-BE49-F238E27FC236}">
-                <a16:creationId xmlns:a16="http://schemas.microsoft.com/office/drawing/2014/main" id="{808B1E0A-2D38-4414-7CA1-921CAB1356B6}"/>
+                <a16:creationId xmlns:a16="http://schemas.microsoft.com/office/drawing/2014/main" id="{018336ED-C996-09B0-B76D-C3468E2CC19C}"/>
               </a:ext>
             </a:extLst>
           </p:cNvPr>
@@ -3689,7 +3689,7 @@
           <p:cNvPr id="9" name="TextBox 8">
             <a:extLst>
               <a:ext uri="{FF2B5EF4-FFF2-40B4-BE49-F238E27FC236}">
-                <a16:creationId xmlns:a16="http://schemas.microsoft.com/office/drawing/2014/main" id="{97F557EB-5875-CCB5-FEC0-889F72D3E219}"/>
+                <a16:creationId xmlns:a16="http://schemas.microsoft.com/office/drawing/2014/main" id="{57EE21D5-79AE-BE9E-6CD5-6387B19C71FC}"/>
               </a:ext>
             </a:extLst>
           </p:cNvPr>
@@ -3735,7 +3735,7 @@
           <p:cNvPr id="10" name="Rectangle: Rounded Corners 9">
             <a:extLst>
               <a:ext uri="{FF2B5EF4-FFF2-40B4-BE49-F238E27FC236}">
-                <a16:creationId xmlns:a16="http://schemas.microsoft.com/office/drawing/2014/main" id="{CDC677A4-BCD9-4CB2-1F35-549539CB069F}"/>
+                <a16:creationId xmlns:a16="http://schemas.microsoft.com/office/drawing/2014/main" id="{E547A7F8-BAB1-AC03-E200-6A9EC397362C}"/>
               </a:ext>
             </a:extLst>
           </p:cNvPr>
@@ -3797,7 +3797,7 @@
           <p:cNvPr id="11" name="TextBox 10">
             <a:extLst>
               <a:ext uri="{FF2B5EF4-FFF2-40B4-BE49-F238E27FC236}">
-                <a16:creationId xmlns:a16="http://schemas.microsoft.com/office/drawing/2014/main" id="{C73A4FF6-FBA8-9030-E020-11BDE973F74C}"/>
+                <a16:creationId xmlns:a16="http://schemas.microsoft.com/office/drawing/2014/main" id="{8C670ADC-0DAE-9E57-6D85-3F83B487A422}"/>
               </a:ext>
             </a:extLst>
           </p:cNvPr>
@@ -3843,7 +3843,7 @@
           <p:cNvPr id="12" name="Rectangle 11">
             <a:extLst>
               <a:ext uri="{FF2B5EF4-FFF2-40B4-BE49-F238E27FC236}">
-                <a16:creationId xmlns:a16="http://schemas.microsoft.com/office/drawing/2014/main" id="{8DB34FBD-74D7-430A-002A-20898D1A09AB}"/>
+                <a16:creationId xmlns:a16="http://schemas.microsoft.com/office/drawing/2014/main" id="{03A70566-AF02-5A3F-6232-E18719833BAE}"/>
               </a:ext>
             </a:extLst>
           </p:cNvPr>
@@ -3911,7 +3911,7 @@
           <p:cNvPr id="13" name="TextBox 12">
             <a:extLst>
               <a:ext uri="{FF2B5EF4-FFF2-40B4-BE49-F238E27FC236}">
-                <a16:creationId xmlns:a16="http://schemas.microsoft.com/office/drawing/2014/main" id="{6ED5F719-2DE9-5ADE-DD9C-5C072AC895EF}"/>
+                <a16:creationId xmlns:a16="http://schemas.microsoft.com/office/drawing/2014/main" id="{648B3AFD-6EF8-520E-D93D-C719774D73AD}"/>
               </a:ext>
             </a:extLst>
           </p:cNvPr>
@@ -3957,7 +3957,7 @@
           <p:cNvPr id="14" name="Rectangle: Rounded Corners 13">
             <a:extLst>
               <a:ext uri="{FF2B5EF4-FFF2-40B4-BE49-F238E27FC236}">
-                <a16:creationId xmlns:a16="http://schemas.microsoft.com/office/drawing/2014/main" id="{A04A5943-583E-B3A1-DE55-F06F7CC3AE0C}"/>
+                <a16:creationId xmlns:a16="http://schemas.microsoft.com/office/drawing/2014/main" id="{5290AEA5-77BB-A1CD-0FBD-AE24280AD803}"/>
               </a:ext>
             </a:extLst>
           </p:cNvPr>
@@ -4011,7 +4011,7 @@
           <p:cNvPr id="15" name="Pentagon 14">
             <a:extLst>
               <a:ext uri="{FF2B5EF4-FFF2-40B4-BE49-F238E27FC236}">
-                <a16:creationId xmlns:a16="http://schemas.microsoft.com/office/drawing/2014/main" id="{B526BE1A-8C5B-C39B-C5A7-F8DF54B879DB}"/>
+                <a16:creationId xmlns:a16="http://schemas.microsoft.com/office/drawing/2014/main" id="{736FC6F4-6F35-CA1D-1CD8-68B9624293FB}"/>
               </a:ext>
             </a:extLst>
           </p:cNvPr>
@@ -4065,7 +4065,7 @@
           <p:cNvPr id="16" name="Pentagon 15">
             <a:extLst>
               <a:ext uri="{FF2B5EF4-FFF2-40B4-BE49-F238E27FC236}">
-                <a16:creationId xmlns:a16="http://schemas.microsoft.com/office/drawing/2014/main" id="{A7CFEAEE-C755-6FAC-CBED-303A3E6DB573}"/>
+                <a16:creationId xmlns:a16="http://schemas.microsoft.com/office/drawing/2014/main" id="{E840B87B-2A9A-AE6B-26AB-12ACABEC2755}"/>
               </a:ext>
             </a:extLst>
           </p:cNvPr>
@@ -4119,7 +4119,7 @@
           <p:cNvPr id="17" name="Pentagon 16">
             <a:extLst>
               <a:ext uri="{FF2B5EF4-FFF2-40B4-BE49-F238E27FC236}">
-                <a16:creationId xmlns:a16="http://schemas.microsoft.com/office/drawing/2014/main" id="{D26CF084-FAF8-2B8B-C946-B1220E533EC4}"/>
+                <a16:creationId xmlns:a16="http://schemas.microsoft.com/office/drawing/2014/main" id="{0653C886-DBBC-87C7-B00F-4741337A0C12}"/>
               </a:ext>
             </a:extLst>
           </p:cNvPr>
@@ -4173,7 +4173,7 @@
           <p:cNvPr id="18" name="Pentagon 17">
             <a:extLst>
               <a:ext uri="{FF2B5EF4-FFF2-40B4-BE49-F238E27FC236}">
-                <a16:creationId xmlns:a16="http://schemas.microsoft.com/office/drawing/2014/main" id="{387C733C-7C5A-B63B-E928-EF185E78A539}"/>
+                <a16:creationId xmlns:a16="http://schemas.microsoft.com/office/drawing/2014/main" id="{7534B4B0-D83E-61BF-9AC2-743DAAF6372A}"/>
               </a:ext>
             </a:extLst>
           </p:cNvPr>
@@ -4227,7 +4227,7 @@
           <p:cNvPr id="20" name="Picture 19">
             <a:extLst>
               <a:ext uri="{FF2B5EF4-FFF2-40B4-BE49-F238E27FC236}">
-                <a16:creationId xmlns:a16="http://schemas.microsoft.com/office/drawing/2014/main" id="{296D73CF-90F2-8E97-FBB0-980185C7797B}"/>
+                <a16:creationId xmlns:a16="http://schemas.microsoft.com/office/drawing/2014/main" id="{49738BAE-274A-ECD6-0285-FC65F3F56D57}"/>
               </a:ext>
             </a:extLst>
           </p:cNvPr>
@@ -4263,7 +4263,7 @@
           <p:cNvPr id="21" name="Rectangle: Rounded Corners 20">
             <a:extLst>
               <a:ext uri="{FF2B5EF4-FFF2-40B4-BE49-F238E27FC236}">
-                <a16:creationId xmlns:a16="http://schemas.microsoft.com/office/drawing/2014/main" id="{1F0F9E2A-BA37-56AA-CCE1-271247B7D509}"/>
+                <a16:creationId xmlns:a16="http://schemas.microsoft.com/office/drawing/2014/main" id="{169BE51F-50E6-0726-0AC0-A3D0DD3D468D}"/>
               </a:ext>
             </a:extLst>
           </p:cNvPr>
@@ -4325,7 +4325,7 @@
           <p:cNvPr id="22" name="TextBox 21">
             <a:extLst>
               <a:ext uri="{FF2B5EF4-FFF2-40B4-BE49-F238E27FC236}">
-                <a16:creationId xmlns:a16="http://schemas.microsoft.com/office/drawing/2014/main" id="{DDF9E3E2-D332-4C82-D260-89FD6C6DB411}"/>
+                <a16:creationId xmlns:a16="http://schemas.microsoft.com/office/drawing/2014/main" id="{E3DC2748-9AAD-4D89-EAAF-0AFB25D4CC15}"/>
               </a:ext>
             </a:extLst>
           </p:cNvPr>
@@ -4371,7 +4371,7 @@
           <p:cNvPr id="23" name="Rectangle: Rounded Corners 22">
             <a:extLst>
               <a:ext uri="{FF2B5EF4-FFF2-40B4-BE49-F238E27FC236}">
-                <a16:creationId xmlns:a16="http://schemas.microsoft.com/office/drawing/2014/main" id="{AB6C225F-3B1A-1092-8DBB-5DB03E4B81E6}"/>
+                <a16:creationId xmlns:a16="http://schemas.microsoft.com/office/drawing/2014/main" id="{167229CB-CE16-EC81-F77E-CAA60D5B975D}"/>
               </a:ext>
             </a:extLst>
           </p:cNvPr>
@@ -4449,7 +4449,7 @@
           <p:cNvPr id="27" name="Group 26">
             <a:extLst>
               <a:ext uri="{FF2B5EF4-FFF2-40B4-BE49-F238E27FC236}">
-                <a16:creationId xmlns:a16="http://schemas.microsoft.com/office/drawing/2014/main" id="{0F441C23-BAC2-17B6-5099-65881532FCED}"/>
+                <a16:creationId xmlns:a16="http://schemas.microsoft.com/office/drawing/2014/main" id="{4ED5C94E-055E-F691-76B8-A8480AC1A3B4}"/>
               </a:ext>
             </a:extLst>
           </p:cNvPr>
@@ -4469,7 +4469,7 @@
             <p:cNvPr id="24" name="Rectangle: Rounded Corners 23">
               <a:extLst>
                 <a:ext uri="{FF2B5EF4-FFF2-40B4-BE49-F238E27FC236}">
-                  <a16:creationId xmlns:a16="http://schemas.microsoft.com/office/drawing/2014/main" id="{F2491F14-BBA7-C888-0FA0-5C33FFFDF4DD}"/>
+                  <a16:creationId xmlns:a16="http://schemas.microsoft.com/office/drawing/2014/main" id="{3DD44004-FEA5-E608-4DFF-A05223E89C95}"/>
                 </a:ext>
               </a:extLst>
             </p:cNvPr>
@@ -4523,7 +4523,7 @@
             <p:cNvPr id="25" name="Rectangle: Rounded Corners 24">
               <a:extLst>
                 <a:ext uri="{FF2B5EF4-FFF2-40B4-BE49-F238E27FC236}">
-                  <a16:creationId xmlns:a16="http://schemas.microsoft.com/office/drawing/2014/main" id="{BED0DB05-374E-B3B5-D792-0209212AF00F}"/>
+                  <a16:creationId xmlns:a16="http://schemas.microsoft.com/office/drawing/2014/main" id="{E184A960-AFEA-914D-1C0E-7B376DE7B5BC}"/>
                 </a:ext>
               </a:extLst>
             </p:cNvPr>
@@ -4585,7 +4585,7 @@
             <p:cNvPr id="26" name="TextBox 25">
               <a:extLst>
                 <a:ext uri="{FF2B5EF4-FFF2-40B4-BE49-F238E27FC236}">
-                  <a16:creationId xmlns:a16="http://schemas.microsoft.com/office/drawing/2014/main" id="{4432DD63-1D6A-C196-765F-4F2F4E21DB19}"/>
+                  <a16:creationId xmlns:a16="http://schemas.microsoft.com/office/drawing/2014/main" id="{16B7C622-9395-3B80-CE0B-42607B52ACFB}"/>
                 </a:ext>
               </a:extLst>
             </p:cNvPr>
@@ -4632,7 +4632,7 @@
           <p:cNvPr id="31" name="Group 30">
             <a:extLst>
               <a:ext uri="{FF2B5EF4-FFF2-40B4-BE49-F238E27FC236}">
-                <a16:creationId xmlns:a16="http://schemas.microsoft.com/office/drawing/2014/main" id="{E2F7959D-0E34-EF7C-883D-F7164F6AE066}"/>
+                <a16:creationId xmlns:a16="http://schemas.microsoft.com/office/drawing/2014/main" id="{066847EA-A491-98B8-25BE-84459A15AC5F}"/>
               </a:ext>
             </a:extLst>
           </p:cNvPr>
@@ -4652,7 +4652,7 @@
             <p:cNvPr id="28" name="Rectangle: Rounded Corners 27">
               <a:extLst>
                 <a:ext uri="{FF2B5EF4-FFF2-40B4-BE49-F238E27FC236}">
-                  <a16:creationId xmlns:a16="http://schemas.microsoft.com/office/drawing/2014/main" id="{AC5C8A05-B7C0-AED5-E5BB-658C340691B3}"/>
+                  <a16:creationId xmlns:a16="http://schemas.microsoft.com/office/drawing/2014/main" id="{B62A983C-6FFC-7861-85BE-E5C58EC41850}"/>
                 </a:ext>
               </a:extLst>
             </p:cNvPr>
@@ -4706,7 +4706,7 @@
             <p:cNvPr id="29" name="Rectangle: Rounded Corners 28">
               <a:extLst>
                 <a:ext uri="{FF2B5EF4-FFF2-40B4-BE49-F238E27FC236}">
-                  <a16:creationId xmlns:a16="http://schemas.microsoft.com/office/drawing/2014/main" id="{282CD146-BB72-21C0-6D02-9F3608CA0D12}"/>
+                  <a16:creationId xmlns:a16="http://schemas.microsoft.com/office/drawing/2014/main" id="{6E10E9EF-446A-6FD0-C7E4-CE37EDD7A488}"/>
                 </a:ext>
               </a:extLst>
             </p:cNvPr>
@@ -4768,7 +4768,7 @@
             <p:cNvPr id="30" name="TextBox 29">
               <a:extLst>
                 <a:ext uri="{FF2B5EF4-FFF2-40B4-BE49-F238E27FC236}">
-                  <a16:creationId xmlns:a16="http://schemas.microsoft.com/office/drawing/2014/main" id="{B78661D6-DEA4-C83B-5CF8-3B6A400F1F7B}"/>
+                  <a16:creationId xmlns:a16="http://schemas.microsoft.com/office/drawing/2014/main" id="{120A6E30-0066-0861-DE31-5153AFB387B2}"/>
                 </a:ext>
               </a:extLst>
             </p:cNvPr>
@@ -4815,7 +4815,7 @@
           <p:cNvPr id="35" name="Group 34">
             <a:extLst>
               <a:ext uri="{FF2B5EF4-FFF2-40B4-BE49-F238E27FC236}">
-                <a16:creationId xmlns:a16="http://schemas.microsoft.com/office/drawing/2014/main" id="{CC1DA14F-01B3-87BB-BB6F-6B1F1938D1D7}"/>
+                <a16:creationId xmlns:a16="http://schemas.microsoft.com/office/drawing/2014/main" id="{D504BD86-CC2C-83F8-A52B-7F1B75FE35B8}"/>
               </a:ext>
             </a:extLst>
           </p:cNvPr>
@@ -4835,7 +4835,7 @@
             <p:cNvPr id="32" name="Rectangle: Rounded Corners 31">
               <a:extLst>
                 <a:ext uri="{FF2B5EF4-FFF2-40B4-BE49-F238E27FC236}">
-                  <a16:creationId xmlns:a16="http://schemas.microsoft.com/office/drawing/2014/main" id="{5C0CE70D-1852-2C09-BBFC-472579CC87F9}"/>
+                  <a16:creationId xmlns:a16="http://schemas.microsoft.com/office/drawing/2014/main" id="{5DA6A823-35D2-B72E-6131-A9AA2D27B4AB}"/>
                 </a:ext>
               </a:extLst>
             </p:cNvPr>
@@ -4889,7 +4889,7 @@
             <p:cNvPr id="33" name="Rectangle: Rounded Corners 32">
               <a:extLst>
                 <a:ext uri="{FF2B5EF4-FFF2-40B4-BE49-F238E27FC236}">
-                  <a16:creationId xmlns:a16="http://schemas.microsoft.com/office/drawing/2014/main" id="{AE837833-07A3-8353-CD3A-1B0F5578B5D6}"/>
+                  <a16:creationId xmlns:a16="http://schemas.microsoft.com/office/drawing/2014/main" id="{91CB3514-E137-5690-AA8A-448FDE67C435}"/>
                 </a:ext>
               </a:extLst>
             </p:cNvPr>
@@ -4951,7 +4951,7 @@
             <p:cNvPr id="34" name="TextBox 33">
               <a:extLst>
                 <a:ext uri="{FF2B5EF4-FFF2-40B4-BE49-F238E27FC236}">
-                  <a16:creationId xmlns:a16="http://schemas.microsoft.com/office/drawing/2014/main" id="{49126444-6867-DCD6-FD85-F235C3E8F413}"/>
+                  <a16:creationId xmlns:a16="http://schemas.microsoft.com/office/drawing/2014/main" id="{F97B985C-596A-C65D-92B2-3EDBB6512639}"/>
                 </a:ext>
               </a:extLst>
             </p:cNvPr>
@@ -4981,7 +4981,7 @@
                   </a:solidFill>
                   <a:latin typeface="Georgia" panose="02040502050405020303" pitchFamily="18" charset="0"/>
                 </a:rPr>
-                <a:t>Presented by [Your Name] — Examining the enduring relevance of Gandhian ideals today.</a:t>
+                <a:t>Presented by Dev Vashisht — Examining the enduring relevance of Gandhian ideals today.</a:t>
               </a:r>
               <a:endParaRPr lang="en-ID" sz="1150">
                 <a:solidFill>
@@ -4998,7 +4998,7 @@
           <p:cNvPr id="36" name="Rectangle: Rounded Corners 35">
             <a:extLst>
               <a:ext uri="{FF2B5EF4-FFF2-40B4-BE49-F238E27FC236}">
-                <a16:creationId xmlns:a16="http://schemas.microsoft.com/office/drawing/2014/main" id="{9518157D-D892-BCE0-5FF0-482A2D0EE73E}"/>
+                <a16:creationId xmlns:a16="http://schemas.microsoft.com/office/drawing/2014/main" id="{09E1BF8D-BC95-9827-CB8C-97F50190B2B8}"/>
               </a:ext>
             </a:extLst>
           </p:cNvPr>
@@ -5050,7 +5050,7 @@
                 </a:solidFill>
                 <a:latin typeface="Georgia" panose="02040502050405020303" pitchFamily="18" charset="0"/>
               </a:rPr>
-              <a:t>❖   PRESENTED BY [YOUR NAME]       —       IN MEMORIAM MAHATMA GANDHI</a:t>
+              <a:t>❖   PRESENTED BY DEV VASHISHT       —       IN MEMORIAM MAHATMA GANDHI</a:t>
             </a:r>
             <a:endParaRPr lang="en-ID" sz="950" b="1">
               <a:solidFill>
@@ -5066,7 +5066,7 @@
           <p:cNvPr id="37" name="Rectangle 36">
             <a:extLst>
               <a:ext uri="{FF2B5EF4-FFF2-40B4-BE49-F238E27FC236}">
-                <a16:creationId xmlns:a16="http://schemas.microsoft.com/office/drawing/2014/main" id="{452DBDBC-AEC5-D2EE-5B81-8A8DC6852FDB}"/>
+                <a16:creationId xmlns:a16="http://schemas.microsoft.com/office/drawing/2014/main" id="{2406C04C-E8C8-BC96-161C-F447275C069F}"/>
               </a:ext>
             </a:extLst>
           </p:cNvPr>
@@ -5134,7 +5134,7 @@
           <p:cNvPr id="38" name="TextBox 37">
             <a:extLst>
               <a:ext uri="{FF2B5EF4-FFF2-40B4-BE49-F238E27FC236}">
-                <a16:creationId xmlns:a16="http://schemas.microsoft.com/office/drawing/2014/main" id="{F33F9799-D9C0-FEF9-E7C7-23B808CCE4DA}"/>
+                <a16:creationId xmlns:a16="http://schemas.microsoft.com/office/drawing/2014/main" id="{F7E19D9B-30E0-FB72-3F00-CE6D2C9ABF34}"/>
               </a:ext>
             </a:extLst>
           </p:cNvPr>
@@ -5174,7 +5174,7 @@
           <p:cNvPr id="39" name="TextBox 38">
             <a:extLst>
               <a:ext uri="{FF2B5EF4-FFF2-40B4-BE49-F238E27FC236}">
-                <a16:creationId xmlns:a16="http://schemas.microsoft.com/office/drawing/2014/main" id="{44791C1D-1A20-FCE4-91B1-4E652EE6FF6E}"/>
+                <a16:creationId xmlns:a16="http://schemas.microsoft.com/office/drawing/2014/main" id="{350AACA9-D542-64D9-F5E9-117AF518502D}"/>
               </a:ext>
             </a:extLst>
           </p:cNvPr>
@@ -5215,7 +5215,7 @@
           <p:cNvPr id="40" name="TextBox 39">
             <a:extLst>
               <a:ext uri="{FF2B5EF4-FFF2-40B4-BE49-F238E27FC236}">
-                <a16:creationId xmlns:a16="http://schemas.microsoft.com/office/drawing/2014/main" id="{CC364BB3-FA59-901B-405C-8972F5E0E38B}"/>
+                <a16:creationId xmlns:a16="http://schemas.microsoft.com/office/drawing/2014/main" id="{102618A9-13ED-47C5-0824-E46B642F3C1D}"/>
               </a:ext>
             </a:extLst>
           </p:cNvPr>
@@ -5254,7 +5254,7 @@
     </p:spTree>
     <p:extLst>
       <p:ext uri="{BB962C8B-B14F-4D97-AF65-F5344CB8AC3E}">
-        <p14:creationId xmlns:p14="http://schemas.microsoft.com/office/powerpoint/2010/main" val="1514262608"/>
+        <p14:creationId xmlns:p14="http://schemas.microsoft.com/office/powerpoint/2010/main" val="3408190731"/>
       </p:ext>
     </p:extLst>
   </p:cSld>
@@ -5555,7 +5555,7 @@
           <p:cNvPr id="2" name="Rectangle 1">
             <a:extLst>
               <a:ext uri="{FF2B5EF4-FFF2-40B4-BE49-F238E27FC236}">
-                <a16:creationId xmlns:a16="http://schemas.microsoft.com/office/drawing/2014/main" id="{F87B2BAC-8FDB-4F14-6BB0-80728B3625A2}"/>
+                <a16:creationId xmlns:a16="http://schemas.microsoft.com/office/drawing/2014/main" id="{28D7F4CF-48D6-A0F2-795F-C0FA54618141}"/>
               </a:ext>
             </a:extLst>
           </p:cNvPr>
@@ -5623,7 +5623,7 @@
           <p:cNvPr id="3" name="Rectangle: Rounded Corners 2">
             <a:extLst>
               <a:ext uri="{FF2B5EF4-FFF2-40B4-BE49-F238E27FC236}">
-                <a16:creationId xmlns:a16="http://schemas.microsoft.com/office/drawing/2014/main" id="{321DAD47-08DD-82C9-DC57-86DB3545A9B9}"/>
+                <a16:creationId xmlns:a16="http://schemas.microsoft.com/office/drawing/2014/main" id="{650C719A-3475-E21E-B645-A121353C5D8D}"/>
               </a:ext>
             </a:extLst>
           </p:cNvPr>
@@ -5677,7 +5677,7 @@
           <p:cNvPr id="4" name="Rectangle: Rounded Corners 3">
             <a:extLst>
               <a:ext uri="{FF2B5EF4-FFF2-40B4-BE49-F238E27FC236}">
-                <a16:creationId xmlns:a16="http://schemas.microsoft.com/office/drawing/2014/main" id="{096F03AB-48B4-C234-FEAC-73D521ECC33C}"/>
+                <a16:creationId xmlns:a16="http://schemas.microsoft.com/office/drawing/2014/main" id="{E54E49CA-44C4-9FBD-49C5-7773D8FD12F7}"/>
               </a:ext>
             </a:extLst>
           </p:cNvPr>
@@ -5728,7 +5728,7 @@
           <p:cNvPr id="5" name="TextBox 4">
             <a:extLst>
               <a:ext uri="{FF2B5EF4-FFF2-40B4-BE49-F238E27FC236}">
-                <a16:creationId xmlns:a16="http://schemas.microsoft.com/office/drawing/2014/main" id="{DD863EA5-37A3-60BF-C142-EDDB201380B4}"/>
+                <a16:creationId xmlns:a16="http://schemas.microsoft.com/office/drawing/2014/main" id="{8F75E792-E2C2-D0ED-3E8D-C53DDE55EC02}"/>
               </a:ext>
             </a:extLst>
           </p:cNvPr>
@@ -5768,7 +5768,7 @@
           <p:cNvPr id="6" name="TextBox 5">
             <a:extLst>
               <a:ext uri="{FF2B5EF4-FFF2-40B4-BE49-F238E27FC236}">
-                <a16:creationId xmlns:a16="http://schemas.microsoft.com/office/drawing/2014/main" id="{E872CFBA-8F13-6BFF-4691-6E3AE383AA4C}"/>
+                <a16:creationId xmlns:a16="http://schemas.microsoft.com/office/drawing/2014/main" id="{46C64E33-B58C-97D8-8F78-64EC0C1056D1}"/>
               </a:ext>
             </a:extLst>
           </p:cNvPr>
@@ -5808,7 +5808,7 @@
           <p:cNvPr id="7" name="TextBox 6">
             <a:extLst>
               <a:ext uri="{FF2B5EF4-FFF2-40B4-BE49-F238E27FC236}">
-                <a16:creationId xmlns:a16="http://schemas.microsoft.com/office/drawing/2014/main" id="{D26A07C5-11BA-174F-F911-2BA6D0E1FBB4}"/>
+                <a16:creationId xmlns:a16="http://schemas.microsoft.com/office/drawing/2014/main" id="{AB0A11CE-F159-2768-1176-774F8C1A7DE5}"/>
               </a:ext>
             </a:extLst>
           </p:cNvPr>
@@ -5848,7 +5848,7 @@
           <p:cNvPr id="8" name="TextBox 7">
             <a:extLst>
               <a:ext uri="{FF2B5EF4-FFF2-40B4-BE49-F238E27FC236}">
-                <a16:creationId xmlns:a16="http://schemas.microsoft.com/office/drawing/2014/main" id="{9F2E8E46-405E-AEC0-38BF-686ACDB4DABC}"/>
+                <a16:creationId xmlns:a16="http://schemas.microsoft.com/office/drawing/2014/main" id="{5D4959A7-8C3A-3130-4ACF-275EBE5D4FDA}"/>
               </a:ext>
             </a:extLst>
           </p:cNvPr>
@@ -5888,7 +5888,7 @@
           <p:cNvPr id="9" name="TextBox 8">
             <a:extLst>
               <a:ext uri="{FF2B5EF4-FFF2-40B4-BE49-F238E27FC236}">
-                <a16:creationId xmlns:a16="http://schemas.microsoft.com/office/drawing/2014/main" id="{86AF1C54-5928-D634-C8E2-A5FE2AACCA7D}"/>
+                <a16:creationId xmlns:a16="http://schemas.microsoft.com/office/drawing/2014/main" id="{40A19F7B-2200-F4CB-2473-A4738AE1C2A6}"/>
               </a:ext>
             </a:extLst>
           </p:cNvPr>
@@ -5928,7 +5928,7 @@
           <p:cNvPr id="10" name="Rectangle: Rounded Corners 9">
             <a:extLst>
               <a:ext uri="{FF2B5EF4-FFF2-40B4-BE49-F238E27FC236}">
-                <a16:creationId xmlns:a16="http://schemas.microsoft.com/office/drawing/2014/main" id="{BB154562-58B0-39E2-4089-317CBD5333CC}"/>
+                <a16:creationId xmlns:a16="http://schemas.microsoft.com/office/drawing/2014/main" id="{0B09267C-7BBC-B874-F825-B4CA567E8653}"/>
               </a:ext>
             </a:extLst>
           </p:cNvPr>
@@ -5990,7 +5990,7 @@
           <p:cNvPr id="11" name="TextBox 10">
             <a:extLst>
               <a:ext uri="{FF2B5EF4-FFF2-40B4-BE49-F238E27FC236}">
-                <a16:creationId xmlns:a16="http://schemas.microsoft.com/office/drawing/2014/main" id="{3F6011F2-A27E-4AA8-2942-CC7C84EFB3C7}"/>
+                <a16:creationId xmlns:a16="http://schemas.microsoft.com/office/drawing/2014/main" id="{2EC65362-3417-9230-5553-A40264572223}"/>
               </a:ext>
             </a:extLst>
           </p:cNvPr>
@@ -6030,7 +6030,7 @@
           <p:cNvPr id="12" name="Rectangle 11">
             <a:extLst>
               <a:ext uri="{FF2B5EF4-FFF2-40B4-BE49-F238E27FC236}">
-                <a16:creationId xmlns:a16="http://schemas.microsoft.com/office/drawing/2014/main" id="{D2EA5247-5FD7-9F59-B73D-C24CD7C9724B}"/>
+                <a16:creationId xmlns:a16="http://schemas.microsoft.com/office/drawing/2014/main" id="{C3425395-D6DF-C95D-F2B7-F65CE7DECA79}"/>
               </a:ext>
             </a:extLst>
           </p:cNvPr>
@@ -6098,7 +6098,7 @@
           <p:cNvPr id="13" name="TextBox 12">
             <a:extLst>
               <a:ext uri="{FF2B5EF4-FFF2-40B4-BE49-F238E27FC236}">
-                <a16:creationId xmlns:a16="http://schemas.microsoft.com/office/drawing/2014/main" id="{08404489-B771-819C-6791-DC3218CC5FA0}"/>
+                <a16:creationId xmlns:a16="http://schemas.microsoft.com/office/drawing/2014/main" id="{A4A7209E-AFC5-141A-50A4-852589684D89}"/>
               </a:ext>
             </a:extLst>
           </p:cNvPr>
@@ -6144,7 +6144,7 @@
           <p:cNvPr id="14" name="Rectangle: Rounded Corners 13">
             <a:extLst>
               <a:ext uri="{FF2B5EF4-FFF2-40B4-BE49-F238E27FC236}">
-                <a16:creationId xmlns:a16="http://schemas.microsoft.com/office/drawing/2014/main" id="{39775818-A887-2C87-0071-9AE9289E4772}"/>
+                <a16:creationId xmlns:a16="http://schemas.microsoft.com/office/drawing/2014/main" id="{B81115F9-03C8-A30C-5BD8-A2DB2A3FA298}"/>
               </a:ext>
             </a:extLst>
           </p:cNvPr>
@@ -6198,7 +6198,7 @@
           <p:cNvPr id="15" name="Pentagon 14">
             <a:extLst>
               <a:ext uri="{FF2B5EF4-FFF2-40B4-BE49-F238E27FC236}">
-                <a16:creationId xmlns:a16="http://schemas.microsoft.com/office/drawing/2014/main" id="{09106184-9484-4DC6-ED95-49C37096DE29}"/>
+                <a16:creationId xmlns:a16="http://schemas.microsoft.com/office/drawing/2014/main" id="{ACF67706-A543-24F1-381B-EC20F7EBC829}"/>
               </a:ext>
             </a:extLst>
           </p:cNvPr>
@@ -6252,7 +6252,7 @@
           <p:cNvPr id="16" name="Pentagon 15">
             <a:extLst>
               <a:ext uri="{FF2B5EF4-FFF2-40B4-BE49-F238E27FC236}">
-                <a16:creationId xmlns:a16="http://schemas.microsoft.com/office/drawing/2014/main" id="{BA9ED3CF-3DD5-500B-CB39-A95E13068E13}"/>
+                <a16:creationId xmlns:a16="http://schemas.microsoft.com/office/drawing/2014/main" id="{207A7BAE-AF37-06C9-34C9-79AB3324AA08}"/>
               </a:ext>
             </a:extLst>
           </p:cNvPr>
@@ -6306,7 +6306,7 @@
           <p:cNvPr id="17" name="Pentagon 16">
             <a:extLst>
               <a:ext uri="{FF2B5EF4-FFF2-40B4-BE49-F238E27FC236}">
-                <a16:creationId xmlns:a16="http://schemas.microsoft.com/office/drawing/2014/main" id="{316C7553-01CF-8666-7CEC-85BE9B142F24}"/>
+                <a16:creationId xmlns:a16="http://schemas.microsoft.com/office/drawing/2014/main" id="{725F5862-B618-B262-FCD1-5F0FF6BAEC50}"/>
               </a:ext>
             </a:extLst>
           </p:cNvPr>
@@ -6360,7 +6360,7 @@
           <p:cNvPr id="18" name="Pentagon 17">
             <a:extLst>
               <a:ext uri="{FF2B5EF4-FFF2-40B4-BE49-F238E27FC236}">
-                <a16:creationId xmlns:a16="http://schemas.microsoft.com/office/drawing/2014/main" id="{61163F31-3FF6-75E2-7C25-06F80C7553BD}"/>
+                <a16:creationId xmlns:a16="http://schemas.microsoft.com/office/drawing/2014/main" id="{F801065A-E75E-D2C9-3509-F6019A850228}"/>
               </a:ext>
             </a:extLst>
           </p:cNvPr>
@@ -6414,7 +6414,7 @@
           <p:cNvPr id="20" name="Picture 19">
             <a:extLst>
               <a:ext uri="{FF2B5EF4-FFF2-40B4-BE49-F238E27FC236}">
-                <a16:creationId xmlns:a16="http://schemas.microsoft.com/office/drawing/2014/main" id="{2EF478E4-14DA-BC3E-5ED0-9F06335CC49A}"/>
+                <a16:creationId xmlns:a16="http://schemas.microsoft.com/office/drawing/2014/main" id="{2FB45753-2588-8877-9221-43DEEB6A04C1}"/>
               </a:ext>
             </a:extLst>
           </p:cNvPr>
@@ -6450,7 +6450,7 @@
           <p:cNvPr id="21" name="Rectangle: Rounded Corners 20">
             <a:extLst>
               <a:ext uri="{FF2B5EF4-FFF2-40B4-BE49-F238E27FC236}">
-                <a16:creationId xmlns:a16="http://schemas.microsoft.com/office/drawing/2014/main" id="{5E534003-A692-BBC7-AA7F-A1B66FD6531E}"/>
+                <a16:creationId xmlns:a16="http://schemas.microsoft.com/office/drawing/2014/main" id="{FB51CCAF-AEF3-F57F-98C4-036ADE69F5E1}"/>
               </a:ext>
             </a:extLst>
           </p:cNvPr>
@@ -6512,7 +6512,7 @@
           <p:cNvPr id="22" name="TextBox 21">
             <a:extLst>
               <a:ext uri="{FF2B5EF4-FFF2-40B4-BE49-F238E27FC236}">
-                <a16:creationId xmlns:a16="http://schemas.microsoft.com/office/drawing/2014/main" id="{CA9E8942-3CAC-C77B-0DF4-7D38E16F11BE}"/>
+                <a16:creationId xmlns:a16="http://schemas.microsoft.com/office/drawing/2014/main" id="{343BE1C7-7A54-E409-74A2-6828D2EBCEC2}"/>
               </a:ext>
             </a:extLst>
           </p:cNvPr>
@@ -6568,7 +6568,7 @@
           <p:cNvPr id="23" name="Rectangle: Rounded Corners 22">
             <a:extLst>
               <a:ext uri="{FF2B5EF4-FFF2-40B4-BE49-F238E27FC236}">
-                <a16:creationId xmlns:a16="http://schemas.microsoft.com/office/drawing/2014/main" id="{D5C0799C-4C0D-6BB2-4BB1-CD9967B1EAC8}"/>
+                <a16:creationId xmlns:a16="http://schemas.microsoft.com/office/drawing/2014/main" id="{F275FA7D-588A-73BC-38AE-2FAFF06E5296}"/>
               </a:ext>
             </a:extLst>
           </p:cNvPr>
@@ -6646,7 +6646,7 @@
           <p:cNvPr id="27" name="Group 26">
             <a:extLst>
               <a:ext uri="{FF2B5EF4-FFF2-40B4-BE49-F238E27FC236}">
-                <a16:creationId xmlns:a16="http://schemas.microsoft.com/office/drawing/2014/main" id="{BE703BA9-7E0B-08EA-6E1B-CD083617F7AD}"/>
+                <a16:creationId xmlns:a16="http://schemas.microsoft.com/office/drawing/2014/main" id="{4063A72A-2F30-89E3-3170-E5F0B08AC05C}"/>
               </a:ext>
             </a:extLst>
           </p:cNvPr>
@@ -6666,7 +6666,7 @@
             <p:cNvPr id="24" name="Rectangle: Rounded Corners 23">
               <a:extLst>
                 <a:ext uri="{FF2B5EF4-FFF2-40B4-BE49-F238E27FC236}">
-                  <a16:creationId xmlns:a16="http://schemas.microsoft.com/office/drawing/2014/main" id="{0A853463-20CC-9D58-5E27-4C6125EC1A6E}"/>
+                  <a16:creationId xmlns:a16="http://schemas.microsoft.com/office/drawing/2014/main" id="{B63304C5-A89D-4D9A-7194-1D73D2CE9777}"/>
                 </a:ext>
               </a:extLst>
             </p:cNvPr>
@@ -6720,7 +6720,7 @@
             <p:cNvPr id="25" name="Rectangle: Rounded Corners 24">
               <a:extLst>
                 <a:ext uri="{FF2B5EF4-FFF2-40B4-BE49-F238E27FC236}">
-                  <a16:creationId xmlns:a16="http://schemas.microsoft.com/office/drawing/2014/main" id="{AFDB9A0C-3C55-540F-7ACD-7AED2D0A5F02}"/>
+                  <a16:creationId xmlns:a16="http://schemas.microsoft.com/office/drawing/2014/main" id="{DD64DB76-7FF8-167A-5673-3D9C655A832E}"/>
                 </a:ext>
               </a:extLst>
             </p:cNvPr>
@@ -6782,7 +6782,7 @@
             <p:cNvPr id="26" name="TextBox 25">
               <a:extLst>
                 <a:ext uri="{FF2B5EF4-FFF2-40B4-BE49-F238E27FC236}">
-                  <a16:creationId xmlns:a16="http://schemas.microsoft.com/office/drawing/2014/main" id="{A9DB4105-DA8B-55D0-7410-90C6280F372F}"/>
+                  <a16:creationId xmlns:a16="http://schemas.microsoft.com/office/drawing/2014/main" id="{647B5E7E-5E8F-9213-C522-5CA2A999FC81}"/>
                 </a:ext>
               </a:extLst>
             </p:cNvPr>
@@ -6829,7 +6829,7 @@
           <p:cNvPr id="31" name="Group 30">
             <a:extLst>
               <a:ext uri="{FF2B5EF4-FFF2-40B4-BE49-F238E27FC236}">
-                <a16:creationId xmlns:a16="http://schemas.microsoft.com/office/drawing/2014/main" id="{76A3DF54-6CCB-E5FF-40CD-52542968C084}"/>
+                <a16:creationId xmlns:a16="http://schemas.microsoft.com/office/drawing/2014/main" id="{3C91D737-562D-F151-4181-FDBD6E0D83B6}"/>
               </a:ext>
             </a:extLst>
           </p:cNvPr>
@@ -6849,7 +6849,7 @@
             <p:cNvPr id="28" name="Rectangle: Rounded Corners 27">
               <a:extLst>
                 <a:ext uri="{FF2B5EF4-FFF2-40B4-BE49-F238E27FC236}">
-                  <a16:creationId xmlns:a16="http://schemas.microsoft.com/office/drawing/2014/main" id="{2931D351-5345-5744-E8D3-D339D9DBEF31}"/>
+                  <a16:creationId xmlns:a16="http://schemas.microsoft.com/office/drawing/2014/main" id="{A69A03F0-B3C2-7503-9E5C-0822996E1C74}"/>
                 </a:ext>
               </a:extLst>
             </p:cNvPr>
@@ -6903,7 +6903,7 @@
             <p:cNvPr id="29" name="Rectangle: Rounded Corners 28">
               <a:extLst>
                 <a:ext uri="{FF2B5EF4-FFF2-40B4-BE49-F238E27FC236}">
-                  <a16:creationId xmlns:a16="http://schemas.microsoft.com/office/drawing/2014/main" id="{C6EC8B92-4E75-2452-3E3A-4D35C1CDEC3C}"/>
+                  <a16:creationId xmlns:a16="http://schemas.microsoft.com/office/drawing/2014/main" id="{F36D2991-A7FC-17E6-9924-6750D5D0574E}"/>
                 </a:ext>
               </a:extLst>
             </p:cNvPr>
@@ -6965,7 +6965,7 @@
             <p:cNvPr id="30" name="TextBox 29">
               <a:extLst>
                 <a:ext uri="{FF2B5EF4-FFF2-40B4-BE49-F238E27FC236}">
-                  <a16:creationId xmlns:a16="http://schemas.microsoft.com/office/drawing/2014/main" id="{12050FF1-8BB1-8603-1FE0-8E324979CC1F}"/>
+                  <a16:creationId xmlns:a16="http://schemas.microsoft.com/office/drawing/2014/main" id="{AFAA6B0B-37D2-9FB3-E3E1-C4FB420106F5}"/>
                 </a:ext>
               </a:extLst>
             </p:cNvPr>
@@ -7012,7 +7012,7 @@
           <p:cNvPr id="35" name="Group 34">
             <a:extLst>
               <a:ext uri="{FF2B5EF4-FFF2-40B4-BE49-F238E27FC236}">
-                <a16:creationId xmlns:a16="http://schemas.microsoft.com/office/drawing/2014/main" id="{B4958D27-BC55-0691-6B6A-A2F9CF45E884}"/>
+                <a16:creationId xmlns:a16="http://schemas.microsoft.com/office/drawing/2014/main" id="{AF799987-A0C7-8941-87F4-FC7430C4503C}"/>
               </a:ext>
             </a:extLst>
           </p:cNvPr>
@@ -7032,7 +7032,7 @@
             <p:cNvPr id="32" name="Rectangle: Rounded Corners 31">
               <a:extLst>
                 <a:ext uri="{FF2B5EF4-FFF2-40B4-BE49-F238E27FC236}">
-                  <a16:creationId xmlns:a16="http://schemas.microsoft.com/office/drawing/2014/main" id="{7C90DD3B-7433-706C-D2A8-19A7F980F89F}"/>
+                  <a16:creationId xmlns:a16="http://schemas.microsoft.com/office/drawing/2014/main" id="{6AE74480-A015-4C60-22FB-0663678F3396}"/>
                 </a:ext>
               </a:extLst>
             </p:cNvPr>
@@ -7086,7 +7086,7 @@
             <p:cNvPr id="33" name="Rectangle: Rounded Corners 32">
               <a:extLst>
                 <a:ext uri="{FF2B5EF4-FFF2-40B4-BE49-F238E27FC236}">
-                  <a16:creationId xmlns:a16="http://schemas.microsoft.com/office/drawing/2014/main" id="{A79588C5-E00E-4E8B-B89A-7B07CF3097DA}"/>
+                  <a16:creationId xmlns:a16="http://schemas.microsoft.com/office/drawing/2014/main" id="{BC91D760-C380-FD4E-C5C5-FD3A3708AB43}"/>
                 </a:ext>
               </a:extLst>
             </p:cNvPr>
@@ -7148,7 +7148,7 @@
             <p:cNvPr id="34" name="TextBox 33">
               <a:extLst>
                 <a:ext uri="{FF2B5EF4-FFF2-40B4-BE49-F238E27FC236}">
-                  <a16:creationId xmlns:a16="http://schemas.microsoft.com/office/drawing/2014/main" id="{05FD92F7-7B22-6B23-C06C-F0D5685FBA4C}"/>
+                  <a16:creationId xmlns:a16="http://schemas.microsoft.com/office/drawing/2014/main" id="{FF1FC5A5-35A2-835D-975C-4AE57BD3A3F3}"/>
                 </a:ext>
               </a:extLst>
             </p:cNvPr>
@@ -7195,7 +7195,7 @@
           <p:cNvPr id="39" name="Group 38">
             <a:extLst>
               <a:ext uri="{FF2B5EF4-FFF2-40B4-BE49-F238E27FC236}">
-                <a16:creationId xmlns:a16="http://schemas.microsoft.com/office/drawing/2014/main" id="{63BB75D1-8890-0B72-9A88-52471A1DE058}"/>
+                <a16:creationId xmlns:a16="http://schemas.microsoft.com/office/drawing/2014/main" id="{0E840687-EADD-7568-CED3-41935A2DBFB9}"/>
               </a:ext>
             </a:extLst>
           </p:cNvPr>
@@ -7215,7 +7215,7 @@
             <p:cNvPr id="36" name="Rectangle: Rounded Corners 35">
               <a:extLst>
                 <a:ext uri="{FF2B5EF4-FFF2-40B4-BE49-F238E27FC236}">
-                  <a16:creationId xmlns:a16="http://schemas.microsoft.com/office/drawing/2014/main" id="{100A12D0-0E8F-2B2B-8EED-E40C0765B254}"/>
+                  <a16:creationId xmlns:a16="http://schemas.microsoft.com/office/drawing/2014/main" id="{0E802B9C-C2D1-412E-14B2-7EC8E5329284}"/>
                 </a:ext>
               </a:extLst>
             </p:cNvPr>
@@ -7269,7 +7269,7 @@
             <p:cNvPr id="37" name="Rectangle: Rounded Corners 36">
               <a:extLst>
                 <a:ext uri="{FF2B5EF4-FFF2-40B4-BE49-F238E27FC236}">
-                  <a16:creationId xmlns:a16="http://schemas.microsoft.com/office/drawing/2014/main" id="{630E0B8F-C081-765B-3A54-E38449BD9C50}"/>
+                  <a16:creationId xmlns:a16="http://schemas.microsoft.com/office/drawing/2014/main" id="{DB378F32-4440-C8D7-5BF8-DB5E2C36EA13}"/>
                 </a:ext>
               </a:extLst>
             </p:cNvPr>
@@ -7331,7 +7331,7 @@
             <p:cNvPr id="38" name="TextBox 37">
               <a:extLst>
                 <a:ext uri="{FF2B5EF4-FFF2-40B4-BE49-F238E27FC236}">
-                  <a16:creationId xmlns:a16="http://schemas.microsoft.com/office/drawing/2014/main" id="{094E0C3F-2F32-44C3-BEAC-E6DD699737CD}"/>
+                  <a16:creationId xmlns:a16="http://schemas.microsoft.com/office/drawing/2014/main" id="{3149C80D-4AD2-3E05-2D80-53BA9AAE6609}"/>
                 </a:ext>
               </a:extLst>
             </p:cNvPr>
@@ -7372,7 +7372,7 @@
           <p:cNvPr id="40" name="Rectangle: Rounded Corners 39">
             <a:extLst>
               <a:ext uri="{FF2B5EF4-FFF2-40B4-BE49-F238E27FC236}">
-                <a16:creationId xmlns:a16="http://schemas.microsoft.com/office/drawing/2014/main" id="{C2BDB457-8E54-7D0E-4178-D8436601424D}"/>
+                <a16:creationId xmlns:a16="http://schemas.microsoft.com/office/drawing/2014/main" id="{084B58D9-1D69-AEA3-5DD0-F66EA458DDDB}"/>
               </a:ext>
             </a:extLst>
           </p:cNvPr>
@@ -7440,7 +7440,7 @@
           <p:cNvPr id="41" name="Rectangle 40">
             <a:extLst>
               <a:ext uri="{FF2B5EF4-FFF2-40B4-BE49-F238E27FC236}">
-                <a16:creationId xmlns:a16="http://schemas.microsoft.com/office/drawing/2014/main" id="{F997E9D8-6C43-CF41-A871-E0CB3B517C34}"/>
+                <a16:creationId xmlns:a16="http://schemas.microsoft.com/office/drawing/2014/main" id="{F0A11934-20DC-5817-ED4A-1FBD1DBCEC42}"/>
               </a:ext>
             </a:extLst>
           </p:cNvPr>
@@ -7508,7 +7508,7 @@
           <p:cNvPr id="42" name="TextBox 41">
             <a:extLst>
               <a:ext uri="{FF2B5EF4-FFF2-40B4-BE49-F238E27FC236}">
-                <a16:creationId xmlns:a16="http://schemas.microsoft.com/office/drawing/2014/main" id="{19326B65-FF7F-4683-165B-9537A83100EE}"/>
+                <a16:creationId xmlns:a16="http://schemas.microsoft.com/office/drawing/2014/main" id="{2032A2CE-6FB7-F472-D6EF-05CB77473296}"/>
               </a:ext>
             </a:extLst>
           </p:cNvPr>
@@ -7548,7 +7548,7 @@
           <p:cNvPr id="43" name="TextBox 42">
             <a:extLst>
               <a:ext uri="{FF2B5EF4-FFF2-40B4-BE49-F238E27FC236}">
-                <a16:creationId xmlns:a16="http://schemas.microsoft.com/office/drawing/2014/main" id="{48FF6BD2-4FB0-ABA1-7D57-8D3A9D1F55E5}"/>
+                <a16:creationId xmlns:a16="http://schemas.microsoft.com/office/drawing/2014/main" id="{7BE2D7B7-FD2C-E64E-BE59-895E22F1392F}"/>
               </a:ext>
             </a:extLst>
           </p:cNvPr>
@@ -7589,7 +7589,7 @@
           <p:cNvPr id="44" name="TextBox 43">
             <a:extLst>
               <a:ext uri="{FF2B5EF4-FFF2-40B4-BE49-F238E27FC236}">
-                <a16:creationId xmlns:a16="http://schemas.microsoft.com/office/drawing/2014/main" id="{583BB12F-41FC-030C-4A46-FFE45700F75A}"/>
+                <a16:creationId xmlns:a16="http://schemas.microsoft.com/office/drawing/2014/main" id="{71C4D304-8C5B-FE87-1FFF-15C15AA994F5}"/>
               </a:ext>
             </a:extLst>
           </p:cNvPr>
@@ -7628,7 +7628,7 @@
     </p:spTree>
     <p:extLst>
       <p:ext uri="{BB962C8B-B14F-4D97-AF65-F5344CB8AC3E}">
-        <p14:creationId xmlns:p14="http://schemas.microsoft.com/office/powerpoint/2010/main" val="4112469426"/>
+        <p14:creationId xmlns:p14="http://schemas.microsoft.com/office/powerpoint/2010/main" val="1979771630"/>
       </p:ext>
     </p:extLst>
   </p:cSld>
@@ -7973,7 +7973,7 @@
           <p:cNvPr id="2" name="Rectangle 1">
             <a:extLst>
               <a:ext uri="{FF2B5EF4-FFF2-40B4-BE49-F238E27FC236}">
-                <a16:creationId xmlns:a16="http://schemas.microsoft.com/office/drawing/2014/main" id="{C9F73EC9-49A2-FE71-B21D-7D764CF3BCD2}"/>
+                <a16:creationId xmlns:a16="http://schemas.microsoft.com/office/drawing/2014/main" id="{0833C40B-E368-92ED-1971-61B729AD03EB}"/>
               </a:ext>
             </a:extLst>
           </p:cNvPr>
@@ -8041,7 +8041,7 @@
           <p:cNvPr id="3" name="Rectangle: Rounded Corners 2">
             <a:extLst>
               <a:ext uri="{FF2B5EF4-FFF2-40B4-BE49-F238E27FC236}">
-                <a16:creationId xmlns:a16="http://schemas.microsoft.com/office/drawing/2014/main" id="{A70A0EC0-00D9-0586-2FD8-794D6B8FC458}"/>
+                <a16:creationId xmlns:a16="http://schemas.microsoft.com/office/drawing/2014/main" id="{AF8C23BC-F75C-0311-BFCC-B6444CD3C150}"/>
               </a:ext>
             </a:extLst>
           </p:cNvPr>
@@ -8095,7 +8095,7 @@
           <p:cNvPr id="4" name="Rectangle: Rounded Corners 3">
             <a:extLst>
               <a:ext uri="{FF2B5EF4-FFF2-40B4-BE49-F238E27FC236}">
-                <a16:creationId xmlns:a16="http://schemas.microsoft.com/office/drawing/2014/main" id="{84EEAEA7-6CC2-64EB-4B6F-2CF9A2DB7FE7}"/>
+                <a16:creationId xmlns:a16="http://schemas.microsoft.com/office/drawing/2014/main" id="{B95163C9-2663-5A1E-0053-3D61CCCE1B2F}"/>
               </a:ext>
             </a:extLst>
           </p:cNvPr>
@@ -8146,7 +8146,7 @@
           <p:cNvPr id="5" name="TextBox 4">
             <a:extLst>
               <a:ext uri="{FF2B5EF4-FFF2-40B4-BE49-F238E27FC236}">
-                <a16:creationId xmlns:a16="http://schemas.microsoft.com/office/drawing/2014/main" id="{283D3153-2C85-027D-19AA-AACE5EF7818C}"/>
+                <a16:creationId xmlns:a16="http://schemas.microsoft.com/office/drawing/2014/main" id="{7FE23C11-E3B3-E826-D31D-53ED9AFFF953}"/>
               </a:ext>
             </a:extLst>
           </p:cNvPr>
@@ -8186,7 +8186,7 @@
           <p:cNvPr id="6" name="TextBox 5">
             <a:extLst>
               <a:ext uri="{FF2B5EF4-FFF2-40B4-BE49-F238E27FC236}">
-                <a16:creationId xmlns:a16="http://schemas.microsoft.com/office/drawing/2014/main" id="{AC3B0E80-4BE7-3E64-C064-EA87BD23F301}"/>
+                <a16:creationId xmlns:a16="http://schemas.microsoft.com/office/drawing/2014/main" id="{A425B93E-1578-D9CF-1B54-488B255C25B6}"/>
               </a:ext>
             </a:extLst>
           </p:cNvPr>
@@ -8226,7 +8226,7 @@
           <p:cNvPr id="7" name="TextBox 6">
             <a:extLst>
               <a:ext uri="{FF2B5EF4-FFF2-40B4-BE49-F238E27FC236}">
-                <a16:creationId xmlns:a16="http://schemas.microsoft.com/office/drawing/2014/main" id="{25FB15EB-6375-F6BC-8F25-015483FE5A3C}"/>
+                <a16:creationId xmlns:a16="http://schemas.microsoft.com/office/drawing/2014/main" id="{D86EA38D-F65C-58D5-940C-94A12814EEAB}"/>
               </a:ext>
             </a:extLst>
           </p:cNvPr>
@@ -8266,7 +8266,7 @@
           <p:cNvPr id="8" name="TextBox 7">
             <a:extLst>
               <a:ext uri="{FF2B5EF4-FFF2-40B4-BE49-F238E27FC236}">
-                <a16:creationId xmlns:a16="http://schemas.microsoft.com/office/drawing/2014/main" id="{AF1E1B05-CEE8-E537-CAE4-D35B2F26B3A1}"/>
+                <a16:creationId xmlns:a16="http://schemas.microsoft.com/office/drawing/2014/main" id="{69250B78-708A-E1DC-DEDF-AFC9B0C48A4A}"/>
               </a:ext>
             </a:extLst>
           </p:cNvPr>
@@ -8306,7 +8306,7 @@
           <p:cNvPr id="9" name="TextBox 8">
             <a:extLst>
               <a:ext uri="{FF2B5EF4-FFF2-40B4-BE49-F238E27FC236}">
-                <a16:creationId xmlns:a16="http://schemas.microsoft.com/office/drawing/2014/main" id="{C3DF0A45-E7E9-492D-C692-0B6AC729E204}"/>
+                <a16:creationId xmlns:a16="http://schemas.microsoft.com/office/drawing/2014/main" id="{4CFA076D-529D-A623-86E6-1A2F6CDEAD56}"/>
               </a:ext>
             </a:extLst>
           </p:cNvPr>
@@ -8346,7 +8346,7 @@
           <p:cNvPr id="10" name="Rectangle: Rounded Corners 9">
             <a:extLst>
               <a:ext uri="{FF2B5EF4-FFF2-40B4-BE49-F238E27FC236}">
-                <a16:creationId xmlns:a16="http://schemas.microsoft.com/office/drawing/2014/main" id="{D7603F7D-F6ED-852E-F957-C5B715C26504}"/>
+                <a16:creationId xmlns:a16="http://schemas.microsoft.com/office/drawing/2014/main" id="{854E5758-3CEA-89CF-47D6-997259C788C7}"/>
               </a:ext>
             </a:extLst>
           </p:cNvPr>
@@ -8408,7 +8408,7 @@
           <p:cNvPr id="11" name="TextBox 10">
             <a:extLst>
               <a:ext uri="{FF2B5EF4-FFF2-40B4-BE49-F238E27FC236}">
-                <a16:creationId xmlns:a16="http://schemas.microsoft.com/office/drawing/2014/main" id="{B2B69D8A-8A8C-BE08-2FBC-E643B5E11CD0}"/>
+                <a16:creationId xmlns:a16="http://schemas.microsoft.com/office/drawing/2014/main" id="{A9E186B1-B724-7754-0F7B-9CFF4DC0ED71}"/>
               </a:ext>
             </a:extLst>
           </p:cNvPr>
@@ -8448,7 +8448,7 @@
           <p:cNvPr id="12" name="Rectangle 11">
             <a:extLst>
               <a:ext uri="{FF2B5EF4-FFF2-40B4-BE49-F238E27FC236}">
-                <a16:creationId xmlns:a16="http://schemas.microsoft.com/office/drawing/2014/main" id="{A26B86DB-6972-1FB2-65DC-6A5F5118043C}"/>
+                <a16:creationId xmlns:a16="http://schemas.microsoft.com/office/drawing/2014/main" id="{5A14F50C-4F4A-B3DB-73A0-52CB71265EB0}"/>
               </a:ext>
             </a:extLst>
           </p:cNvPr>
@@ -8516,7 +8516,7 @@
           <p:cNvPr id="13" name="TextBox 12">
             <a:extLst>
               <a:ext uri="{FF2B5EF4-FFF2-40B4-BE49-F238E27FC236}">
-                <a16:creationId xmlns:a16="http://schemas.microsoft.com/office/drawing/2014/main" id="{E571AA8E-AF4B-7F91-9194-D1158A79AD1F}"/>
+                <a16:creationId xmlns:a16="http://schemas.microsoft.com/office/drawing/2014/main" id="{C47C43E7-8128-42A5-F07A-64C5D124BF11}"/>
               </a:ext>
             </a:extLst>
           </p:cNvPr>
@@ -8562,7 +8562,7 @@
           <p:cNvPr id="14" name="Rectangle: Rounded Corners 13">
             <a:extLst>
               <a:ext uri="{FF2B5EF4-FFF2-40B4-BE49-F238E27FC236}">
-                <a16:creationId xmlns:a16="http://schemas.microsoft.com/office/drawing/2014/main" id="{378D7EB1-635B-3E2A-963A-39F168227930}"/>
+                <a16:creationId xmlns:a16="http://schemas.microsoft.com/office/drawing/2014/main" id="{DBA7BCDA-82CB-8A02-68FA-DB5B720A58D3}"/>
               </a:ext>
             </a:extLst>
           </p:cNvPr>
@@ -8616,7 +8616,7 @@
           <p:cNvPr id="15" name="Pentagon 14">
             <a:extLst>
               <a:ext uri="{FF2B5EF4-FFF2-40B4-BE49-F238E27FC236}">
-                <a16:creationId xmlns:a16="http://schemas.microsoft.com/office/drawing/2014/main" id="{4B3ECCAC-3301-E6A1-7700-F5F54D5C7D90}"/>
+                <a16:creationId xmlns:a16="http://schemas.microsoft.com/office/drawing/2014/main" id="{AE82AD8F-9AE7-8829-FBD4-94BFA82AF5C3}"/>
               </a:ext>
             </a:extLst>
           </p:cNvPr>
@@ -8670,7 +8670,7 @@
           <p:cNvPr id="16" name="Pentagon 15">
             <a:extLst>
               <a:ext uri="{FF2B5EF4-FFF2-40B4-BE49-F238E27FC236}">
-                <a16:creationId xmlns:a16="http://schemas.microsoft.com/office/drawing/2014/main" id="{5FED1501-DA35-92B5-CDF4-77076D54FEEB}"/>
+                <a16:creationId xmlns:a16="http://schemas.microsoft.com/office/drawing/2014/main" id="{38FA7ECD-6EB7-B28F-895B-C91EC04B6029}"/>
               </a:ext>
             </a:extLst>
           </p:cNvPr>
@@ -8724,7 +8724,7 @@
           <p:cNvPr id="17" name="Pentagon 16">
             <a:extLst>
               <a:ext uri="{FF2B5EF4-FFF2-40B4-BE49-F238E27FC236}">
-                <a16:creationId xmlns:a16="http://schemas.microsoft.com/office/drawing/2014/main" id="{E94E4938-4FE1-2422-C1EE-16BDD3DF623D}"/>
+                <a16:creationId xmlns:a16="http://schemas.microsoft.com/office/drawing/2014/main" id="{882F6629-F3BC-7497-3357-664A7C8AA037}"/>
               </a:ext>
             </a:extLst>
           </p:cNvPr>
@@ -8778,7 +8778,7 @@
           <p:cNvPr id="18" name="Pentagon 17">
             <a:extLst>
               <a:ext uri="{FF2B5EF4-FFF2-40B4-BE49-F238E27FC236}">
-                <a16:creationId xmlns:a16="http://schemas.microsoft.com/office/drawing/2014/main" id="{3E0656E3-5947-9706-1C7C-78D33CF80F3A}"/>
+                <a16:creationId xmlns:a16="http://schemas.microsoft.com/office/drawing/2014/main" id="{B3A5A4E8-5CA1-6121-58D4-6761EA6DE84F}"/>
               </a:ext>
             </a:extLst>
           </p:cNvPr>
@@ -8832,7 +8832,7 @@
           <p:cNvPr id="20" name="Picture 19">
             <a:extLst>
               <a:ext uri="{FF2B5EF4-FFF2-40B4-BE49-F238E27FC236}">
-                <a16:creationId xmlns:a16="http://schemas.microsoft.com/office/drawing/2014/main" id="{76647B09-EA21-2321-04EE-1AB7374D0E46}"/>
+                <a16:creationId xmlns:a16="http://schemas.microsoft.com/office/drawing/2014/main" id="{C0EA7D59-774C-26AD-56BD-6F67CE5715C6}"/>
               </a:ext>
             </a:extLst>
           </p:cNvPr>
@@ -8868,7 +8868,7 @@
           <p:cNvPr id="21" name="Rectangle: Rounded Corners 20">
             <a:extLst>
               <a:ext uri="{FF2B5EF4-FFF2-40B4-BE49-F238E27FC236}">
-                <a16:creationId xmlns:a16="http://schemas.microsoft.com/office/drawing/2014/main" id="{04C55C12-56AB-E23A-02D2-9E1C89D87857}"/>
+                <a16:creationId xmlns:a16="http://schemas.microsoft.com/office/drawing/2014/main" id="{EC76449C-D3B4-5595-B5CF-70D57BEFACEB}"/>
               </a:ext>
             </a:extLst>
           </p:cNvPr>
@@ -8930,7 +8930,7 @@
           <p:cNvPr id="22" name="TextBox 21">
             <a:extLst>
               <a:ext uri="{FF2B5EF4-FFF2-40B4-BE49-F238E27FC236}">
-                <a16:creationId xmlns:a16="http://schemas.microsoft.com/office/drawing/2014/main" id="{1CC3224B-6261-C5AB-CFEF-05E061662D08}"/>
+                <a16:creationId xmlns:a16="http://schemas.microsoft.com/office/drawing/2014/main" id="{8569EF86-96C4-7477-1FCD-3BC5B45F0E74}"/>
               </a:ext>
             </a:extLst>
           </p:cNvPr>
@@ -8970,7 +8970,7 @@
           <p:cNvPr id="23" name="Rectangle: Rounded Corners 22">
             <a:extLst>
               <a:ext uri="{FF2B5EF4-FFF2-40B4-BE49-F238E27FC236}">
-                <a16:creationId xmlns:a16="http://schemas.microsoft.com/office/drawing/2014/main" id="{40AF19B7-8994-3723-8A35-346A5C0BFB63}"/>
+                <a16:creationId xmlns:a16="http://schemas.microsoft.com/office/drawing/2014/main" id="{B8F8A591-8588-460F-5982-A0EA335E96BC}"/>
               </a:ext>
             </a:extLst>
           </p:cNvPr>
@@ -9048,7 +9048,7 @@
           <p:cNvPr id="27" name="Group 26">
             <a:extLst>
               <a:ext uri="{FF2B5EF4-FFF2-40B4-BE49-F238E27FC236}">
-                <a16:creationId xmlns:a16="http://schemas.microsoft.com/office/drawing/2014/main" id="{DD33FA48-85D8-CCB6-0BC4-56EBCE4AEED7}"/>
+                <a16:creationId xmlns:a16="http://schemas.microsoft.com/office/drawing/2014/main" id="{F64EBC21-2934-4386-27D7-2C627E5376C7}"/>
               </a:ext>
             </a:extLst>
           </p:cNvPr>
@@ -9068,7 +9068,7 @@
             <p:cNvPr id="24" name="Rectangle: Rounded Corners 23">
               <a:extLst>
                 <a:ext uri="{FF2B5EF4-FFF2-40B4-BE49-F238E27FC236}">
-                  <a16:creationId xmlns:a16="http://schemas.microsoft.com/office/drawing/2014/main" id="{BAF1C371-6C78-2E92-BFE6-4C7C529DF2E8}"/>
+                  <a16:creationId xmlns:a16="http://schemas.microsoft.com/office/drawing/2014/main" id="{1DB9A9B6-D362-B836-0F99-AA24FF8F3A74}"/>
                 </a:ext>
               </a:extLst>
             </p:cNvPr>
@@ -9122,7 +9122,7 @@
             <p:cNvPr id="25" name="Rectangle: Rounded Corners 24">
               <a:extLst>
                 <a:ext uri="{FF2B5EF4-FFF2-40B4-BE49-F238E27FC236}">
-                  <a16:creationId xmlns:a16="http://schemas.microsoft.com/office/drawing/2014/main" id="{3E666244-EF4B-1C3C-B4A2-0DF92EAF682A}"/>
+                  <a16:creationId xmlns:a16="http://schemas.microsoft.com/office/drawing/2014/main" id="{2DC28DEF-F3D9-7EC5-D031-733CEB8991E0}"/>
                 </a:ext>
               </a:extLst>
             </p:cNvPr>
@@ -9184,7 +9184,7 @@
             <p:cNvPr id="26" name="TextBox 25">
               <a:extLst>
                 <a:ext uri="{FF2B5EF4-FFF2-40B4-BE49-F238E27FC236}">
-                  <a16:creationId xmlns:a16="http://schemas.microsoft.com/office/drawing/2014/main" id="{A90CCA74-BA37-A524-903D-769BD137BF5F}"/>
+                  <a16:creationId xmlns:a16="http://schemas.microsoft.com/office/drawing/2014/main" id="{9AB4524D-CD1B-1956-E47C-C517D6134AD0}"/>
                 </a:ext>
               </a:extLst>
             </p:cNvPr>
@@ -9225,7 +9225,7 @@
           <p:cNvPr id="31" name="Group 30">
             <a:extLst>
               <a:ext uri="{FF2B5EF4-FFF2-40B4-BE49-F238E27FC236}">
-                <a16:creationId xmlns:a16="http://schemas.microsoft.com/office/drawing/2014/main" id="{3DB0E235-FB73-1B74-1A16-D6E182FFE770}"/>
+                <a16:creationId xmlns:a16="http://schemas.microsoft.com/office/drawing/2014/main" id="{FD970994-2E71-D5AE-4E3D-54D08FEBB8E0}"/>
               </a:ext>
             </a:extLst>
           </p:cNvPr>
@@ -9245,7 +9245,7 @@
             <p:cNvPr id="28" name="Rectangle: Rounded Corners 27">
               <a:extLst>
                 <a:ext uri="{FF2B5EF4-FFF2-40B4-BE49-F238E27FC236}">
-                  <a16:creationId xmlns:a16="http://schemas.microsoft.com/office/drawing/2014/main" id="{65A1F829-5034-3BC8-E667-A6384FD77026}"/>
+                  <a16:creationId xmlns:a16="http://schemas.microsoft.com/office/drawing/2014/main" id="{26885EBC-EF5D-8FF4-90F5-66D4E8309A03}"/>
                 </a:ext>
               </a:extLst>
             </p:cNvPr>
@@ -9299,7 +9299,7 @@
             <p:cNvPr id="29" name="Rectangle: Rounded Corners 28">
               <a:extLst>
                 <a:ext uri="{FF2B5EF4-FFF2-40B4-BE49-F238E27FC236}">
-                  <a16:creationId xmlns:a16="http://schemas.microsoft.com/office/drawing/2014/main" id="{FD0683E6-4969-C69D-1F5E-F2512D2CA832}"/>
+                  <a16:creationId xmlns:a16="http://schemas.microsoft.com/office/drawing/2014/main" id="{7F919CF4-2BFF-7EAC-692B-176E58832067}"/>
                 </a:ext>
               </a:extLst>
             </p:cNvPr>
@@ -9361,7 +9361,7 @@
             <p:cNvPr id="30" name="TextBox 29">
               <a:extLst>
                 <a:ext uri="{FF2B5EF4-FFF2-40B4-BE49-F238E27FC236}">
-                  <a16:creationId xmlns:a16="http://schemas.microsoft.com/office/drawing/2014/main" id="{DC099200-AEDE-CD88-1136-E039B4B757A2}"/>
+                  <a16:creationId xmlns:a16="http://schemas.microsoft.com/office/drawing/2014/main" id="{F3DEF8CF-41A8-C829-3FD3-341054AA811D}"/>
                 </a:ext>
               </a:extLst>
             </p:cNvPr>
@@ -9408,7 +9408,7 @@
           <p:cNvPr id="35" name="Group 34">
             <a:extLst>
               <a:ext uri="{FF2B5EF4-FFF2-40B4-BE49-F238E27FC236}">
-                <a16:creationId xmlns:a16="http://schemas.microsoft.com/office/drawing/2014/main" id="{ADDEA789-F869-91C3-AFAB-CB910099D53F}"/>
+                <a16:creationId xmlns:a16="http://schemas.microsoft.com/office/drawing/2014/main" id="{00C41364-546A-6B8C-D56B-0DE91C30C40D}"/>
               </a:ext>
             </a:extLst>
           </p:cNvPr>
@@ -9428,7 +9428,7 @@
             <p:cNvPr id="32" name="Rectangle: Rounded Corners 31">
               <a:extLst>
                 <a:ext uri="{FF2B5EF4-FFF2-40B4-BE49-F238E27FC236}">
-                  <a16:creationId xmlns:a16="http://schemas.microsoft.com/office/drawing/2014/main" id="{B51771B4-C015-FF75-998F-FA6DAFC7F01C}"/>
+                  <a16:creationId xmlns:a16="http://schemas.microsoft.com/office/drawing/2014/main" id="{2127B82C-688A-78A2-3523-A7BA40F79B0C}"/>
                 </a:ext>
               </a:extLst>
             </p:cNvPr>
@@ -9482,7 +9482,7 @@
             <p:cNvPr id="33" name="Rectangle: Rounded Corners 32">
               <a:extLst>
                 <a:ext uri="{FF2B5EF4-FFF2-40B4-BE49-F238E27FC236}">
-                  <a16:creationId xmlns:a16="http://schemas.microsoft.com/office/drawing/2014/main" id="{4BE92D9F-6446-674F-6B88-2B8F404D330B}"/>
+                  <a16:creationId xmlns:a16="http://schemas.microsoft.com/office/drawing/2014/main" id="{964C93B3-215E-2B4E-FFF2-7ECB2D86BD79}"/>
                 </a:ext>
               </a:extLst>
             </p:cNvPr>
@@ -9544,7 +9544,7 @@
             <p:cNvPr id="34" name="TextBox 33">
               <a:extLst>
                 <a:ext uri="{FF2B5EF4-FFF2-40B4-BE49-F238E27FC236}">
-                  <a16:creationId xmlns:a16="http://schemas.microsoft.com/office/drawing/2014/main" id="{92F8B322-6752-FC7D-8C86-620CC38B7080}"/>
+                  <a16:creationId xmlns:a16="http://schemas.microsoft.com/office/drawing/2014/main" id="{4596F2F7-2EE7-7BE9-F62A-A2B4C9A7E0B0}"/>
                 </a:ext>
               </a:extLst>
             </p:cNvPr>
@@ -9591,7 +9591,7 @@
           <p:cNvPr id="39" name="Group 38">
             <a:extLst>
               <a:ext uri="{FF2B5EF4-FFF2-40B4-BE49-F238E27FC236}">
-                <a16:creationId xmlns:a16="http://schemas.microsoft.com/office/drawing/2014/main" id="{6566B2DE-BB74-D8A9-9821-14C6C3B0879E}"/>
+                <a16:creationId xmlns:a16="http://schemas.microsoft.com/office/drawing/2014/main" id="{1AB46098-BD6E-8B38-8DD8-32D3D98EA77F}"/>
               </a:ext>
             </a:extLst>
           </p:cNvPr>
@@ -9611,7 +9611,7 @@
             <p:cNvPr id="36" name="Rectangle: Rounded Corners 35">
               <a:extLst>
                 <a:ext uri="{FF2B5EF4-FFF2-40B4-BE49-F238E27FC236}">
-                  <a16:creationId xmlns:a16="http://schemas.microsoft.com/office/drawing/2014/main" id="{778D1239-57AA-9D3D-162E-98742AB488FB}"/>
+                  <a16:creationId xmlns:a16="http://schemas.microsoft.com/office/drawing/2014/main" id="{D88BAC38-49AE-67BC-A75B-5F3CC142113A}"/>
                 </a:ext>
               </a:extLst>
             </p:cNvPr>
@@ -9665,7 +9665,7 @@
             <p:cNvPr id="37" name="Rectangle: Rounded Corners 36">
               <a:extLst>
                 <a:ext uri="{FF2B5EF4-FFF2-40B4-BE49-F238E27FC236}">
-                  <a16:creationId xmlns:a16="http://schemas.microsoft.com/office/drawing/2014/main" id="{172DAB4C-797A-1C46-CF6C-19085B82698D}"/>
+                  <a16:creationId xmlns:a16="http://schemas.microsoft.com/office/drawing/2014/main" id="{D2E0765D-01B7-4ACE-48ED-1685EA46E0D9}"/>
                 </a:ext>
               </a:extLst>
             </p:cNvPr>
@@ -9727,7 +9727,7 @@
             <p:cNvPr id="38" name="TextBox 37">
               <a:extLst>
                 <a:ext uri="{FF2B5EF4-FFF2-40B4-BE49-F238E27FC236}">
-                  <a16:creationId xmlns:a16="http://schemas.microsoft.com/office/drawing/2014/main" id="{4171988D-656B-7796-617E-379B8524A54D}"/>
+                  <a16:creationId xmlns:a16="http://schemas.microsoft.com/office/drawing/2014/main" id="{346B9BB7-B627-E4DB-1C82-6BD8394984C9}"/>
                 </a:ext>
               </a:extLst>
             </p:cNvPr>
@@ -9774,7 +9774,7 @@
           <p:cNvPr id="43" name="Group 42">
             <a:extLst>
               <a:ext uri="{FF2B5EF4-FFF2-40B4-BE49-F238E27FC236}">
-                <a16:creationId xmlns:a16="http://schemas.microsoft.com/office/drawing/2014/main" id="{086A5DC0-987E-61F0-8F6A-CBF78F265509}"/>
+                <a16:creationId xmlns:a16="http://schemas.microsoft.com/office/drawing/2014/main" id="{3255F757-7290-84D8-E46C-512B15C9C3F0}"/>
               </a:ext>
             </a:extLst>
           </p:cNvPr>
@@ -9794,7 +9794,7 @@
             <p:cNvPr id="40" name="Rectangle: Rounded Corners 39">
               <a:extLst>
                 <a:ext uri="{FF2B5EF4-FFF2-40B4-BE49-F238E27FC236}">
-                  <a16:creationId xmlns:a16="http://schemas.microsoft.com/office/drawing/2014/main" id="{42F3D266-DB5E-53F3-DACB-62ED1E0B5BF3}"/>
+                  <a16:creationId xmlns:a16="http://schemas.microsoft.com/office/drawing/2014/main" id="{037E59CB-F0D9-2652-396F-B6D7B4BAA7D9}"/>
                 </a:ext>
               </a:extLst>
             </p:cNvPr>
@@ -9848,7 +9848,7 @@
             <p:cNvPr id="41" name="Rectangle: Rounded Corners 40">
               <a:extLst>
                 <a:ext uri="{FF2B5EF4-FFF2-40B4-BE49-F238E27FC236}">
-                  <a16:creationId xmlns:a16="http://schemas.microsoft.com/office/drawing/2014/main" id="{527EFEA0-9651-7750-E69F-37F8675BA9A5}"/>
+                  <a16:creationId xmlns:a16="http://schemas.microsoft.com/office/drawing/2014/main" id="{5AF15CFC-0201-F349-AC29-8E53DAC19C66}"/>
                 </a:ext>
               </a:extLst>
             </p:cNvPr>
@@ -9910,7 +9910,7 @@
             <p:cNvPr id="42" name="TextBox 41">
               <a:extLst>
                 <a:ext uri="{FF2B5EF4-FFF2-40B4-BE49-F238E27FC236}">
-                  <a16:creationId xmlns:a16="http://schemas.microsoft.com/office/drawing/2014/main" id="{0DB95ACD-2F32-6638-B758-7DB3B7806F95}"/>
+                  <a16:creationId xmlns:a16="http://schemas.microsoft.com/office/drawing/2014/main" id="{8DBCDB15-FC43-F22F-78C6-C121F021E923}"/>
                 </a:ext>
               </a:extLst>
             </p:cNvPr>
@@ -9957,7 +9957,7 @@
           <p:cNvPr id="44" name="Rectangle 43">
             <a:extLst>
               <a:ext uri="{FF2B5EF4-FFF2-40B4-BE49-F238E27FC236}">
-                <a16:creationId xmlns:a16="http://schemas.microsoft.com/office/drawing/2014/main" id="{1865BCDE-DDDD-9BFC-5B1B-C4EE85878581}"/>
+                <a16:creationId xmlns:a16="http://schemas.microsoft.com/office/drawing/2014/main" id="{97C4016C-09D4-AC78-1F91-3F77B8936FFA}"/>
               </a:ext>
             </a:extLst>
           </p:cNvPr>
@@ -10025,7 +10025,7 @@
           <p:cNvPr id="45" name="TextBox 44">
             <a:extLst>
               <a:ext uri="{FF2B5EF4-FFF2-40B4-BE49-F238E27FC236}">
-                <a16:creationId xmlns:a16="http://schemas.microsoft.com/office/drawing/2014/main" id="{BD65A821-0608-73FF-1A5D-E068E6924A07}"/>
+                <a16:creationId xmlns:a16="http://schemas.microsoft.com/office/drawing/2014/main" id="{597491CD-C490-842B-1829-A35B981292F2}"/>
               </a:ext>
             </a:extLst>
           </p:cNvPr>
@@ -10065,7 +10065,7 @@
           <p:cNvPr id="46" name="TextBox 45">
             <a:extLst>
               <a:ext uri="{FF2B5EF4-FFF2-40B4-BE49-F238E27FC236}">
-                <a16:creationId xmlns:a16="http://schemas.microsoft.com/office/drawing/2014/main" id="{091CEA50-6165-3A7D-FF0B-0FC02A4050BD}"/>
+                <a16:creationId xmlns:a16="http://schemas.microsoft.com/office/drawing/2014/main" id="{A46A2699-C7F8-27A1-CC6D-BD365B5F39BC}"/>
               </a:ext>
             </a:extLst>
           </p:cNvPr>
@@ -10106,7 +10106,7 @@
           <p:cNvPr id="47" name="TextBox 46">
             <a:extLst>
               <a:ext uri="{FF2B5EF4-FFF2-40B4-BE49-F238E27FC236}">
-                <a16:creationId xmlns:a16="http://schemas.microsoft.com/office/drawing/2014/main" id="{3DB604A8-95B6-5652-5892-8F84AC947F68}"/>
+                <a16:creationId xmlns:a16="http://schemas.microsoft.com/office/drawing/2014/main" id="{32042428-3338-1018-DD65-5DDC2AEBA089}"/>
               </a:ext>
             </a:extLst>
           </p:cNvPr>
@@ -10145,7 +10145,7 @@
     </p:spTree>
     <p:extLst>
       <p:ext uri="{BB962C8B-B14F-4D97-AF65-F5344CB8AC3E}">
-        <p14:creationId xmlns:p14="http://schemas.microsoft.com/office/powerpoint/2010/main" val="3219504872"/>
+        <p14:creationId xmlns:p14="http://schemas.microsoft.com/office/powerpoint/2010/main" val="1383917540"/>
       </p:ext>
     </p:extLst>
   </p:cSld>
@@ -10489,7 +10489,7 @@
           <p:cNvPr id="2" name="Rectangle 1">
             <a:extLst>
               <a:ext uri="{FF2B5EF4-FFF2-40B4-BE49-F238E27FC236}">
-                <a16:creationId xmlns:a16="http://schemas.microsoft.com/office/drawing/2014/main" id="{7D88CF81-2DD2-2EF4-D6A5-75F2D97FC809}"/>
+                <a16:creationId xmlns:a16="http://schemas.microsoft.com/office/drawing/2014/main" id="{B1023916-9CE7-0258-422F-D4BC5C674D9B}"/>
               </a:ext>
             </a:extLst>
           </p:cNvPr>
@@ -10557,7 +10557,7 @@
           <p:cNvPr id="3" name="Rectangle: Rounded Corners 2">
             <a:extLst>
               <a:ext uri="{FF2B5EF4-FFF2-40B4-BE49-F238E27FC236}">
-                <a16:creationId xmlns:a16="http://schemas.microsoft.com/office/drawing/2014/main" id="{AD963810-946D-B606-AC92-A8627A9AB55E}"/>
+                <a16:creationId xmlns:a16="http://schemas.microsoft.com/office/drawing/2014/main" id="{5D8189CB-E788-B50A-A37B-95A1CCB1E4C9}"/>
               </a:ext>
             </a:extLst>
           </p:cNvPr>
@@ -10611,7 +10611,7 @@
           <p:cNvPr id="4" name="Rectangle: Rounded Corners 3">
             <a:extLst>
               <a:ext uri="{FF2B5EF4-FFF2-40B4-BE49-F238E27FC236}">
-                <a16:creationId xmlns:a16="http://schemas.microsoft.com/office/drawing/2014/main" id="{568016FC-3539-F662-77DC-E8BBA9A6A16E}"/>
+                <a16:creationId xmlns:a16="http://schemas.microsoft.com/office/drawing/2014/main" id="{841893FF-CA71-BB06-0544-56BA04D067CD}"/>
               </a:ext>
             </a:extLst>
           </p:cNvPr>
@@ -10662,7 +10662,7 @@
           <p:cNvPr id="5" name="TextBox 4">
             <a:extLst>
               <a:ext uri="{FF2B5EF4-FFF2-40B4-BE49-F238E27FC236}">
-                <a16:creationId xmlns:a16="http://schemas.microsoft.com/office/drawing/2014/main" id="{604FE1E9-4751-8D2C-6917-EB6D8362F910}"/>
+                <a16:creationId xmlns:a16="http://schemas.microsoft.com/office/drawing/2014/main" id="{BB0C435F-BDFD-B435-DF56-29C14BA8382D}"/>
               </a:ext>
             </a:extLst>
           </p:cNvPr>
@@ -10702,7 +10702,7 @@
           <p:cNvPr id="6" name="TextBox 5">
             <a:extLst>
               <a:ext uri="{FF2B5EF4-FFF2-40B4-BE49-F238E27FC236}">
-                <a16:creationId xmlns:a16="http://schemas.microsoft.com/office/drawing/2014/main" id="{EBE0C9B7-6E50-E67A-7489-057CB6812146}"/>
+                <a16:creationId xmlns:a16="http://schemas.microsoft.com/office/drawing/2014/main" id="{DC617292-56F3-F0CC-BD78-085AC6100A5C}"/>
               </a:ext>
             </a:extLst>
           </p:cNvPr>
@@ -10742,7 +10742,7 @@
           <p:cNvPr id="7" name="TextBox 6">
             <a:extLst>
               <a:ext uri="{FF2B5EF4-FFF2-40B4-BE49-F238E27FC236}">
-                <a16:creationId xmlns:a16="http://schemas.microsoft.com/office/drawing/2014/main" id="{5B228989-6123-5F63-77EE-B756C684475F}"/>
+                <a16:creationId xmlns:a16="http://schemas.microsoft.com/office/drawing/2014/main" id="{BE11EEAA-7E4E-856D-9087-E49ECE9F2A11}"/>
               </a:ext>
             </a:extLst>
           </p:cNvPr>
@@ -10782,7 +10782,7 @@
           <p:cNvPr id="8" name="TextBox 7">
             <a:extLst>
               <a:ext uri="{FF2B5EF4-FFF2-40B4-BE49-F238E27FC236}">
-                <a16:creationId xmlns:a16="http://schemas.microsoft.com/office/drawing/2014/main" id="{E0A4947A-64D0-0E8D-140C-AEECEA2756EE}"/>
+                <a16:creationId xmlns:a16="http://schemas.microsoft.com/office/drawing/2014/main" id="{9927148C-CB5E-EF3C-619B-30047C9F7C08}"/>
               </a:ext>
             </a:extLst>
           </p:cNvPr>
@@ -10822,7 +10822,7 @@
           <p:cNvPr id="9" name="TextBox 8">
             <a:extLst>
               <a:ext uri="{FF2B5EF4-FFF2-40B4-BE49-F238E27FC236}">
-                <a16:creationId xmlns:a16="http://schemas.microsoft.com/office/drawing/2014/main" id="{36A7B8CF-D790-9B19-318D-D68A79641B9B}"/>
+                <a16:creationId xmlns:a16="http://schemas.microsoft.com/office/drawing/2014/main" id="{200EF469-263E-B494-378B-0B7BD300C0C7}"/>
               </a:ext>
             </a:extLst>
           </p:cNvPr>
@@ -10862,7 +10862,7 @@
           <p:cNvPr id="10" name="Rectangle: Rounded Corners 9">
             <a:extLst>
               <a:ext uri="{FF2B5EF4-FFF2-40B4-BE49-F238E27FC236}">
-                <a16:creationId xmlns:a16="http://schemas.microsoft.com/office/drawing/2014/main" id="{64AEC387-D568-BBEB-06D7-73D2900D9314}"/>
+                <a16:creationId xmlns:a16="http://schemas.microsoft.com/office/drawing/2014/main" id="{F34CCB08-EED3-27D4-14B0-6B9B5CBA45F5}"/>
               </a:ext>
             </a:extLst>
           </p:cNvPr>
@@ -10924,7 +10924,7 @@
           <p:cNvPr id="11" name="TextBox 10">
             <a:extLst>
               <a:ext uri="{FF2B5EF4-FFF2-40B4-BE49-F238E27FC236}">
-                <a16:creationId xmlns:a16="http://schemas.microsoft.com/office/drawing/2014/main" id="{8171F144-00D2-2968-C759-D9998133AEB4}"/>
+                <a16:creationId xmlns:a16="http://schemas.microsoft.com/office/drawing/2014/main" id="{1986BB4A-46BD-E406-53F7-D68E98F3AA5F}"/>
               </a:ext>
             </a:extLst>
           </p:cNvPr>
@@ -10964,7 +10964,7 @@
           <p:cNvPr id="12" name="Rectangle 11">
             <a:extLst>
               <a:ext uri="{FF2B5EF4-FFF2-40B4-BE49-F238E27FC236}">
-                <a16:creationId xmlns:a16="http://schemas.microsoft.com/office/drawing/2014/main" id="{B25C3509-4C83-2E40-098F-2016F4D56449}"/>
+                <a16:creationId xmlns:a16="http://schemas.microsoft.com/office/drawing/2014/main" id="{FFD00F03-FE91-0A2B-CE06-2E3F0003D4F0}"/>
               </a:ext>
             </a:extLst>
           </p:cNvPr>
@@ -11032,7 +11032,7 @@
           <p:cNvPr id="13" name="TextBox 12">
             <a:extLst>
               <a:ext uri="{FF2B5EF4-FFF2-40B4-BE49-F238E27FC236}">
-                <a16:creationId xmlns:a16="http://schemas.microsoft.com/office/drawing/2014/main" id="{591A526A-B775-90D4-CBE7-8709D1FBDCD8}"/>
+                <a16:creationId xmlns:a16="http://schemas.microsoft.com/office/drawing/2014/main" id="{652E1E03-880C-A45B-958F-4EA3D240C586}"/>
               </a:ext>
             </a:extLst>
           </p:cNvPr>
@@ -11078,7 +11078,7 @@
           <p:cNvPr id="14" name="Rectangle: Rounded Corners 13">
             <a:extLst>
               <a:ext uri="{FF2B5EF4-FFF2-40B4-BE49-F238E27FC236}">
-                <a16:creationId xmlns:a16="http://schemas.microsoft.com/office/drawing/2014/main" id="{74AC9734-7540-EDD4-A89D-7FF1678616D6}"/>
+                <a16:creationId xmlns:a16="http://schemas.microsoft.com/office/drawing/2014/main" id="{752C7F75-02B7-2484-AB44-B45BF0F7E471}"/>
               </a:ext>
             </a:extLst>
           </p:cNvPr>
@@ -11132,7 +11132,7 @@
           <p:cNvPr id="15" name="Pentagon 14">
             <a:extLst>
               <a:ext uri="{FF2B5EF4-FFF2-40B4-BE49-F238E27FC236}">
-                <a16:creationId xmlns:a16="http://schemas.microsoft.com/office/drawing/2014/main" id="{BFD444ED-61C7-82F4-428C-DC1C9BC241E4}"/>
+                <a16:creationId xmlns:a16="http://schemas.microsoft.com/office/drawing/2014/main" id="{9CE93FB3-343F-7933-50A8-F844454A4CA3}"/>
               </a:ext>
             </a:extLst>
           </p:cNvPr>
@@ -11186,7 +11186,7 @@
           <p:cNvPr id="16" name="Pentagon 15">
             <a:extLst>
               <a:ext uri="{FF2B5EF4-FFF2-40B4-BE49-F238E27FC236}">
-                <a16:creationId xmlns:a16="http://schemas.microsoft.com/office/drawing/2014/main" id="{83C56216-7F04-A920-79D7-6B66C67C3ACB}"/>
+                <a16:creationId xmlns:a16="http://schemas.microsoft.com/office/drawing/2014/main" id="{FB869994-F26C-1A82-EA4F-F4B9019E5D77}"/>
               </a:ext>
             </a:extLst>
           </p:cNvPr>
@@ -11240,7 +11240,7 @@
           <p:cNvPr id="17" name="Pentagon 16">
             <a:extLst>
               <a:ext uri="{FF2B5EF4-FFF2-40B4-BE49-F238E27FC236}">
-                <a16:creationId xmlns:a16="http://schemas.microsoft.com/office/drawing/2014/main" id="{9CB19560-BBDE-39A3-7206-457443E89351}"/>
+                <a16:creationId xmlns:a16="http://schemas.microsoft.com/office/drawing/2014/main" id="{E671EE6F-5A61-1B4C-415A-DF17D8AA140E}"/>
               </a:ext>
             </a:extLst>
           </p:cNvPr>
@@ -11294,7 +11294,7 @@
           <p:cNvPr id="18" name="Pentagon 17">
             <a:extLst>
               <a:ext uri="{FF2B5EF4-FFF2-40B4-BE49-F238E27FC236}">
-                <a16:creationId xmlns:a16="http://schemas.microsoft.com/office/drawing/2014/main" id="{84A8063F-40AA-6894-9613-B4038DA4AF2F}"/>
+                <a16:creationId xmlns:a16="http://schemas.microsoft.com/office/drawing/2014/main" id="{2B36ACDB-DDE7-335D-A586-CEB38D39622F}"/>
               </a:ext>
             </a:extLst>
           </p:cNvPr>
@@ -11348,7 +11348,7 @@
           <p:cNvPr id="20" name="Picture 19">
             <a:extLst>
               <a:ext uri="{FF2B5EF4-FFF2-40B4-BE49-F238E27FC236}">
-                <a16:creationId xmlns:a16="http://schemas.microsoft.com/office/drawing/2014/main" id="{A697C77D-DD6A-A79D-6EC4-B49A4A6EBA95}"/>
+                <a16:creationId xmlns:a16="http://schemas.microsoft.com/office/drawing/2014/main" id="{C4C6C90E-729F-1172-D0B5-F9E9E4965F13}"/>
               </a:ext>
             </a:extLst>
           </p:cNvPr>
@@ -11384,7 +11384,7 @@
           <p:cNvPr id="21" name="Rectangle: Rounded Corners 20">
             <a:extLst>
               <a:ext uri="{FF2B5EF4-FFF2-40B4-BE49-F238E27FC236}">
-                <a16:creationId xmlns:a16="http://schemas.microsoft.com/office/drawing/2014/main" id="{AEC8ABED-5B15-7C9D-6A3C-6A43DFA43981}"/>
+                <a16:creationId xmlns:a16="http://schemas.microsoft.com/office/drawing/2014/main" id="{F56B9A61-AFE4-0CD3-1D47-A7D9B0E09FF8}"/>
               </a:ext>
             </a:extLst>
           </p:cNvPr>
@@ -11446,7 +11446,7 @@
           <p:cNvPr id="22" name="TextBox 21">
             <a:extLst>
               <a:ext uri="{FF2B5EF4-FFF2-40B4-BE49-F238E27FC236}">
-                <a16:creationId xmlns:a16="http://schemas.microsoft.com/office/drawing/2014/main" id="{0B016DB8-838E-2047-240E-08A5C951BD0C}"/>
+                <a16:creationId xmlns:a16="http://schemas.microsoft.com/office/drawing/2014/main" id="{AD716EA1-69AE-8DB2-D2E5-7B27214DB1D2}"/>
               </a:ext>
             </a:extLst>
           </p:cNvPr>
@@ -11492,7 +11492,7 @@
           <p:cNvPr id="23" name="Rectangle: Rounded Corners 22">
             <a:extLst>
               <a:ext uri="{FF2B5EF4-FFF2-40B4-BE49-F238E27FC236}">
-                <a16:creationId xmlns:a16="http://schemas.microsoft.com/office/drawing/2014/main" id="{80ADA421-B77B-C8DF-0278-1FFA38550C9D}"/>
+                <a16:creationId xmlns:a16="http://schemas.microsoft.com/office/drawing/2014/main" id="{078A2F4A-12E9-503F-CBD0-D63ACC7B8B12}"/>
               </a:ext>
             </a:extLst>
           </p:cNvPr>
@@ -11570,7 +11570,7 @@
           <p:cNvPr id="27" name="Group 26">
             <a:extLst>
               <a:ext uri="{FF2B5EF4-FFF2-40B4-BE49-F238E27FC236}">
-                <a16:creationId xmlns:a16="http://schemas.microsoft.com/office/drawing/2014/main" id="{975E8E06-DC9A-D58A-3B23-A8CBC9881A4A}"/>
+                <a16:creationId xmlns:a16="http://schemas.microsoft.com/office/drawing/2014/main" id="{872CBCF8-4DB0-16C6-F34C-A151089356BB}"/>
               </a:ext>
             </a:extLst>
           </p:cNvPr>
@@ -11590,7 +11590,7 @@
             <p:cNvPr id="24" name="Rectangle: Rounded Corners 23">
               <a:extLst>
                 <a:ext uri="{FF2B5EF4-FFF2-40B4-BE49-F238E27FC236}">
-                  <a16:creationId xmlns:a16="http://schemas.microsoft.com/office/drawing/2014/main" id="{7C78E3A1-ACEE-E6C6-AD49-ABAAC485C30C}"/>
+                  <a16:creationId xmlns:a16="http://schemas.microsoft.com/office/drawing/2014/main" id="{6C910143-1DFF-09EC-B710-DD16DCC1DDC6}"/>
                 </a:ext>
               </a:extLst>
             </p:cNvPr>
@@ -11644,7 +11644,7 @@
             <p:cNvPr id="25" name="Rectangle: Rounded Corners 24">
               <a:extLst>
                 <a:ext uri="{FF2B5EF4-FFF2-40B4-BE49-F238E27FC236}">
-                  <a16:creationId xmlns:a16="http://schemas.microsoft.com/office/drawing/2014/main" id="{932A37EF-D8C0-73D6-EA3C-BA22AD71C127}"/>
+                  <a16:creationId xmlns:a16="http://schemas.microsoft.com/office/drawing/2014/main" id="{218B7ABF-26EB-7206-BCF3-DFFF3C3AF6EF}"/>
                 </a:ext>
               </a:extLst>
             </p:cNvPr>
@@ -11706,7 +11706,7 @@
             <p:cNvPr id="26" name="TextBox 25">
               <a:extLst>
                 <a:ext uri="{FF2B5EF4-FFF2-40B4-BE49-F238E27FC236}">
-                  <a16:creationId xmlns:a16="http://schemas.microsoft.com/office/drawing/2014/main" id="{4266377C-1A16-B8B6-D521-4852ACECBB0E}"/>
+                  <a16:creationId xmlns:a16="http://schemas.microsoft.com/office/drawing/2014/main" id="{D7E08E32-BCF5-AC7E-9E94-52EED0C4D83D}"/>
                 </a:ext>
               </a:extLst>
             </p:cNvPr>
@@ -11753,7 +11753,7 @@
           <p:cNvPr id="31" name="Group 30">
             <a:extLst>
               <a:ext uri="{FF2B5EF4-FFF2-40B4-BE49-F238E27FC236}">
-                <a16:creationId xmlns:a16="http://schemas.microsoft.com/office/drawing/2014/main" id="{19C3FF40-51F8-D7F6-73D2-D3A2B648F620}"/>
+                <a16:creationId xmlns:a16="http://schemas.microsoft.com/office/drawing/2014/main" id="{13F5849B-6382-35CE-2BF1-2C0A65E1B267}"/>
               </a:ext>
             </a:extLst>
           </p:cNvPr>
@@ -11773,7 +11773,7 @@
             <p:cNvPr id="28" name="Rectangle: Rounded Corners 27">
               <a:extLst>
                 <a:ext uri="{FF2B5EF4-FFF2-40B4-BE49-F238E27FC236}">
-                  <a16:creationId xmlns:a16="http://schemas.microsoft.com/office/drawing/2014/main" id="{B12B15AF-57A8-A9CA-AC30-B9EF33FE9981}"/>
+                  <a16:creationId xmlns:a16="http://schemas.microsoft.com/office/drawing/2014/main" id="{F6F3E4A1-B440-A05C-0870-46421BB7A71F}"/>
                 </a:ext>
               </a:extLst>
             </p:cNvPr>
@@ -11827,7 +11827,7 @@
             <p:cNvPr id="29" name="Rectangle: Rounded Corners 28">
               <a:extLst>
                 <a:ext uri="{FF2B5EF4-FFF2-40B4-BE49-F238E27FC236}">
-                  <a16:creationId xmlns:a16="http://schemas.microsoft.com/office/drawing/2014/main" id="{6986C629-B94E-4245-53A6-F45D72863A01}"/>
+                  <a16:creationId xmlns:a16="http://schemas.microsoft.com/office/drawing/2014/main" id="{9038C10B-FE55-ACB2-478F-3B6DEADCE15B}"/>
                 </a:ext>
               </a:extLst>
             </p:cNvPr>
@@ -11889,7 +11889,7 @@
             <p:cNvPr id="30" name="TextBox 29">
               <a:extLst>
                 <a:ext uri="{FF2B5EF4-FFF2-40B4-BE49-F238E27FC236}">
-                  <a16:creationId xmlns:a16="http://schemas.microsoft.com/office/drawing/2014/main" id="{5D55AAD6-8DEF-1231-CBA7-AF1D608E63C6}"/>
+                  <a16:creationId xmlns:a16="http://schemas.microsoft.com/office/drawing/2014/main" id="{820C50B2-19AA-41AE-1C19-ABC472DC6800}"/>
                 </a:ext>
               </a:extLst>
             </p:cNvPr>
@@ -11936,7 +11936,7 @@
           <p:cNvPr id="35" name="Group 34">
             <a:extLst>
               <a:ext uri="{FF2B5EF4-FFF2-40B4-BE49-F238E27FC236}">
-                <a16:creationId xmlns:a16="http://schemas.microsoft.com/office/drawing/2014/main" id="{34AC76CF-552B-4D32-1F85-3AA0A709C6FF}"/>
+                <a16:creationId xmlns:a16="http://schemas.microsoft.com/office/drawing/2014/main" id="{80273A81-C5FE-9D58-3996-036302F4C0B2}"/>
               </a:ext>
             </a:extLst>
           </p:cNvPr>
@@ -11956,7 +11956,7 @@
             <p:cNvPr id="32" name="Rectangle: Rounded Corners 31">
               <a:extLst>
                 <a:ext uri="{FF2B5EF4-FFF2-40B4-BE49-F238E27FC236}">
-                  <a16:creationId xmlns:a16="http://schemas.microsoft.com/office/drawing/2014/main" id="{1A17E8A2-7311-8194-4122-86E56E9B8B2A}"/>
+                  <a16:creationId xmlns:a16="http://schemas.microsoft.com/office/drawing/2014/main" id="{D0160553-751E-05C7-B377-708D7374BB5C}"/>
                 </a:ext>
               </a:extLst>
             </p:cNvPr>
@@ -12010,7 +12010,7 @@
             <p:cNvPr id="33" name="Rectangle: Rounded Corners 32">
               <a:extLst>
                 <a:ext uri="{FF2B5EF4-FFF2-40B4-BE49-F238E27FC236}">
-                  <a16:creationId xmlns:a16="http://schemas.microsoft.com/office/drawing/2014/main" id="{F87301FF-BAB2-6486-994D-90C5BD5D0101}"/>
+                  <a16:creationId xmlns:a16="http://schemas.microsoft.com/office/drawing/2014/main" id="{19B2F848-C0B7-E5CB-D53A-0DBB21988330}"/>
                 </a:ext>
               </a:extLst>
             </p:cNvPr>
@@ -12072,7 +12072,7 @@
             <p:cNvPr id="34" name="TextBox 33">
               <a:extLst>
                 <a:ext uri="{FF2B5EF4-FFF2-40B4-BE49-F238E27FC236}">
-                  <a16:creationId xmlns:a16="http://schemas.microsoft.com/office/drawing/2014/main" id="{9ECD1303-10C4-3CAB-235A-2F13FF779CBE}"/>
+                  <a16:creationId xmlns:a16="http://schemas.microsoft.com/office/drawing/2014/main" id="{800A3384-AFBA-FCCE-168C-AB3D9DC63B11}"/>
                 </a:ext>
               </a:extLst>
             </p:cNvPr>
@@ -12119,7 +12119,7 @@
           <p:cNvPr id="39" name="Group 38">
             <a:extLst>
               <a:ext uri="{FF2B5EF4-FFF2-40B4-BE49-F238E27FC236}">
-                <a16:creationId xmlns:a16="http://schemas.microsoft.com/office/drawing/2014/main" id="{A3A65C59-2145-0E15-2020-3F5FEB9EBBD5}"/>
+                <a16:creationId xmlns:a16="http://schemas.microsoft.com/office/drawing/2014/main" id="{9314935E-245B-6DF2-7E30-7B8DBCC77FDF}"/>
               </a:ext>
             </a:extLst>
           </p:cNvPr>
@@ -12139,7 +12139,7 @@
             <p:cNvPr id="36" name="Rectangle: Rounded Corners 35">
               <a:extLst>
                 <a:ext uri="{FF2B5EF4-FFF2-40B4-BE49-F238E27FC236}">
-                  <a16:creationId xmlns:a16="http://schemas.microsoft.com/office/drawing/2014/main" id="{9D4AB9B5-5D5D-4891-B741-103D4DEFE086}"/>
+                  <a16:creationId xmlns:a16="http://schemas.microsoft.com/office/drawing/2014/main" id="{06BFFAAF-7071-D2D7-7811-62AC85995AED}"/>
                 </a:ext>
               </a:extLst>
             </p:cNvPr>
@@ -12193,7 +12193,7 @@
             <p:cNvPr id="37" name="Rectangle: Rounded Corners 36">
               <a:extLst>
                 <a:ext uri="{FF2B5EF4-FFF2-40B4-BE49-F238E27FC236}">
-                  <a16:creationId xmlns:a16="http://schemas.microsoft.com/office/drawing/2014/main" id="{EAF17C17-1FAE-8E2E-9BA1-1CF52A033F00}"/>
+                  <a16:creationId xmlns:a16="http://schemas.microsoft.com/office/drawing/2014/main" id="{CF5FBA3F-A818-84AC-F213-A4AB962C66FA}"/>
                 </a:ext>
               </a:extLst>
             </p:cNvPr>
@@ -12255,7 +12255,7 @@
             <p:cNvPr id="38" name="TextBox 37">
               <a:extLst>
                 <a:ext uri="{FF2B5EF4-FFF2-40B4-BE49-F238E27FC236}">
-                  <a16:creationId xmlns:a16="http://schemas.microsoft.com/office/drawing/2014/main" id="{2F15F3B8-F18C-FDF1-AE19-68EA1F30D871}"/>
+                  <a16:creationId xmlns:a16="http://schemas.microsoft.com/office/drawing/2014/main" id="{FDA57425-C050-13DF-416C-D9F5846911F5}"/>
                 </a:ext>
               </a:extLst>
             </p:cNvPr>
@@ -12302,7 +12302,7 @@
           <p:cNvPr id="43" name="Group 42">
             <a:extLst>
               <a:ext uri="{FF2B5EF4-FFF2-40B4-BE49-F238E27FC236}">
-                <a16:creationId xmlns:a16="http://schemas.microsoft.com/office/drawing/2014/main" id="{3D8326BA-2A77-5A1B-AB17-2AC14C682F7C}"/>
+                <a16:creationId xmlns:a16="http://schemas.microsoft.com/office/drawing/2014/main" id="{8BBCD3C4-6D36-7D25-BC08-DC194B955F88}"/>
               </a:ext>
             </a:extLst>
           </p:cNvPr>
@@ -12322,7 +12322,7 @@
             <p:cNvPr id="40" name="Rectangle: Rounded Corners 39">
               <a:extLst>
                 <a:ext uri="{FF2B5EF4-FFF2-40B4-BE49-F238E27FC236}">
-                  <a16:creationId xmlns:a16="http://schemas.microsoft.com/office/drawing/2014/main" id="{17DD514A-D69E-A66D-E52A-387616F09A2E}"/>
+                  <a16:creationId xmlns:a16="http://schemas.microsoft.com/office/drawing/2014/main" id="{7F4AC41A-1DB1-8997-3D91-081A6990CF16}"/>
                 </a:ext>
               </a:extLst>
             </p:cNvPr>
@@ -12376,7 +12376,7 @@
             <p:cNvPr id="41" name="Rectangle: Rounded Corners 40">
               <a:extLst>
                 <a:ext uri="{FF2B5EF4-FFF2-40B4-BE49-F238E27FC236}">
-                  <a16:creationId xmlns:a16="http://schemas.microsoft.com/office/drawing/2014/main" id="{2FB427FF-D407-1534-0E0F-5F040EDE15A8}"/>
+                  <a16:creationId xmlns:a16="http://schemas.microsoft.com/office/drawing/2014/main" id="{E466B0AF-866E-0806-8DDD-1EDA9AAF06F6}"/>
                 </a:ext>
               </a:extLst>
             </p:cNvPr>
@@ -12438,7 +12438,7 @@
             <p:cNvPr id="42" name="TextBox 41">
               <a:extLst>
                 <a:ext uri="{FF2B5EF4-FFF2-40B4-BE49-F238E27FC236}">
-                  <a16:creationId xmlns:a16="http://schemas.microsoft.com/office/drawing/2014/main" id="{2765F25F-4E11-2F4C-2C73-2AA8C661F044}"/>
+                  <a16:creationId xmlns:a16="http://schemas.microsoft.com/office/drawing/2014/main" id="{45B60A22-282E-4E3C-3A0A-22D8F42839FA}"/>
                 </a:ext>
               </a:extLst>
             </p:cNvPr>
@@ -12485,7 +12485,7 @@
           <p:cNvPr id="47" name="Group 46">
             <a:extLst>
               <a:ext uri="{FF2B5EF4-FFF2-40B4-BE49-F238E27FC236}">
-                <a16:creationId xmlns:a16="http://schemas.microsoft.com/office/drawing/2014/main" id="{15A763F3-04D4-F6A8-EDCA-9D51AFF7CFF1}"/>
+                <a16:creationId xmlns:a16="http://schemas.microsoft.com/office/drawing/2014/main" id="{71A76C74-34DD-668F-2962-BA14BBFCCCC9}"/>
               </a:ext>
             </a:extLst>
           </p:cNvPr>
@@ -12505,7 +12505,7 @@
             <p:cNvPr id="44" name="Rectangle: Rounded Corners 43">
               <a:extLst>
                 <a:ext uri="{FF2B5EF4-FFF2-40B4-BE49-F238E27FC236}">
-                  <a16:creationId xmlns:a16="http://schemas.microsoft.com/office/drawing/2014/main" id="{43009195-C052-21F0-3B82-B8BE90E3CF7D}"/>
+                  <a16:creationId xmlns:a16="http://schemas.microsoft.com/office/drawing/2014/main" id="{0DED29B0-35B9-6372-3CF0-5B535DFB04C3}"/>
                 </a:ext>
               </a:extLst>
             </p:cNvPr>
@@ -12559,7 +12559,7 @@
             <p:cNvPr id="45" name="Rectangle: Rounded Corners 44">
               <a:extLst>
                 <a:ext uri="{FF2B5EF4-FFF2-40B4-BE49-F238E27FC236}">
-                  <a16:creationId xmlns:a16="http://schemas.microsoft.com/office/drawing/2014/main" id="{EB791BFE-8AE3-4EF4-8838-B37F1490106A}"/>
+                  <a16:creationId xmlns:a16="http://schemas.microsoft.com/office/drawing/2014/main" id="{78EAE0EE-0CD9-EDFF-8E3B-C1661445A35D}"/>
                 </a:ext>
               </a:extLst>
             </p:cNvPr>
@@ -12621,7 +12621,7 @@
             <p:cNvPr id="46" name="TextBox 45">
               <a:extLst>
                 <a:ext uri="{FF2B5EF4-FFF2-40B4-BE49-F238E27FC236}">
-                  <a16:creationId xmlns:a16="http://schemas.microsoft.com/office/drawing/2014/main" id="{49A93FEE-8DD8-0A6D-1862-102BBD7CAA95}"/>
+                  <a16:creationId xmlns:a16="http://schemas.microsoft.com/office/drawing/2014/main" id="{080EF220-BD9E-2E0A-B256-7D84E890D94D}"/>
                 </a:ext>
               </a:extLst>
             </p:cNvPr>
@@ -12668,7 +12668,7 @@
           <p:cNvPr id="48" name="Rectangle 47">
             <a:extLst>
               <a:ext uri="{FF2B5EF4-FFF2-40B4-BE49-F238E27FC236}">
-                <a16:creationId xmlns:a16="http://schemas.microsoft.com/office/drawing/2014/main" id="{D3C9B792-2BC8-C372-BA43-D1460962EC37}"/>
+                <a16:creationId xmlns:a16="http://schemas.microsoft.com/office/drawing/2014/main" id="{4EB57828-F516-7668-573B-9017E252DB75}"/>
               </a:ext>
             </a:extLst>
           </p:cNvPr>
@@ -12736,7 +12736,7 @@
           <p:cNvPr id="49" name="TextBox 48">
             <a:extLst>
               <a:ext uri="{FF2B5EF4-FFF2-40B4-BE49-F238E27FC236}">
-                <a16:creationId xmlns:a16="http://schemas.microsoft.com/office/drawing/2014/main" id="{46380DFC-C186-8887-A767-D3D2B9EBD179}"/>
+                <a16:creationId xmlns:a16="http://schemas.microsoft.com/office/drawing/2014/main" id="{AB03C0B9-97EE-7443-0E38-A03014B42EC7}"/>
               </a:ext>
             </a:extLst>
           </p:cNvPr>
@@ -12776,7 +12776,7 @@
           <p:cNvPr id="50" name="TextBox 49">
             <a:extLst>
               <a:ext uri="{FF2B5EF4-FFF2-40B4-BE49-F238E27FC236}">
-                <a16:creationId xmlns:a16="http://schemas.microsoft.com/office/drawing/2014/main" id="{8D7B20B7-B7F3-479E-DEF5-0F584DEF9572}"/>
+                <a16:creationId xmlns:a16="http://schemas.microsoft.com/office/drawing/2014/main" id="{EBB6295E-A707-75FD-DAD8-E5ACA9FE398F}"/>
               </a:ext>
             </a:extLst>
           </p:cNvPr>
@@ -12817,7 +12817,7 @@
           <p:cNvPr id="51" name="TextBox 50">
             <a:extLst>
               <a:ext uri="{FF2B5EF4-FFF2-40B4-BE49-F238E27FC236}">
-                <a16:creationId xmlns:a16="http://schemas.microsoft.com/office/drawing/2014/main" id="{52A072D7-E828-A3DD-E00F-BFE15395B3EF}"/>
+                <a16:creationId xmlns:a16="http://schemas.microsoft.com/office/drawing/2014/main" id="{5AE5F62B-302D-3929-EB39-89107A2395C6}"/>
               </a:ext>
             </a:extLst>
           </p:cNvPr>
@@ -12856,7 +12856,7 @@
     </p:spTree>
     <p:extLst>
       <p:ext uri="{BB962C8B-B14F-4D97-AF65-F5344CB8AC3E}">
-        <p14:creationId xmlns:p14="http://schemas.microsoft.com/office/powerpoint/2010/main" val="3863621763"/>
+        <p14:creationId xmlns:p14="http://schemas.microsoft.com/office/powerpoint/2010/main" val="2064542537"/>
       </p:ext>
     </p:extLst>
   </p:cSld>
@@ -13244,7 +13244,7 @@
           <p:cNvPr id="2" name="Rectangle 1">
             <a:extLst>
               <a:ext uri="{FF2B5EF4-FFF2-40B4-BE49-F238E27FC236}">
-                <a16:creationId xmlns:a16="http://schemas.microsoft.com/office/drawing/2014/main" id="{1F6133E1-5FB1-40E8-9BA8-CE90ADF863E9}"/>
+                <a16:creationId xmlns:a16="http://schemas.microsoft.com/office/drawing/2014/main" id="{244355DE-0B91-8D5A-2702-B4E8D896F081}"/>
               </a:ext>
             </a:extLst>
           </p:cNvPr>
@@ -13312,7 +13312,7 @@
           <p:cNvPr id="3" name="Rectangle: Rounded Corners 2">
             <a:extLst>
               <a:ext uri="{FF2B5EF4-FFF2-40B4-BE49-F238E27FC236}">
-                <a16:creationId xmlns:a16="http://schemas.microsoft.com/office/drawing/2014/main" id="{3E56D48F-B636-2982-5E6E-410F1E228183}"/>
+                <a16:creationId xmlns:a16="http://schemas.microsoft.com/office/drawing/2014/main" id="{54D37F48-E890-E37E-DC2B-015521C7F3BD}"/>
               </a:ext>
             </a:extLst>
           </p:cNvPr>
@@ -13366,7 +13366,7 @@
           <p:cNvPr id="4" name="Rectangle: Rounded Corners 3">
             <a:extLst>
               <a:ext uri="{FF2B5EF4-FFF2-40B4-BE49-F238E27FC236}">
-                <a16:creationId xmlns:a16="http://schemas.microsoft.com/office/drawing/2014/main" id="{8091F2F2-ABC6-6D8F-61D5-21F5F2CA96A8}"/>
+                <a16:creationId xmlns:a16="http://schemas.microsoft.com/office/drawing/2014/main" id="{CC7E65C6-F65F-7BAC-EEDB-A7B5D80FA686}"/>
               </a:ext>
             </a:extLst>
           </p:cNvPr>
@@ -13417,7 +13417,7 @@
           <p:cNvPr id="5" name="TextBox 4">
             <a:extLst>
               <a:ext uri="{FF2B5EF4-FFF2-40B4-BE49-F238E27FC236}">
-                <a16:creationId xmlns:a16="http://schemas.microsoft.com/office/drawing/2014/main" id="{3FF82585-3B83-AE73-F281-E66FBD46D118}"/>
+                <a16:creationId xmlns:a16="http://schemas.microsoft.com/office/drawing/2014/main" id="{91742AF6-8F26-5F6E-3D85-5AF36F444906}"/>
               </a:ext>
             </a:extLst>
           </p:cNvPr>
@@ -13457,7 +13457,7 @@
           <p:cNvPr id="6" name="TextBox 5">
             <a:extLst>
               <a:ext uri="{FF2B5EF4-FFF2-40B4-BE49-F238E27FC236}">
-                <a16:creationId xmlns:a16="http://schemas.microsoft.com/office/drawing/2014/main" id="{B4F878F1-CACD-FDB7-6292-3EAFBA935A13}"/>
+                <a16:creationId xmlns:a16="http://schemas.microsoft.com/office/drawing/2014/main" id="{A87B8E5C-86C0-5ECF-8155-7D4858E96383}"/>
               </a:ext>
             </a:extLst>
           </p:cNvPr>
@@ -13497,7 +13497,7 @@
           <p:cNvPr id="7" name="TextBox 6">
             <a:extLst>
               <a:ext uri="{FF2B5EF4-FFF2-40B4-BE49-F238E27FC236}">
-                <a16:creationId xmlns:a16="http://schemas.microsoft.com/office/drawing/2014/main" id="{7A18DA60-9273-BA36-C539-8F98E6F24DE9}"/>
+                <a16:creationId xmlns:a16="http://schemas.microsoft.com/office/drawing/2014/main" id="{9A1B2DD3-00BF-BD85-6101-DCAE0428E5D4}"/>
               </a:ext>
             </a:extLst>
           </p:cNvPr>
@@ -13537,7 +13537,7 @@
           <p:cNvPr id="8" name="TextBox 7">
             <a:extLst>
               <a:ext uri="{FF2B5EF4-FFF2-40B4-BE49-F238E27FC236}">
-                <a16:creationId xmlns:a16="http://schemas.microsoft.com/office/drawing/2014/main" id="{2A108EF4-4DAB-8580-52AE-8A803B7C3F7E}"/>
+                <a16:creationId xmlns:a16="http://schemas.microsoft.com/office/drawing/2014/main" id="{7C61CE85-C239-BED1-4AC9-D4B1E0731AA6}"/>
               </a:ext>
             </a:extLst>
           </p:cNvPr>
@@ -13577,7 +13577,7 @@
           <p:cNvPr id="9" name="TextBox 8">
             <a:extLst>
               <a:ext uri="{FF2B5EF4-FFF2-40B4-BE49-F238E27FC236}">
-                <a16:creationId xmlns:a16="http://schemas.microsoft.com/office/drawing/2014/main" id="{F673AD69-84D6-726C-C928-93026426D64A}"/>
+                <a16:creationId xmlns:a16="http://schemas.microsoft.com/office/drawing/2014/main" id="{9F9FC869-2E13-4432-0CC8-297F2B90C403}"/>
               </a:ext>
             </a:extLst>
           </p:cNvPr>
@@ -13623,7 +13623,7 @@
           <p:cNvPr id="10" name="Rectangle: Rounded Corners 9">
             <a:extLst>
               <a:ext uri="{FF2B5EF4-FFF2-40B4-BE49-F238E27FC236}">
-                <a16:creationId xmlns:a16="http://schemas.microsoft.com/office/drawing/2014/main" id="{4E90CD39-BF27-636F-ED15-EE214CCAA809}"/>
+                <a16:creationId xmlns:a16="http://schemas.microsoft.com/office/drawing/2014/main" id="{879FD501-BFC9-71AD-ECBA-8ACDB8680490}"/>
               </a:ext>
             </a:extLst>
           </p:cNvPr>
@@ -13685,7 +13685,7 @@
           <p:cNvPr id="11" name="TextBox 10">
             <a:extLst>
               <a:ext uri="{FF2B5EF4-FFF2-40B4-BE49-F238E27FC236}">
-                <a16:creationId xmlns:a16="http://schemas.microsoft.com/office/drawing/2014/main" id="{33465D47-5E4C-909E-ECB5-9813A70666EF}"/>
+                <a16:creationId xmlns:a16="http://schemas.microsoft.com/office/drawing/2014/main" id="{057C4049-EF04-6BC5-5C3F-DCE337A30265}"/>
               </a:ext>
             </a:extLst>
           </p:cNvPr>
@@ -13731,7 +13731,7 @@
           <p:cNvPr id="12" name="Rectangle 11">
             <a:extLst>
               <a:ext uri="{FF2B5EF4-FFF2-40B4-BE49-F238E27FC236}">
-                <a16:creationId xmlns:a16="http://schemas.microsoft.com/office/drawing/2014/main" id="{D82645C8-E1F6-9217-88AF-19C8D6C9BF87}"/>
+                <a16:creationId xmlns:a16="http://schemas.microsoft.com/office/drawing/2014/main" id="{DAF3AA12-6D5D-B9FC-6356-75265D49BC33}"/>
               </a:ext>
             </a:extLst>
           </p:cNvPr>
@@ -13799,7 +13799,7 @@
           <p:cNvPr id="13" name="TextBox 12">
             <a:extLst>
               <a:ext uri="{FF2B5EF4-FFF2-40B4-BE49-F238E27FC236}">
-                <a16:creationId xmlns:a16="http://schemas.microsoft.com/office/drawing/2014/main" id="{B33FCFA4-C24C-3DF0-9B24-D81A25CFE95C}"/>
+                <a16:creationId xmlns:a16="http://schemas.microsoft.com/office/drawing/2014/main" id="{35999C84-3D18-C110-DF29-8BDC45114FE3}"/>
               </a:ext>
             </a:extLst>
           </p:cNvPr>
@@ -13845,7 +13845,7 @@
           <p:cNvPr id="14" name="Rectangle: Rounded Corners 13">
             <a:extLst>
               <a:ext uri="{FF2B5EF4-FFF2-40B4-BE49-F238E27FC236}">
-                <a16:creationId xmlns:a16="http://schemas.microsoft.com/office/drawing/2014/main" id="{39A2CE5E-2350-014C-EB8D-15E2A92D7864}"/>
+                <a16:creationId xmlns:a16="http://schemas.microsoft.com/office/drawing/2014/main" id="{2E71D4D7-40B3-905C-4D6A-7BF272E8D4FF}"/>
               </a:ext>
             </a:extLst>
           </p:cNvPr>
@@ -13899,7 +13899,7 @@
           <p:cNvPr id="15" name="Pentagon 14">
             <a:extLst>
               <a:ext uri="{FF2B5EF4-FFF2-40B4-BE49-F238E27FC236}">
-                <a16:creationId xmlns:a16="http://schemas.microsoft.com/office/drawing/2014/main" id="{A98773C1-0BAF-813B-343F-46AA1D5C3A66}"/>
+                <a16:creationId xmlns:a16="http://schemas.microsoft.com/office/drawing/2014/main" id="{9B46D1DF-FA6D-83A9-19E3-D70D74272E17}"/>
               </a:ext>
             </a:extLst>
           </p:cNvPr>
@@ -13953,7 +13953,7 @@
           <p:cNvPr id="16" name="Pentagon 15">
             <a:extLst>
               <a:ext uri="{FF2B5EF4-FFF2-40B4-BE49-F238E27FC236}">
-                <a16:creationId xmlns:a16="http://schemas.microsoft.com/office/drawing/2014/main" id="{9D273440-7F74-E427-7CB6-6BEE18E70F64}"/>
+                <a16:creationId xmlns:a16="http://schemas.microsoft.com/office/drawing/2014/main" id="{DB2BF415-74E4-3700-6163-68F59BE0105A}"/>
               </a:ext>
             </a:extLst>
           </p:cNvPr>
@@ -14007,7 +14007,7 @@
           <p:cNvPr id="17" name="Pentagon 16">
             <a:extLst>
               <a:ext uri="{FF2B5EF4-FFF2-40B4-BE49-F238E27FC236}">
-                <a16:creationId xmlns:a16="http://schemas.microsoft.com/office/drawing/2014/main" id="{70BD3DAD-75B4-02E9-2BB9-33E9CFEBD05D}"/>
+                <a16:creationId xmlns:a16="http://schemas.microsoft.com/office/drawing/2014/main" id="{8707DA61-9A02-D593-43B8-7A37E275B948}"/>
               </a:ext>
             </a:extLst>
           </p:cNvPr>
@@ -14061,7 +14061,7 @@
           <p:cNvPr id="18" name="Pentagon 17">
             <a:extLst>
               <a:ext uri="{FF2B5EF4-FFF2-40B4-BE49-F238E27FC236}">
-                <a16:creationId xmlns:a16="http://schemas.microsoft.com/office/drawing/2014/main" id="{D60D3B36-AC37-F693-54C0-5DAB5D8FDDAC}"/>
+                <a16:creationId xmlns:a16="http://schemas.microsoft.com/office/drawing/2014/main" id="{1207F423-F47A-9533-FE4C-A3AB914D4341}"/>
               </a:ext>
             </a:extLst>
           </p:cNvPr>
@@ -14115,7 +14115,7 @@
           <p:cNvPr id="20" name="Picture 19">
             <a:extLst>
               <a:ext uri="{FF2B5EF4-FFF2-40B4-BE49-F238E27FC236}">
-                <a16:creationId xmlns:a16="http://schemas.microsoft.com/office/drawing/2014/main" id="{6685B78E-59C1-704B-A8B1-D427226A7637}"/>
+                <a16:creationId xmlns:a16="http://schemas.microsoft.com/office/drawing/2014/main" id="{4050F903-F3C2-E1CE-3B97-80C2EEE4D3C0}"/>
               </a:ext>
             </a:extLst>
           </p:cNvPr>
@@ -14151,7 +14151,7 @@
           <p:cNvPr id="21" name="Rectangle: Rounded Corners 20">
             <a:extLst>
               <a:ext uri="{FF2B5EF4-FFF2-40B4-BE49-F238E27FC236}">
-                <a16:creationId xmlns:a16="http://schemas.microsoft.com/office/drawing/2014/main" id="{F3EA4210-8FA5-E4A5-C031-3A563554BDB1}"/>
+                <a16:creationId xmlns:a16="http://schemas.microsoft.com/office/drawing/2014/main" id="{29479A3A-41E3-5AC7-6686-14A7076BAF9E}"/>
               </a:ext>
             </a:extLst>
           </p:cNvPr>
@@ -14213,7 +14213,7 @@
           <p:cNvPr id="22" name="TextBox 21">
             <a:extLst>
               <a:ext uri="{FF2B5EF4-FFF2-40B4-BE49-F238E27FC236}">
-                <a16:creationId xmlns:a16="http://schemas.microsoft.com/office/drawing/2014/main" id="{446669A7-314E-7BA5-E10F-0A8C1469EC55}"/>
+                <a16:creationId xmlns:a16="http://schemas.microsoft.com/office/drawing/2014/main" id="{6CA88154-FF99-AD9B-8A39-0E07356A4439}"/>
               </a:ext>
             </a:extLst>
           </p:cNvPr>
@@ -14259,7 +14259,7 @@
           <p:cNvPr id="23" name="Rectangle: Rounded Corners 22">
             <a:extLst>
               <a:ext uri="{FF2B5EF4-FFF2-40B4-BE49-F238E27FC236}">
-                <a16:creationId xmlns:a16="http://schemas.microsoft.com/office/drawing/2014/main" id="{61B575DD-B0DB-7AAB-1A02-A734BD2B65E4}"/>
+                <a16:creationId xmlns:a16="http://schemas.microsoft.com/office/drawing/2014/main" id="{E8203B07-2DC8-4D21-74DB-BC0D1817045C}"/>
               </a:ext>
             </a:extLst>
           </p:cNvPr>
@@ -14337,7 +14337,7 @@
           <p:cNvPr id="27" name="Group 26">
             <a:extLst>
               <a:ext uri="{FF2B5EF4-FFF2-40B4-BE49-F238E27FC236}">
-                <a16:creationId xmlns:a16="http://schemas.microsoft.com/office/drawing/2014/main" id="{5030CD96-600B-3730-29E3-ACBEDFFE0218}"/>
+                <a16:creationId xmlns:a16="http://schemas.microsoft.com/office/drawing/2014/main" id="{78268EDE-6577-C43A-8A15-DD2BB6CD1FEC}"/>
               </a:ext>
             </a:extLst>
           </p:cNvPr>
@@ -14357,7 +14357,7 @@
             <p:cNvPr id="24" name="Rectangle: Rounded Corners 23">
               <a:extLst>
                 <a:ext uri="{FF2B5EF4-FFF2-40B4-BE49-F238E27FC236}">
-                  <a16:creationId xmlns:a16="http://schemas.microsoft.com/office/drawing/2014/main" id="{AF2CDD60-356D-12EA-BEE2-9EC17519548F}"/>
+                  <a16:creationId xmlns:a16="http://schemas.microsoft.com/office/drawing/2014/main" id="{E5768515-C9CB-7D23-2216-491F0A6E4FF7}"/>
                 </a:ext>
               </a:extLst>
             </p:cNvPr>
@@ -14411,7 +14411,7 @@
             <p:cNvPr id="25" name="Rectangle: Rounded Corners 24">
               <a:extLst>
                 <a:ext uri="{FF2B5EF4-FFF2-40B4-BE49-F238E27FC236}">
-                  <a16:creationId xmlns:a16="http://schemas.microsoft.com/office/drawing/2014/main" id="{4BE25EAE-2EE6-ABDF-2EE7-6068DE508A3E}"/>
+                  <a16:creationId xmlns:a16="http://schemas.microsoft.com/office/drawing/2014/main" id="{C115066C-42BF-257B-71F5-59CF34CD5E51}"/>
                 </a:ext>
               </a:extLst>
             </p:cNvPr>
@@ -14473,7 +14473,7 @@
             <p:cNvPr id="26" name="TextBox 25">
               <a:extLst>
                 <a:ext uri="{FF2B5EF4-FFF2-40B4-BE49-F238E27FC236}">
-                  <a16:creationId xmlns:a16="http://schemas.microsoft.com/office/drawing/2014/main" id="{0E8DD59C-D050-991C-22EA-F4D92E7248CE}"/>
+                  <a16:creationId xmlns:a16="http://schemas.microsoft.com/office/drawing/2014/main" id="{219FE2B9-52C0-D419-0D0E-CABE20B6A4FE}"/>
                 </a:ext>
               </a:extLst>
             </p:cNvPr>
@@ -14520,7 +14520,7 @@
           <p:cNvPr id="31" name="Group 30">
             <a:extLst>
               <a:ext uri="{FF2B5EF4-FFF2-40B4-BE49-F238E27FC236}">
-                <a16:creationId xmlns:a16="http://schemas.microsoft.com/office/drawing/2014/main" id="{A9A894A3-35A2-D81E-3ED9-733443AAC708}"/>
+                <a16:creationId xmlns:a16="http://schemas.microsoft.com/office/drawing/2014/main" id="{B02D3CAC-0FAA-BA93-4C15-E1FB8E99E26A}"/>
               </a:ext>
             </a:extLst>
           </p:cNvPr>
@@ -14540,7 +14540,7 @@
             <p:cNvPr id="28" name="Rectangle: Rounded Corners 27">
               <a:extLst>
                 <a:ext uri="{FF2B5EF4-FFF2-40B4-BE49-F238E27FC236}">
-                  <a16:creationId xmlns:a16="http://schemas.microsoft.com/office/drawing/2014/main" id="{C9D4155C-8778-DFCD-7E6D-D2F416933C2F}"/>
+                  <a16:creationId xmlns:a16="http://schemas.microsoft.com/office/drawing/2014/main" id="{E7A322E0-BD34-3272-0ABF-D5CD7CEF2A28}"/>
                 </a:ext>
               </a:extLst>
             </p:cNvPr>
@@ -14594,7 +14594,7 @@
             <p:cNvPr id="29" name="Rectangle: Rounded Corners 28">
               <a:extLst>
                 <a:ext uri="{FF2B5EF4-FFF2-40B4-BE49-F238E27FC236}">
-                  <a16:creationId xmlns:a16="http://schemas.microsoft.com/office/drawing/2014/main" id="{74646672-0CD3-2225-FC9B-2C9C6DB7DF33}"/>
+                  <a16:creationId xmlns:a16="http://schemas.microsoft.com/office/drawing/2014/main" id="{7E38292E-3542-75E6-62A7-98B4AA717185}"/>
                 </a:ext>
               </a:extLst>
             </p:cNvPr>
@@ -14656,7 +14656,7 @@
             <p:cNvPr id="30" name="TextBox 29">
               <a:extLst>
                 <a:ext uri="{FF2B5EF4-FFF2-40B4-BE49-F238E27FC236}">
-                  <a16:creationId xmlns:a16="http://schemas.microsoft.com/office/drawing/2014/main" id="{D48EB11A-82DC-FA54-4264-49A042B715EA}"/>
+                  <a16:creationId xmlns:a16="http://schemas.microsoft.com/office/drawing/2014/main" id="{27C73C27-2A31-5F4E-2F21-7F57706060CF}"/>
                 </a:ext>
               </a:extLst>
             </p:cNvPr>
@@ -14703,7 +14703,7 @@
           <p:cNvPr id="35" name="Group 34">
             <a:extLst>
               <a:ext uri="{FF2B5EF4-FFF2-40B4-BE49-F238E27FC236}">
-                <a16:creationId xmlns:a16="http://schemas.microsoft.com/office/drawing/2014/main" id="{E0931437-5B82-1608-2310-DD490763F24E}"/>
+                <a16:creationId xmlns:a16="http://schemas.microsoft.com/office/drawing/2014/main" id="{A42BDA3F-61D0-379E-35BC-E58EF2054066}"/>
               </a:ext>
             </a:extLst>
           </p:cNvPr>
@@ -14723,7 +14723,7 @@
             <p:cNvPr id="32" name="Rectangle: Rounded Corners 31">
               <a:extLst>
                 <a:ext uri="{FF2B5EF4-FFF2-40B4-BE49-F238E27FC236}">
-                  <a16:creationId xmlns:a16="http://schemas.microsoft.com/office/drawing/2014/main" id="{51A7D4D8-8C32-0D15-72B1-0AA1357CCBC3}"/>
+                  <a16:creationId xmlns:a16="http://schemas.microsoft.com/office/drawing/2014/main" id="{4E0FEA3E-9C4C-4938-2DB4-D91E8D7B3EDF}"/>
                 </a:ext>
               </a:extLst>
             </p:cNvPr>
@@ -14777,7 +14777,7 @@
             <p:cNvPr id="33" name="Rectangle: Rounded Corners 32">
               <a:extLst>
                 <a:ext uri="{FF2B5EF4-FFF2-40B4-BE49-F238E27FC236}">
-                  <a16:creationId xmlns:a16="http://schemas.microsoft.com/office/drawing/2014/main" id="{2E54D85A-3BAE-838C-0E46-2AE945DCA1BD}"/>
+                  <a16:creationId xmlns:a16="http://schemas.microsoft.com/office/drawing/2014/main" id="{A6562B9C-F0D2-9DEA-DAD9-FF9F994DDF76}"/>
                 </a:ext>
               </a:extLst>
             </p:cNvPr>
@@ -14839,7 +14839,7 @@
             <p:cNvPr id="34" name="TextBox 33">
               <a:extLst>
                 <a:ext uri="{FF2B5EF4-FFF2-40B4-BE49-F238E27FC236}">
-                  <a16:creationId xmlns:a16="http://schemas.microsoft.com/office/drawing/2014/main" id="{B909A0D2-64DA-BE1B-1277-95FDBCB28C29}"/>
+                  <a16:creationId xmlns:a16="http://schemas.microsoft.com/office/drawing/2014/main" id="{FC9D7306-C6E3-6AE1-10AE-067D5B412721}"/>
                 </a:ext>
               </a:extLst>
             </p:cNvPr>
@@ -14886,7 +14886,7 @@
           <p:cNvPr id="39" name="Group 38">
             <a:extLst>
               <a:ext uri="{FF2B5EF4-FFF2-40B4-BE49-F238E27FC236}">
-                <a16:creationId xmlns:a16="http://schemas.microsoft.com/office/drawing/2014/main" id="{9CB7D8BE-CEC9-5E23-051A-65E391A64A4F}"/>
+                <a16:creationId xmlns:a16="http://schemas.microsoft.com/office/drawing/2014/main" id="{B275647D-2A52-C3CE-52AF-08B7C8E6399C}"/>
               </a:ext>
             </a:extLst>
           </p:cNvPr>
@@ -14906,7 +14906,7 @@
             <p:cNvPr id="36" name="Rectangle: Rounded Corners 35">
               <a:extLst>
                 <a:ext uri="{FF2B5EF4-FFF2-40B4-BE49-F238E27FC236}">
-                  <a16:creationId xmlns:a16="http://schemas.microsoft.com/office/drawing/2014/main" id="{D93EA6AB-44A5-8FDC-B223-F395EB32487E}"/>
+                  <a16:creationId xmlns:a16="http://schemas.microsoft.com/office/drawing/2014/main" id="{9F5878B9-1272-47AB-4C64-50B660C6767D}"/>
                 </a:ext>
               </a:extLst>
             </p:cNvPr>
@@ -14960,7 +14960,7 @@
             <p:cNvPr id="37" name="Rectangle: Rounded Corners 36">
               <a:extLst>
                 <a:ext uri="{FF2B5EF4-FFF2-40B4-BE49-F238E27FC236}">
-                  <a16:creationId xmlns:a16="http://schemas.microsoft.com/office/drawing/2014/main" id="{DB7AAAD3-4F49-A2EF-694B-E5BF15AE2801}"/>
+                  <a16:creationId xmlns:a16="http://schemas.microsoft.com/office/drawing/2014/main" id="{49AB8E86-13A2-F695-5D3A-82A0F38EC0BF}"/>
                 </a:ext>
               </a:extLst>
             </p:cNvPr>
@@ -15022,7 +15022,7 @@
             <p:cNvPr id="38" name="TextBox 37">
               <a:extLst>
                 <a:ext uri="{FF2B5EF4-FFF2-40B4-BE49-F238E27FC236}">
-                  <a16:creationId xmlns:a16="http://schemas.microsoft.com/office/drawing/2014/main" id="{72E5CAB1-DCD5-FEE0-E456-C3F6DE6B61F1}"/>
+                  <a16:creationId xmlns:a16="http://schemas.microsoft.com/office/drawing/2014/main" id="{9B615C0D-FF5A-BCAB-7E52-FCFA564542D6}"/>
                 </a:ext>
               </a:extLst>
             </p:cNvPr>
@@ -15069,7 +15069,7 @@
           <p:cNvPr id="43" name="Group 42">
             <a:extLst>
               <a:ext uri="{FF2B5EF4-FFF2-40B4-BE49-F238E27FC236}">
-                <a16:creationId xmlns:a16="http://schemas.microsoft.com/office/drawing/2014/main" id="{17742980-8BFE-047C-95B7-9300319FA63D}"/>
+                <a16:creationId xmlns:a16="http://schemas.microsoft.com/office/drawing/2014/main" id="{B16DC92F-C62D-CF39-F77B-8F98E0BCEDCF}"/>
               </a:ext>
             </a:extLst>
           </p:cNvPr>
@@ -15089,7 +15089,7 @@
             <p:cNvPr id="40" name="Rectangle: Rounded Corners 39">
               <a:extLst>
                 <a:ext uri="{FF2B5EF4-FFF2-40B4-BE49-F238E27FC236}">
-                  <a16:creationId xmlns:a16="http://schemas.microsoft.com/office/drawing/2014/main" id="{F8B03BA9-40A8-18FA-4BA5-D0765A48D228}"/>
+                  <a16:creationId xmlns:a16="http://schemas.microsoft.com/office/drawing/2014/main" id="{58910B88-0D0F-496C-FF32-E68C55FA1D74}"/>
                 </a:ext>
               </a:extLst>
             </p:cNvPr>
@@ -15143,7 +15143,7 @@
             <p:cNvPr id="41" name="Rectangle: Rounded Corners 40">
               <a:extLst>
                 <a:ext uri="{FF2B5EF4-FFF2-40B4-BE49-F238E27FC236}">
-                  <a16:creationId xmlns:a16="http://schemas.microsoft.com/office/drawing/2014/main" id="{66B67CD1-BA2E-42EC-B700-A1F407F4C84B}"/>
+                  <a16:creationId xmlns:a16="http://schemas.microsoft.com/office/drawing/2014/main" id="{2BA3CA7A-2D4D-29E3-8547-F00F3A2CA185}"/>
                 </a:ext>
               </a:extLst>
             </p:cNvPr>
@@ -15205,7 +15205,7 @@
             <p:cNvPr id="42" name="TextBox 41">
               <a:extLst>
                 <a:ext uri="{FF2B5EF4-FFF2-40B4-BE49-F238E27FC236}">
-                  <a16:creationId xmlns:a16="http://schemas.microsoft.com/office/drawing/2014/main" id="{18E9D315-C19D-2D83-53B0-5656DAEB6D40}"/>
+                  <a16:creationId xmlns:a16="http://schemas.microsoft.com/office/drawing/2014/main" id="{47852EDE-D235-E80B-7B67-E9C7631D2393}"/>
                 </a:ext>
               </a:extLst>
             </p:cNvPr>
@@ -15252,7 +15252,7 @@
           <p:cNvPr id="47" name="Group 46">
             <a:extLst>
               <a:ext uri="{FF2B5EF4-FFF2-40B4-BE49-F238E27FC236}">
-                <a16:creationId xmlns:a16="http://schemas.microsoft.com/office/drawing/2014/main" id="{9A07DB0B-22E0-AF4C-B04F-7E52D0651B6C}"/>
+                <a16:creationId xmlns:a16="http://schemas.microsoft.com/office/drawing/2014/main" id="{D8DE7A6C-CFA4-9C46-6FD2-27A3F8FE3586}"/>
               </a:ext>
             </a:extLst>
           </p:cNvPr>
@@ -15272,7 +15272,7 @@
             <p:cNvPr id="44" name="Rectangle: Rounded Corners 43">
               <a:extLst>
                 <a:ext uri="{FF2B5EF4-FFF2-40B4-BE49-F238E27FC236}">
-                  <a16:creationId xmlns:a16="http://schemas.microsoft.com/office/drawing/2014/main" id="{DFACE95B-1A63-3D1F-7664-F573FE4F9B04}"/>
+                  <a16:creationId xmlns:a16="http://schemas.microsoft.com/office/drawing/2014/main" id="{AB1D11D1-1746-E9FB-BE06-8AD44904BBB2}"/>
                 </a:ext>
               </a:extLst>
             </p:cNvPr>
@@ -15326,7 +15326,7 @@
             <p:cNvPr id="45" name="Rectangle: Rounded Corners 44">
               <a:extLst>
                 <a:ext uri="{FF2B5EF4-FFF2-40B4-BE49-F238E27FC236}">
-                  <a16:creationId xmlns:a16="http://schemas.microsoft.com/office/drawing/2014/main" id="{2A978827-9E83-7472-3AB6-ED12136746B2}"/>
+                  <a16:creationId xmlns:a16="http://schemas.microsoft.com/office/drawing/2014/main" id="{0EA2514A-0105-350E-4A71-FC7F1AF46105}"/>
                 </a:ext>
               </a:extLst>
             </p:cNvPr>
@@ -15388,7 +15388,7 @@
             <p:cNvPr id="46" name="TextBox 45">
               <a:extLst>
                 <a:ext uri="{FF2B5EF4-FFF2-40B4-BE49-F238E27FC236}">
-                  <a16:creationId xmlns:a16="http://schemas.microsoft.com/office/drawing/2014/main" id="{76FA9F99-F090-15D9-9847-4B1EFF2F4537}"/>
+                  <a16:creationId xmlns:a16="http://schemas.microsoft.com/office/drawing/2014/main" id="{8B77475D-39A0-AF52-DCA7-C87A3849F6CC}"/>
                 </a:ext>
               </a:extLst>
             </p:cNvPr>
@@ -15435,7 +15435,7 @@
           <p:cNvPr id="48" name="Rectangle 47">
             <a:extLst>
               <a:ext uri="{FF2B5EF4-FFF2-40B4-BE49-F238E27FC236}">
-                <a16:creationId xmlns:a16="http://schemas.microsoft.com/office/drawing/2014/main" id="{5F6F5EE7-8008-95FA-D665-D28011AC0975}"/>
+                <a16:creationId xmlns:a16="http://schemas.microsoft.com/office/drawing/2014/main" id="{D3ADFF94-38CD-BEC8-7BA1-98D4CB295AA3}"/>
               </a:ext>
             </a:extLst>
           </p:cNvPr>
@@ -15503,7 +15503,7 @@
           <p:cNvPr id="49" name="TextBox 48">
             <a:extLst>
               <a:ext uri="{FF2B5EF4-FFF2-40B4-BE49-F238E27FC236}">
-                <a16:creationId xmlns:a16="http://schemas.microsoft.com/office/drawing/2014/main" id="{67D936CB-6203-0404-B5FA-4B5952F5CF8C}"/>
+                <a16:creationId xmlns:a16="http://schemas.microsoft.com/office/drawing/2014/main" id="{1A0FB4C9-9881-4F1B-8908-0E3CE8EEC6FA}"/>
               </a:ext>
             </a:extLst>
           </p:cNvPr>
@@ -15543,7 +15543,7 @@
           <p:cNvPr id="50" name="TextBox 49">
             <a:extLst>
               <a:ext uri="{FF2B5EF4-FFF2-40B4-BE49-F238E27FC236}">
-                <a16:creationId xmlns:a16="http://schemas.microsoft.com/office/drawing/2014/main" id="{7820037E-28C8-B058-DAFA-B39D1859ACAB}"/>
+                <a16:creationId xmlns:a16="http://schemas.microsoft.com/office/drawing/2014/main" id="{58FDC475-FA89-B07B-6B95-17E67088BF01}"/>
               </a:ext>
             </a:extLst>
           </p:cNvPr>
@@ -15584,7 +15584,7 @@
           <p:cNvPr id="51" name="TextBox 50">
             <a:extLst>
               <a:ext uri="{FF2B5EF4-FFF2-40B4-BE49-F238E27FC236}">
-                <a16:creationId xmlns:a16="http://schemas.microsoft.com/office/drawing/2014/main" id="{1CDF002C-452A-B987-2B23-9072FE4EDF77}"/>
+                <a16:creationId xmlns:a16="http://schemas.microsoft.com/office/drawing/2014/main" id="{2852FE8F-34A7-259F-421A-F4DC91FA3A8E}"/>
               </a:ext>
             </a:extLst>
           </p:cNvPr>
@@ -15623,7 +15623,7 @@
     </p:spTree>
     <p:extLst>
       <p:ext uri="{BB962C8B-B14F-4D97-AF65-F5344CB8AC3E}">
-        <p14:creationId xmlns:p14="http://schemas.microsoft.com/office/powerpoint/2010/main" val="3853165677"/>
+        <p14:creationId xmlns:p14="http://schemas.microsoft.com/office/powerpoint/2010/main" val="1913393397"/>
       </p:ext>
     </p:extLst>
   </p:cSld>
@@ -16011,7 +16011,7 @@
           <p:cNvPr id="2" name="Rectangle 1">
             <a:extLst>
               <a:ext uri="{FF2B5EF4-FFF2-40B4-BE49-F238E27FC236}">
-                <a16:creationId xmlns:a16="http://schemas.microsoft.com/office/drawing/2014/main" id="{3D0A26E1-8C2D-9210-9225-7A00DF7DC24C}"/>
+                <a16:creationId xmlns:a16="http://schemas.microsoft.com/office/drawing/2014/main" id="{7AB130D0-5A61-AAA4-996D-EBA31FB62829}"/>
               </a:ext>
             </a:extLst>
           </p:cNvPr>
@@ -16079,7 +16079,7 @@
           <p:cNvPr id="3" name="Rectangle: Rounded Corners 2">
             <a:extLst>
               <a:ext uri="{FF2B5EF4-FFF2-40B4-BE49-F238E27FC236}">
-                <a16:creationId xmlns:a16="http://schemas.microsoft.com/office/drawing/2014/main" id="{0BD41F97-2901-C59D-D694-D7EB80B89CE1}"/>
+                <a16:creationId xmlns:a16="http://schemas.microsoft.com/office/drawing/2014/main" id="{D5267CC2-2000-2F1D-3CDE-9AC3CDAEFE0C}"/>
               </a:ext>
             </a:extLst>
           </p:cNvPr>
@@ -16133,7 +16133,7 @@
           <p:cNvPr id="4" name="Rectangle: Rounded Corners 3">
             <a:extLst>
               <a:ext uri="{FF2B5EF4-FFF2-40B4-BE49-F238E27FC236}">
-                <a16:creationId xmlns:a16="http://schemas.microsoft.com/office/drawing/2014/main" id="{1EAE463B-A3BB-BB02-E23C-6DCC066D10D5}"/>
+                <a16:creationId xmlns:a16="http://schemas.microsoft.com/office/drawing/2014/main" id="{D82A1FB8-599D-9CE6-1BD1-EA1A816E5E0D}"/>
               </a:ext>
             </a:extLst>
           </p:cNvPr>
@@ -16184,7 +16184,7 @@
           <p:cNvPr id="5" name="TextBox 4">
             <a:extLst>
               <a:ext uri="{FF2B5EF4-FFF2-40B4-BE49-F238E27FC236}">
-                <a16:creationId xmlns:a16="http://schemas.microsoft.com/office/drawing/2014/main" id="{2372139A-FE9F-2039-9C0D-83FF76828959}"/>
+                <a16:creationId xmlns:a16="http://schemas.microsoft.com/office/drawing/2014/main" id="{4CE7CA49-9093-3A29-86F5-FA8FEE670A04}"/>
               </a:ext>
             </a:extLst>
           </p:cNvPr>
@@ -16224,7 +16224,7 @@
           <p:cNvPr id="6" name="TextBox 5">
             <a:extLst>
               <a:ext uri="{FF2B5EF4-FFF2-40B4-BE49-F238E27FC236}">
-                <a16:creationId xmlns:a16="http://schemas.microsoft.com/office/drawing/2014/main" id="{A0F82C48-681A-9810-843D-79C5647901EC}"/>
+                <a16:creationId xmlns:a16="http://schemas.microsoft.com/office/drawing/2014/main" id="{C95D7162-392D-F11A-A8D2-17B59592F18B}"/>
               </a:ext>
             </a:extLst>
           </p:cNvPr>
@@ -16264,7 +16264,7 @@
           <p:cNvPr id="7" name="TextBox 6">
             <a:extLst>
               <a:ext uri="{FF2B5EF4-FFF2-40B4-BE49-F238E27FC236}">
-                <a16:creationId xmlns:a16="http://schemas.microsoft.com/office/drawing/2014/main" id="{BFD1C3EF-3354-F962-68E2-7895C8C0BE02}"/>
+                <a16:creationId xmlns:a16="http://schemas.microsoft.com/office/drawing/2014/main" id="{A3D16CDF-3A7B-D2F3-6F4A-D64427805A43}"/>
               </a:ext>
             </a:extLst>
           </p:cNvPr>
@@ -16304,7 +16304,7 @@
           <p:cNvPr id="8" name="TextBox 7">
             <a:extLst>
               <a:ext uri="{FF2B5EF4-FFF2-40B4-BE49-F238E27FC236}">
-                <a16:creationId xmlns:a16="http://schemas.microsoft.com/office/drawing/2014/main" id="{AD3293C7-5E2C-06CA-A409-8E46884FC8E0}"/>
+                <a16:creationId xmlns:a16="http://schemas.microsoft.com/office/drawing/2014/main" id="{B055E291-D74C-D741-4E8B-3C21E442DFFD}"/>
               </a:ext>
             </a:extLst>
           </p:cNvPr>
@@ -16344,7 +16344,7 @@
           <p:cNvPr id="9" name="TextBox 8">
             <a:extLst>
               <a:ext uri="{FF2B5EF4-FFF2-40B4-BE49-F238E27FC236}">
-                <a16:creationId xmlns:a16="http://schemas.microsoft.com/office/drawing/2014/main" id="{85BFE4A2-FAA8-A9FA-A9D2-E67EF3EAFC8A}"/>
+                <a16:creationId xmlns:a16="http://schemas.microsoft.com/office/drawing/2014/main" id="{FF6903D5-1062-7431-8800-3ECECA5A14B4}"/>
               </a:ext>
             </a:extLst>
           </p:cNvPr>
@@ -16390,7 +16390,7 @@
           <p:cNvPr id="10" name="Rectangle: Rounded Corners 9">
             <a:extLst>
               <a:ext uri="{FF2B5EF4-FFF2-40B4-BE49-F238E27FC236}">
-                <a16:creationId xmlns:a16="http://schemas.microsoft.com/office/drawing/2014/main" id="{B303E0AC-9CA4-69FC-D222-931BFE7C6063}"/>
+                <a16:creationId xmlns:a16="http://schemas.microsoft.com/office/drawing/2014/main" id="{60ACC50C-EDA0-DBCA-227E-ECD69B27ECCB}"/>
               </a:ext>
             </a:extLst>
           </p:cNvPr>
@@ -16452,7 +16452,7 @@
           <p:cNvPr id="11" name="TextBox 10">
             <a:extLst>
               <a:ext uri="{FF2B5EF4-FFF2-40B4-BE49-F238E27FC236}">
-                <a16:creationId xmlns:a16="http://schemas.microsoft.com/office/drawing/2014/main" id="{4C6194A3-9003-E0F4-CE23-5522C912AE03}"/>
+                <a16:creationId xmlns:a16="http://schemas.microsoft.com/office/drawing/2014/main" id="{11E5B303-0F9D-58BD-4797-D2F831D3FB99}"/>
               </a:ext>
             </a:extLst>
           </p:cNvPr>
@@ -16492,7 +16492,7 @@
           <p:cNvPr id="12" name="Rectangle 11">
             <a:extLst>
               <a:ext uri="{FF2B5EF4-FFF2-40B4-BE49-F238E27FC236}">
-                <a16:creationId xmlns:a16="http://schemas.microsoft.com/office/drawing/2014/main" id="{6B3F6140-B117-8158-ABB5-FAB45C616783}"/>
+                <a16:creationId xmlns:a16="http://schemas.microsoft.com/office/drawing/2014/main" id="{0D610535-ABC8-8117-F342-B8F0ABEB0A24}"/>
               </a:ext>
             </a:extLst>
           </p:cNvPr>
@@ -16560,7 +16560,7 @@
           <p:cNvPr id="13" name="TextBox 12">
             <a:extLst>
               <a:ext uri="{FF2B5EF4-FFF2-40B4-BE49-F238E27FC236}">
-                <a16:creationId xmlns:a16="http://schemas.microsoft.com/office/drawing/2014/main" id="{7D75584A-B2CA-F398-B4E6-F934C24E9197}"/>
+                <a16:creationId xmlns:a16="http://schemas.microsoft.com/office/drawing/2014/main" id="{37F48E14-6B1A-F412-963E-12BCF6EB458C}"/>
               </a:ext>
             </a:extLst>
           </p:cNvPr>
@@ -16606,7 +16606,7 @@
           <p:cNvPr id="14" name="Rectangle: Rounded Corners 13">
             <a:extLst>
               <a:ext uri="{FF2B5EF4-FFF2-40B4-BE49-F238E27FC236}">
-                <a16:creationId xmlns:a16="http://schemas.microsoft.com/office/drawing/2014/main" id="{CF444AA5-5287-417F-FD3B-78891C6E4F1C}"/>
+                <a16:creationId xmlns:a16="http://schemas.microsoft.com/office/drawing/2014/main" id="{5094DDD0-1D32-AD7F-A114-04B4F32F0838}"/>
               </a:ext>
             </a:extLst>
           </p:cNvPr>
@@ -16660,7 +16660,7 @@
           <p:cNvPr id="15" name="Pentagon 14">
             <a:extLst>
               <a:ext uri="{FF2B5EF4-FFF2-40B4-BE49-F238E27FC236}">
-                <a16:creationId xmlns:a16="http://schemas.microsoft.com/office/drawing/2014/main" id="{2E2F683A-60D7-5CD5-15F5-EF0491BB5A25}"/>
+                <a16:creationId xmlns:a16="http://schemas.microsoft.com/office/drawing/2014/main" id="{A0798BFC-7BB7-BD9F-B8DD-1D3FFE2A6081}"/>
               </a:ext>
             </a:extLst>
           </p:cNvPr>
@@ -16714,7 +16714,7 @@
           <p:cNvPr id="16" name="Pentagon 15">
             <a:extLst>
               <a:ext uri="{FF2B5EF4-FFF2-40B4-BE49-F238E27FC236}">
-                <a16:creationId xmlns:a16="http://schemas.microsoft.com/office/drawing/2014/main" id="{9128EE8B-2541-07F4-8D98-B2ED1401FB6D}"/>
+                <a16:creationId xmlns:a16="http://schemas.microsoft.com/office/drawing/2014/main" id="{8262ABC8-35A8-EF81-9ECA-6C8AF58A7B0D}"/>
               </a:ext>
             </a:extLst>
           </p:cNvPr>
@@ -16768,7 +16768,7 @@
           <p:cNvPr id="17" name="Pentagon 16">
             <a:extLst>
               <a:ext uri="{FF2B5EF4-FFF2-40B4-BE49-F238E27FC236}">
-                <a16:creationId xmlns:a16="http://schemas.microsoft.com/office/drawing/2014/main" id="{91AD7254-7BAB-CF5E-6E92-84EE2FF25375}"/>
+                <a16:creationId xmlns:a16="http://schemas.microsoft.com/office/drawing/2014/main" id="{0D9A9E90-3C73-4413-3411-BD188A387295}"/>
               </a:ext>
             </a:extLst>
           </p:cNvPr>
@@ -16822,7 +16822,7 @@
           <p:cNvPr id="18" name="Pentagon 17">
             <a:extLst>
               <a:ext uri="{FF2B5EF4-FFF2-40B4-BE49-F238E27FC236}">
-                <a16:creationId xmlns:a16="http://schemas.microsoft.com/office/drawing/2014/main" id="{3F460B3C-2979-FCEB-EAD4-DF6566A67AAD}"/>
+                <a16:creationId xmlns:a16="http://schemas.microsoft.com/office/drawing/2014/main" id="{4E737868-747D-8545-6B98-ED62A648DF88}"/>
               </a:ext>
             </a:extLst>
           </p:cNvPr>
@@ -16876,7 +16876,7 @@
           <p:cNvPr id="20" name="Picture 19">
             <a:extLst>
               <a:ext uri="{FF2B5EF4-FFF2-40B4-BE49-F238E27FC236}">
-                <a16:creationId xmlns:a16="http://schemas.microsoft.com/office/drawing/2014/main" id="{329DDF77-BA79-FE36-24D1-3541E293D6B2}"/>
+                <a16:creationId xmlns:a16="http://schemas.microsoft.com/office/drawing/2014/main" id="{5C0AE988-D322-FEEC-734A-D3579500F92B}"/>
               </a:ext>
             </a:extLst>
           </p:cNvPr>
@@ -16912,7 +16912,7 @@
           <p:cNvPr id="21" name="Rectangle: Rounded Corners 20">
             <a:extLst>
               <a:ext uri="{FF2B5EF4-FFF2-40B4-BE49-F238E27FC236}">
-                <a16:creationId xmlns:a16="http://schemas.microsoft.com/office/drawing/2014/main" id="{8B5730E1-AE27-A1C7-114A-62B14F63D62E}"/>
+                <a16:creationId xmlns:a16="http://schemas.microsoft.com/office/drawing/2014/main" id="{B324D517-0E2F-3A2B-37A5-F797DE7854B5}"/>
               </a:ext>
             </a:extLst>
           </p:cNvPr>
@@ -16974,7 +16974,7 @@
           <p:cNvPr id="22" name="TextBox 21">
             <a:extLst>
               <a:ext uri="{FF2B5EF4-FFF2-40B4-BE49-F238E27FC236}">
-                <a16:creationId xmlns:a16="http://schemas.microsoft.com/office/drawing/2014/main" id="{D846A035-35DA-A6C7-F076-98C6B97EC809}"/>
+                <a16:creationId xmlns:a16="http://schemas.microsoft.com/office/drawing/2014/main" id="{4099C706-35F4-2999-7874-5C3EB687C3E9}"/>
               </a:ext>
             </a:extLst>
           </p:cNvPr>
@@ -17014,7 +17014,7 @@
           <p:cNvPr id="23" name="Rectangle: Rounded Corners 22">
             <a:extLst>
               <a:ext uri="{FF2B5EF4-FFF2-40B4-BE49-F238E27FC236}">
-                <a16:creationId xmlns:a16="http://schemas.microsoft.com/office/drawing/2014/main" id="{EA685B67-4D2D-0FEC-6670-0824A82AC016}"/>
+                <a16:creationId xmlns:a16="http://schemas.microsoft.com/office/drawing/2014/main" id="{FB0F953B-76B9-7221-01F9-AEB6E4DCC60B}"/>
               </a:ext>
             </a:extLst>
           </p:cNvPr>
@@ -17092,7 +17092,7 @@
           <p:cNvPr id="27" name="Group 26">
             <a:extLst>
               <a:ext uri="{FF2B5EF4-FFF2-40B4-BE49-F238E27FC236}">
-                <a16:creationId xmlns:a16="http://schemas.microsoft.com/office/drawing/2014/main" id="{9CB11E1B-97DE-DB8E-CB1C-97D350E341AF}"/>
+                <a16:creationId xmlns:a16="http://schemas.microsoft.com/office/drawing/2014/main" id="{83E7FBBC-0C9A-EC93-7422-C21A29C19004}"/>
               </a:ext>
             </a:extLst>
           </p:cNvPr>
@@ -17112,7 +17112,7 @@
             <p:cNvPr id="24" name="Rectangle: Rounded Corners 23">
               <a:extLst>
                 <a:ext uri="{FF2B5EF4-FFF2-40B4-BE49-F238E27FC236}">
-                  <a16:creationId xmlns:a16="http://schemas.microsoft.com/office/drawing/2014/main" id="{ECB5A59B-477F-C10A-B3F9-062B8F1975E0}"/>
+                  <a16:creationId xmlns:a16="http://schemas.microsoft.com/office/drawing/2014/main" id="{EFB48A1B-ED54-02D1-7469-0C07EAB8870D}"/>
                 </a:ext>
               </a:extLst>
             </p:cNvPr>
@@ -17166,7 +17166,7 @@
             <p:cNvPr id="25" name="Rectangle: Rounded Corners 24">
               <a:extLst>
                 <a:ext uri="{FF2B5EF4-FFF2-40B4-BE49-F238E27FC236}">
-                  <a16:creationId xmlns:a16="http://schemas.microsoft.com/office/drawing/2014/main" id="{4C314D1F-1536-19E6-64CB-45D7B60F89F4}"/>
+                  <a16:creationId xmlns:a16="http://schemas.microsoft.com/office/drawing/2014/main" id="{A8F5C4E7-D7B0-FFA5-D780-7C9A40D9C58D}"/>
                 </a:ext>
               </a:extLst>
             </p:cNvPr>
@@ -17228,7 +17228,7 @@
             <p:cNvPr id="26" name="TextBox 25">
               <a:extLst>
                 <a:ext uri="{FF2B5EF4-FFF2-40B4-BE49-F238E27FC236}">
-                  <a16:creationId xmlns:a16="http://schemas.microsoft.com/office/drawing/2014/main" id="{4FA29580-1247-E408-80BE-7C98B04BB29B}"/>
+                  <a16:creationId xmlns:a16="http://schemas.microsoft.com/office/drawing/2014/main" id="{49BB9209-23CD-B4F1-B3A9-0EB1A229CE96}"/>
                 </a:ext>
               </a:extLst>
             </p:cNvPr>
@@ -17275,7 +17275,7 @@
           <p:cNvPr id="31" name="Group 30">
             <a:extLst>
               <a:ext uri="{FF2B5EF4-FFF2-40B4-BE49-F238E27FC236}">
-                <a16:creationId xmlns:a16="http://schemas.microsoft.com/office/drawing/2014/main" id="{3C6794F1-E173-F5C5-5845-E4C8C2C1D619}"/>
+                <a16:creationId xmlns:a16="http://schemas.microsoft.com/office/drawing/2014/main" id="{4BC0609A-3D51-C43E-2494-B8FCBA1CC52B}"/>
               </a:ext>
             </a:extLst>
           </p:cNvPr>
@@ -17295,7 +17295,7 @@
             <p:cNvPr id="28" name="Rectangle: Rounded Corners 27">
               <a:extLst>
                 <a:ext uri="{FF2B5EF4-FFF2-40B4-BE49-F238E27FC236}">
-                  <a16:creationId xmlns:a16="http://schemas.microsoft.com/office/drawing/2014/main" id="{CDD3FB55-FF5F-01FC-63D0-48B8E496159E}"/>
+                  <a16:creationId xmlns:a16="http://schemas.microsoft.com/office/drawing/2014/main" id="{C0D0F1E2-8469-B3D1-3E2C-304E8CE4A9F5}"/>
                 </a:ext>
               </a:extLst>
             </p:cNvPr>
@@ -17349,7 +17349,7 @@
             <p:cNvPr id="29" name="Rectangle: Rounded Corners 28">
               <a:extLst>
                 <a:ext uri="{FF2B5EF4-FFF2-40B4-BE49-F238E27FC236}">
-                  <a16:creationId xmlns:a16="http://schemas.microsoft.com/office/drawing/2014/main" id="{09750BCB-87F5-AFFE-CF69-FF0282F0F6A5}"/>
+                  <a16:creationId xmlns:a16="http://schemas.microsoft.com/office/drawing/2014/main" id="{F6E1313C-0D74-46F3-05B5-F8A53A594B91}"/>
                 </a:ext>
               </a:extLst>
             </p:cNvPr>
@@ -17411,7 +17411,7 @@
             <p:cNvPr id="30" name="TextBox 29">
               <a:extLst>
                 <a:ext uri="{FF2B5EF4-FFF2-40B4-BE49-F238E27FC236}">
-                  <a16:creationId xmlns:a16="http://schemas.microsoft.com/office/drawing/2014/main" id="{0E27D810-A178-947C-255D-10CBFFE5656D}"/>
+                  <a16:creationId xmlns:a16="http://schemas.microsoft.com/office/drawing/2014/main" id="{C3EE21AF-EA26-C3BE-EF5F-6840B634742C}"/>
                 </a:ext>
               </a:extLst>
             </p:cNvPr>
@@ -17458,7 +17458,7 @@
           <p:cNvPr id="35" name="Group 34">
             <a:extLst>
               <a:ext uri="{FF2B5EF4-FFF2-40B4-BE49-F238E27FC236}">
-                <a16:creationId xmlns:a16="http://schemas.microsoft.com/office/drawing/2014/main" id="{51216904-C19A-AEF9-62C4-2051D757ADA7}"/>
+                <a16:creationId xmlns:a16="http://schemas.microsoft.com/office/drawing/2014/main" id="{A212B292-A0EC-473A-A5CD-406F0B4A445C}"/>
               </a:ext>
             </a:extLst>
           </p:cNvPr>
@@ -17478,7 +17478,7 @@
             <p:cNvPr id="32" name="Rectangle: Rounded Corners 31">
               <a:extLst>
                 <a:ext uri="{FF2B5EF4-FFF2-40B4-BE49-F238E27FC236}">
-                  <a16:creationId xmlns:a16="http://schemas.microsoft.com/office/drawing/2014/main" id="{8E0F3EA8-1485-3F45-34CB-5726D4FF5421}"/>
+                  <a16:creationId xmlns:a16="http://schemas.microsoft.com/office/drawing/2014/main" id="{E9BCBF86-9EAF-2C45-42AA-B78F784064F8}"/>
                 </a:ext>
               </a:extLst>
             </p:cNvPr>
@@ -17532,7 +17532,7 @@
             <p:cNvPr id="33" name="Rectangle: Rounded Corners 32">
               <a:extLst>
                 <a:ext uri="{FF2B5EF4-FFF2-40B4-BE49-F238E27FC236}">
-                  <a16:creationId xmlns:a16="http://schemas.microsoft.com/office/drawing/2014/main" id="{53330AF9-D810-1398-6386-ECF77C3D73AE}"/>
+                  <a16:creationId xmlns:a16="http://schemas.microsoft.com/office/drawing/2014/main" id="{DD092D54-7093-A3C9-1ED0-44D7D2A0FA66}"/>
                 </a:ext>
               </a:extLst>
             </p:cNvPr>
@@ -17594,7 +17594,7 @@
             <p:cNvPr id="34" name="TextBox 33">
               <a:extLst>
                 <a:ext uri="{FF2B5EF4-FFF2-40B4-BE49-F238E27FC236}">
-                  <a16:creationId xmlns:a16="http://schemas.microsoft.com/office/drawing/2014/main" id="{22BAD6D7-1B76-A826-51F1-3FF2AD628556}"/>
+                  <a16:creationId xmlns:a16="http://schemas.microsoft.com/office/drawing/2014/main" id="{88D58A99-9340-1D67-528C-91C3C921A156}"/>
                 </a:ext>
               </a:extLst>
             </p:cNvPr>
@@ -17641,7 +17641,7 @@
           <p:cNvPr id="36" name="Rectangle 35">
             <a:extLst>
               <a:ext uri="{FF2B5EF4-FFF2-40B4-BE49-F238E27FC236}">
-                <a16:creationId xmlns:a16="http://schemas.microsoft.com/office/drawing/2014/main" id="{131F36F1-3A9F-71C8-1E50-A9BC5A628419}"/>
+                <a16:creationId xmlns:a16="http://schemas.microsoft.com/office/drawing/2014/main" id="{E4EF244A-9E31-1769-F0D0-30F9F89F2F44}"/>
               </a:ext>
             </a:extLst>
           </p:cNvPr>
@@ -17709,7 +17709,7 @@
           <p:cNvPr id="37" name="TextBox 36">
             <a:extLst>
               <a:ext uri="{FF2B5EF4-FFF2-40B4-BE49-F238E27FC236}">
-                <a16:creationId xmlns:a16="http://schemas.microsoft.com/office/drawing/2014/main" id="{903D1FF7-E173-C3D0-E740-68D12D5C5E8C}"/>
+                <a16:creationId xmlns:a16="http://schemas.microsoft.com/office/drawing/2014/main" id="{CBE67B60-5ADB-F9A2-A6D6-9B68E4D3DEE9}"/>
               </a:ext>
             </a:extLst>
           </p:cNvPr>
@@ -17749,7 +17749,7 @@
           <p:cNvPr id="38" name="TextBox 37">
             <a:extLst>
               <a:ext uri="{FF2B5EF4-FFF2-40B4-BE49-F238E27FC236}">
-                <a16:creationId xmlns:a16="http://schemas.microsoft.com/office/drawing/2014/main" id="{0E8DB75B-E2AB-2615-0CEA-65D1EE347314}"/>
+                <a16:creationId xmlns:a16="http://schemas.microsoft.com/office/drawing/2014/main" id="{96909243-1516-9AB9-CFAE-A3F6E4444956}"/>
               </a:ext>
             </a:extLst>
           </p:cNvPr>
@@ -17790,7 +17790,7 @@
           <p:cNvPr id="39" name="TextBox 38">
             <a:extLst>
               <a:ext uri="{FF2B5EF4-FFF2-40B4-BE49-F238E27FC236}">
-                <a16:creationId xmlns:a16="http://schemas.microsoft.com/office/drawing/2014/main" id="{BDD22560-C49C-9EA8-C943-DB16F24BEF88}"/>
+                <a16:creationId xmlns:a16="http://schemas.microsoft.com/office/drawing/2014/main" id="{44B5BB9B-3EF8-9A6A-7C78-62BF1DA4E69A}"/>
               </a:ext>
             </a:extLst>
           </p:cNvPr>
@@ -17829,7 +17829,7 @@
     </p:spTree>
     <p:extLst>
       <p:ext uri="{BB962C8B-B14F-4D97-AF65-F5344CB8AC3E}">
-        <p14:creationId xmlns:p14="http://schemas.microsoft.com/office/powerpoint/2010/main" val="2517015350"/>
+        <p14:creationId xmlns:p14="http://schemas.microsoft.com/office/powerpoint/2010/main" val="787379123"/>
       </p:ext>
     </p:extLst>
   </p:cSld>
@@ -18085,7 +18085,7 @@
           <p:cNvPr id="2" name="Rectangle 1">
             <a:extLst>
               <a:ext uri="{FF2B5EF4-FFF2-40B4-BE49-F238E27FC236}">
-                <a16:creationId xmlns:a16="http://schemas.microsoft.com/office/drawing/2014/main" id="{A9E8F027-64EF-5029-2F5C-6453008D9B05}"/>
+                <a16:creationId xmlns:a16="http://schemas.microsoft.com/office/drawing/2014/main" id="{39AF13B3-263E-DA16-11FE-FDFDC4C41DB3}"/>
               </a:ext>
             </a:extLst>
           </p:cNvPr>
@@ -18153,7 +18153,7 @@
           <p:cNvPr id="3" name="Rectangle: Rounded Corners 2">
             <a:extLst>
               <a:ext uri="{FF2B5EF4-FFF2-40B4-BE49-F238E27FC236}">
-                <a16:creationId xmlns:a16="http://schemas.microsoft.com/office/drawing/2014/main" id="{7DC3EFAB-7C2D-D2BF-56C5-76D4828E0ECF}"/>
+                <a16:creationId xmlns:a16="http://schemas.microsoft.com/office/drawing/2014/main" id="{BDED4313-9A6F-78E5-CF70-650F0414D32C}"/>
               </a:ext>
             </a:extLst>
           </p:cNvPr>
@@ -18207,7 +18207,7 @@
           <p:cNvPr id="4" name="Rectangle: Rounded Corners 3">
             <a:extLst>
               <a:ext uri="{FF2B5EF4-FFF2-40B4-BE49-F238E27FC236}">
-                <a16:creationId xmlns:a16="http://schemas.microsoft.com/office/drawing/2014/main" id="{A9AF993F-3037-BB5B-104E-6F4A52BB2C3A}"/>
+                <a16:creationId xmlns:a16="http://schemas.microsoft.com/office/drawing/2014/main" id="{F1619D68-0CD9-E913-0261-254E53B09A01}"/>
               </a:ext>
             </a:extLst>
           </p:cNvPr>
@@ -18258,7 +18258,7 @@
           <p:cNvPr id="5" name="TextBox 4">
             <a:extLst>
               <a:ext uri="{FF2B5EF4-FFF2-40B4-BE49-F238E27FC236}">
-                <a16:creationId xmlns:a16="http://schemas.microsoft.com/office/drawing/2014/main" id="{A34FE8B3-477D-F161-3C27-2CD25A2E3685}"/>
+                <a16:creationId xmlns:a16="http://schemas.microsoft.com/office/drawing/2014/main" id="{72F1D028-3B3C-E6B4-F6BE-0AE806EBAD13}"/>
               </a:ext>
             </a:extLst>
           </p:cNvPr>
@@ -18298,7 +18298,7 @@
           <p:cNvPr id="6" name="TextBox 5">
             <a:extLst>
               <a:ext uri="{FF2B5EF4-FFF2-40B4-BE49-F238E27FC236}">
-                <a16:creationId xmlns:a16="http://schemas.microsoft.com/office/drawing/2014/main" id="{A8656437-9439-5051-F973-64EBABEBC7B8}"/>
+                <a16:creationId xmlns:a16="http://schemas.microsoft.com/office/drawing/2014/main" id="{D492BBB9-57C2-CC8F-241A-947424771450}"/>
               </a:ext>
             </a:extLst>
           </p:cNvPr>
@@ -18338,7 +18338,7 @@
           <p:cNvPr id="7" name="TextBox 6">
             <a:extLst>
               <a:ext uri="{FF2B5EF4-FFF2-40B4-BE49-F238E27FC236}">
-                <a16:creationId xmlns:a16="http://schemas.microsoft.com/office/drawing/2014/main" id="{8DE7C29C-DEC9-4811-337B-989D49E29220}"/>
+                <a16:creationId xmlns:a16="http://schemas.microsoft.com/office/drawing/2014/main" id="{FDCEADE5-691D-2F47-5736-7CF3BB7188E1}"/>
               </a:ext>
             </a:extLst>
           </p:cNvPr>
@@ -18378,7 +18378,7 @@
           <p:cNvPr id="8" name="TextBox 7">
             <a:extLst>
               <a:ext uri="{FF2B5EF4-FFF2-40B4-BE49-F238E27FC236}">
-                <a16:creationId xmlns:a16="http://schemas.microsoft.com/office/drawing/2014/main" id="{3B3412C4-61B5-B120-7B96-C4E062150E00}"/>
+                <a16:creationId xmlns:a16="http://schemas.microsoft.com/office/drawing/2014/main" id="{DA92AED4-42C5-8DD3-5883-3044747C42A7}"/>
               </a:ext>
             </a:extLst>
           </p:cNvPr>
@@ -18418,7 +18418,7 @@
           <p:cNvPr id="9" name="TextBox 8">
             <a:extLst>
               <a:ext uri="{FF2B5EF4-FFF2-40B4-BE49-F238E27FC236}">
-                <a16:creationId xmlns:a16="http://schemas.microsoft.com/office/drawing/2014/main" id="{E95F8EC9-670B-72E9-CF2A-DC44E91BB552}"/>
+                <a16:creationId xmlns:a16="http://schemas.microsoft.com/office/drawing/2014/main" id="{F460F1B2-282E-57E8-D95B-B248C3ED09B0}"/>
               </a:ext>
             </a:extLst>
           </p:cNvPr>
@@ -18464,7 +18464,7 @@
           <p:cNvPr id="10" name="Rectangle: Rounded Corners 9">
             <a:extLst>
               <a:ext uri="{FF2B5EF4-FFF2-40B4-BE49-F238E27FC236}">
-                <a16:creationId xmlns:a16="http://schemas.microsoft.com/office/drawing/2014/main" id="{8D622D5F-D3D3-D38B-0852-3856DABE8C83}"/>
+                <a16:creationId xmlns:a16="http://schemas.microsoft.com/office/drawing/2014/main" id="{DF9A8E6E-FC5C-54C6-614F-F07F0DE22D3B}"/>
               </a:ext>
             </a:extLst>
           </p:cNvPr>
@@ -18526,7 +18526,7 @@
           <p:cNvPr id="11" name="TextBox 10">
             <a:extLst>
               <a:ext uri="{FF2B5EF4-FFF2-40B4-BE49-F238E27FC236}">
-                <a16:creationId xmlns:a16="http://schemas.microsoft.com/office/drawing/2014/main" id="{122215FE-78B8-76C7-46A7-3544C47BE301}"/>
+                <a16:creationId xmlns:a16="http://schemas.microsoft.com/office/drawing/2014/main" id="{7EEA1807-DF79-A5DE-6213-CC70751926E9}"/>
               </a:ext>
             </a:extLst>
           </p:cNvPr>
@@ -18572,7 +18572,7 @@
           <p:cNvPr id="12" name="Rectangle 11">
             <a:extLst>
               <a:ext uri="{FF2B5EF4-FFF2-40B4-BE49-F238E27FC236}">
-                <a16:creationId xmlns:a16="http://schemas.microsoft.com/office/drawing/2014/main" id="{B3ADD071-F87D-1061-B1DF-1006D23C1371}"/>
+                <a16:creationId xmlns:a16="http://schemas.microsoft.com/office/drawing/2014/main" id="{252189F1-8091-DF6B-89E6-B985C067C7C1}"/>
               </a:ext>
             </a:extLst>
           </p:cNvPr>
@@ -18640,7 +18640,7 @@
           <p:cNvPr id="13" name="TextBox 12">
             <a:extLst>
               <a:ext uri="{FF2B5EF4-FFF2-40B4-BE49-F238E27FC236}">
-                <a16:creationId xmlns:a16="http://schemas.microsoft.com/office/drawing/2014/main" id="{7AAD4A26-F642-C7A1-261E-AAE930547F0E}"/>
+                <a16:creationId xmlns:a16="http://schemas.microsoft.com/office/drawing/2014/main" id="{21611E6E-FDE5-0004-8BBA-09D5B14F6131}"/>
               </a:ext>
             </a:extLst>
           </p:cNvPr>
@@ -18686,7 +18686,7 @@
           <p:cNvPr id="14" name="Rectangle: Rounded Corners 13">
             <a:extLst>
               <a:ext uri="{FF2B5EF4-FFF2-40B4-BE49-F238E27FC236}">
-                <a16:creationId xmlns:a16="http://schemas.microsoft.com/office/drawing/2014/main" id="{CCE34D2E-4170-DDDA-994D-44AAAD91468B}"/>
+                <a16:creationId xmlns:a16="http://schemas.microsoft.com/office/drawing/2014/main" id="{83B6C9AA-2EE6-64B8-0123-39A256746D22}"/>
               </a:ext>
             </a:extLst>
           </p:cNvPr>
@@ -18740,7 +18740,7 @@
           <p:cNvPr id="15" name="Pentagon 14">
             <a:extLst>
               <a:ext uri="{FF2B5EF4-FFF2-40B4-BE49-F238E27FC236}">
-                <a16:creationId xmlns:a16="http://schemas.microsoft.com/office/drawing/2014/main" id="{900C593F-8DA9-E70A-0B04-B1D0A0556197}"/>
+                <a16:creationId xmlns:a16="http://schemas.microsoft.com/office/drawing/2014/main" id="{1406F056-17DB-28B4-CEB0-158F2035808F}"/>
               </a:ext>
             </a:extLst>
           </p:cNvPr>
@@ -18794,7 +18794,7 @@
           <p:cNvPr id="16" name="Pentagon 15">
             <a:extLst>
               <a:ext uri="{FF2B5EF4-FFF2-40B4-BE49-F238E27FC236}">
-                <a16:creationId xmlns:a16="http://schemas.microsoft.com/office/drawing/2014/main" id="{D0AC7C65-ACB0-CDA6-658D-8CC1A5AA04E5}"/>
+                <a16:creationId xmlns:a16="http://schemas.microsoft.com/office/drawing/2014/main" id="{697678AF-8320-0EF7-D7C3-C0AD7471D363}"/>
               </a:ext>
             </a:extLst>
           </p:cNvPr>
@@ -18848,7 +18848,7 @@
           <p:cNvPr id="17" name="Pentagon 16">
             <a:extLst>
               <a:ext uri="{FF2B5EF4-FFF2-40B4-BE49-F238E27FC236}">
-                <a16:creationId xmlns:a16="http://schemas.microsoft.com/office/drawing/2014/main" id="{B0CACC25-9F96-78ED-C28F-B257A2009B5A}"/>
+                <a16:creationId xmlns:a16="http://schemas.microsoft.com/office/drawing/2014/main" id="{461389CB-2036-D005-DCB6-6054BAFFE068}"/>
               </a:ext>
             </a:extLst>
           </p:cNvPr>
@@ -18902,7 +18902,7 @@
           <p:cNvPr id="18" name="Pentagon 17">
             <a:extLst>
               <a:ext uri="{FF2B5EF4-FFF2-40B4-BE49-F238E27FC236}">
-                <a16:creationId xmlns:a16="http://schemas.microsoft.com/office/drawing/2014/main" id="{5BCC7698-59BA-626B-3B11-FEC6DEE9C182}"/>
+                <a16:creationId xmlns:a16="http://schemas.microsoft.com/office/drawing/2014/main" id="{6440C5C6-7460-6267-67A3-795EE03B00BA}"/>
               </a:ext>
             </a:extLst>
           </p:cNvPr>
@@ -18956,7 +18956,7 @@
           <p:cNvPr id="20" name="Picture 19">
             <a:extLst>
               <a:ext uri="{FF2B5EF4-FFF2-40B4-BE49-F238E27FC236}">
-                <a16:creationId xmlns:a16="http://schemas.microsoft.com/office/drawing/2014/main" id="{0085F8C5-1460-BADB-F9A4-DA967F76AF29}"/>
+                <a16:creationId xmlns:a16="http://schemas.microsoft.com/office/drawing/2014/main" id="{9B9F79EF-0BDC-C386-B5BA-B395928F6B9E}"/>
               </a:ext>
             </a:extLst>
           </p:cNvPr>
@@ -18992,7 +18992,7 @@
           <p:cNvPr id="21" name="Rectangle: Rounded Corners 20">
             <a:extLst>
               <a:ext uri="{FF2B5EF4-FFF2-40B4-BE49-F238E27FC236}">
-                <a16:creationId xmlns:a16="http://schemas.microsoft.com/office/drawing/2014/main" id="{BAD248D7-4C48-C600-7190-A8E634C267B7}"/>
+                <a16:creationId xmlns:a16="http://schemas.microsoft.com/office/drawing/2014/main" id="{FBFD7441-BFAB-5FEF-5566-F94EF7E8F21D}"/>
               </a:ext>
             </a:extLst>
           </p:cNvPr>
@@ -19054,7 +19054,7 @@
           <p:cNvPr id="22" name="TextBox 21">
             <a:extLst>
               <a:ext uri="{FF2B5EF4-FFF2-40B4-BE49-F238E27FC236}">
-                <a16:creationId xmlns:a16="http://schemas.microsoft.com/office/drawing/2014/main" id="{41A95914-F325-847D-05E1-C4AD22E75380}"/>
+                <a16:creationId xmlns:a16="http://schemas.microsoft.com/office/drawing/2014/main" id="{FA526394-8658-269B-719B-C1E05BC165BA}"/>
               </a:ext>
             </a:extLst>
           </p:cNvPr>
@@ -19094,7 +19094,7 @@
           <p:cNvPr id="23" name="Rectangle: Rounded Corners 22">
             <a:extLst>
               <a:ext uri="{FF2B5EF4-FFF2-40B4-BE49-F238E27FC236}">
-                <a16:creationId xmlns:a16="http://schemas.microsoft.com/office/drawing/2014/main" id="{0F7FC522-DAB6-EC55-CC56-80B0C0FB5551}"/>
+                <a16:creationId xmlns:a16="http://schemas.microsoft.com/office/drawing/2014/main" id="{EF012678-E687-4FC5-01EB-0ABE8E412944}"/>
               </a:ext>
             </a:extLst>
           </p:cNvPr>
@@ -19172,7 +19172,7 @@
           <p:cNvPr id="27" name="Group 26">
             <a:extLst>
               <a:ext uri="{FF2B5EF4-FFF2-40B4-BE49-F238E27FC236}">
-                <a16:creationId xmlns:a16="http://schemas.microsoft.com/office/drawing/2014/main" id="{E279CEEA-C2CE-FDF0-97C2-48FDDB7BD430}"/>
+                <a16:creationId xmlns:a16="http://schemas.microsoft.com/office/drawing/2014/main" id="{C2668EA3-02CF-173D-7180-52B50D4A0F71}"/>
               </a:ext>
             </a:extLst>
           </p:cNvPr>
@@ -19192,7 +19192,7 @@
             <p:cNvPr id="24" name="Rectangle: Rounded Corners 23">
               <a:extLst>
                 <a:ext uri="{FF2B5EF4-FFF2-40B4-BE49-F238E27FC236}">
-                  <a16:creationId xmlns:a16="http://schemas.microsoft.com/office/drawing/2014/main" id="{48C9A114-BC38-41F8-DF73-D10537666F2E}"/>
+                  <a16:creationId xmlns:a16="http://schemas.microsoft.com/office/drawing/2014/main" id="{DD8F001C-2915-B4D5-F1C2-B366116AF7D5}"/>
                 </a:ext>
               </a:extLst>
             </p:cNvPr>
@@ -19246,7 +19246,7 @@
             <p:cNvPr id="25" name="Rectangle: Rounded Corners 24">
               <a:extLst>
                 <a:ext uri="{FF2B5EF4-FFF2-40B4-BE49-F238E27FC236}">
-                  <a16:creationId xmlns:a16="http://schemas.microsoft.com/office/drawing/2014/main" id="{0596B930-F197-7EC9-3A72-EC2CA23A3206}"/>
+                  <a16:creationId xmlns:a16="http://schemas.microsoft.com/office/drawing/2014/main" id="{DDB0A956-4B2B-449E-ED31-15A091BF0ADF}"/>
                 </a:ext>
               </a:extLst>
             </p:cNvPr>
@@ -19308,7 +19308,7 @@
             <p:cNvPr id="26" name="TextBox 25">
               <a:extLst>
                 <a:ext uri="{FF2B5EF4-FFF2-40B4-BE49-F238E27FC236}">
-                  <a16:creationId xmlns:a16="http://schemas.microsoft.com/office/drawing/2014/main" id="{73DEBAB5-F3F4-FD6A-79E4-ABBB045A7106}"/>
+                  <a16:creationId xmlns:a16="http://schemas.microsoft.com/office/drawing/2014/main" id="{743ADAC4-EB73-1A6F-D68A-9CE70D957F2B}"/>
                 </a:ext>
               </a:extLst>
             </p:cNvPr>
@@ -19355,7 +19355,7 @@
           <p:cNvPr id="31" name="Group 30">
             <a:extLst>
               <a:ext uri="{FF2B5EF4-FFF2-40B4-BE49-F238E27FC236}">
-                <a16:creationId xmlns:a16="http://schemas.microsoft.com/office/drawing/2014/main" id="{BA0E821B-178C-4A69-F573-4D8489EE6180}"/>
+                <a16:creationId xmlns:a16="http://schemas.microsoft.com/office/drawing/2014/main" id="{957848B0-DA15-F582-5CA8-497AC140FEF8}"/>
               </a:ext>
             </a:extLst>
           </p:cNvPr>
@@ -19375,7 +19375,7 @@
             <p:cNvPr id="28" name="Rectangle: Rounded Corners 27">
               <a:extLst>
                 <a:ext uri="{FF2B5EF4-FFF2-40B4-BE49-F238E27FC236}">
-                  <a16:creationId xmlns:a16="http://schemas.microsoft.com/office/drawing/2014/main" id="{C8416079-9D25-8039-4A26-09D41AFD5D97}"/>
+                  <a16:creationId xmlns:a16="http://schemas.microsoft.com/office/drawing/2014/main" id="{2A802806-D66F-6B0A-F0DD-15C8692D89AC}"/>
                 </a:ext>
               </a:extLst>
             </p:cNvPr>
@@ -19429,7 +19429,7 @@
             <p:cNvPr id="29" name="Rectangle: Rounded Corners 28">
               <a:extLst>
                 <a:ext uri="{FF2B5EF4-FFF2-40B4-BE49-F238E27FC236}">
-                  <a16:creationId xmlns:a16="http://schemas.microsoft.com/office/drawing/2014/main" id="{E45F9FBA-4989-199D-D1B8-88AD5A8FFA77}"/>
+                  <a16:creationId xmlns:a16="http://schemas.microsoft.com/office/drawing/2014/main" id="{40D8B171-7AF0-ADDC-0732-815FFF380E27}"/>
                 </a:ext>
               </a:extLst>
             </p:cNvPr>
@@ -19491,7 +19491,7 @@
             <p:cNvPr id="30" name="TextBox 29">
               <a:extLst>
                 <a:ext uri="{FF2B5EF4-FFF2-40B4-BE49-F238E27FC236}">
-                  <a16:creationId xmlns:a16="http://schemas.microsoft.com/office/drawing/2014/main" id="{B4D8EB0E-948C-760B-C98F-3D5D76BC7EB4}"/>
+                  <a16:creationId xmlns:a16="http://schemas.microsoft.com/office/drawing/2014/main" id="{7A0561DE-9B96-F87A-7C51-A0E8BA6777D7}"/>
                 </a:ext>
               </a:extLst>
             </p:cNvPr>
@@ -19538,7 +19538,7 @@
           <p:cNvPr id="35" name="Group 34">
             <a:extLst>
               <a:ext uri="{FF2B5EF4-FFF2-40B4-BE49-F238E27FC236}">
-                <a16:creationId xmlns:a16="http://schemas.microsoft.com/office/drawing/2014/main" id="{CDD6C387-B040-2CD7-F516-1814791DD0E5}"/>
+                <a16:creationId xmlns:a16="http://schemas.microsoft.com/office/drawing/2014/main" id="{2BCE4EAB-E994-0F66-12BD-5F4BF446C0CE}"/>
               </a:ext>
             </a:extLst>
           </p:cNvPr>
@@ -19558,7 +19558,7 @@
             <p:cNvPr id="32" name="Rectangle: Rounded Corners 31">
               <a:extLst>
                 <a:ext uri="{FF2B5EF4-FFF2-40B4-BE49-F238E27FC236}">
-                  <a16:creationId xmlns:a16="http://schemas.microsoft.com/office/drawing/2014/main" id="{657DE639-3E8A-6184-DC88-3B7092D61A42}"/>
+                  <a16:creationId xmlns:a16="http://schemas.microsoft.com/office/drawing/2014/main" id="{9689065D-50BA-9440-52D6-7CA0E37B5B67}"/>
                 </a:ext>
               </a:extLst>
             </p:cNvPr>
@@ -19612,7 +19612,7 @@
             <p:cNvPr id="33" name="Rectangle: Rounded Corners 32">
               <a:extLst>
                 <a:ext uri="{FF2B5EF4-FFF2-40B4-BE49-F238E27FC236}">
-                  <a16:creationId xmlns:a16="http://schemas.microsoft.com/office/drawing/2014/main" id="{47C70F8E-0CE9-4759-ADE6-B23308C82758}"/>
+                  <a16:creationId xmlns:a16="http://schemas.microsoft.com/office/drawing/2014/main" id="{03D4C762-3C9B-8980-7BC9-2BC54A03A1C0}"/>
                 </a:ext>
               </a:extLst>
             </p:cNvPr>
@@ -19674,7 +19674,7 @@
             <p:cNvPr id="34" name="TextBox 33">
               <a:extLst>
                 <a:ext uri="{FF2B5EF4-FFF2-40B4-BE49-F238E27FC236}">
-                  <a16:creationId xmlns:a16="http://schemas.microsoft.com/office/drawing/2014/main" id="{A96F6EE5-1C16-BA6C-8646-E8C3765A2EF8}"/>
+                  <a16:creationId xmlns:a16="http://schemas.microsoft.com/office/drawing/2014/main" id="{5FC4AC25-59AF-5254-72A1-B8A16D681342}"/>
                 </a:ext>
               </a:extLst>
             </p:cNvPr>
@@ -19721,7 +19721,7 @@
           <p:cNvPr id="39" name="Group 38">
             <a:extLst>
               <a:ext uri="{FF2B5EF4-FFF2-40B4-BE49-F238E27FC236}">
-                <a16:creationId xmlns:a16="http://schemas.microsoft.com/office/drawing/2014/main" id="{B1323733-3E35-6A2D-C20E-BFA3FE02FD70}"/>
+                <a16:creationId xmlns:a16="http://schemas.microsoft.com/office/drawing/2014/main" id="{2641FC06-56D2-8E1F-D34E-25874574F5C0}"/>
               </a:ext>
             </a:extLst>
           </p:cNvPr>
@@ -19741,7 +19741,7 @@
             <p:cNvPr id="36" name="Rectangle: Rounded Corners 35">
               <a:extLst>
                 <a:ext uri="{FF2B5EF4-FFF2-40B4-BE49-F238E27FC236}">
-                  <a16:creationId xmlns:a16="http://schemas.microsoft.com/office/drawing/2014/main" id="{A04D927F-4F87-F82C-798A-9A42672D9873}"/>
+                  <a16:creationId xmlns:a16="http://schemas.microsoft.com/office/drawing/2014/main" id="{18F94242-D25E-B997-5043-BA20092352BB}"/>
                 </a:ext>
               </a:extLst>
             </p:cNvPr>
@@ -19795,7 +19795,7 @@
             <p:cNvPr id="37" name="Rectangle: Rounded Corners 36">
               <a:extLst>
                 <a:ext uri="{FF2B5EF4-FFF2-40B4-BE49-F238E27FC236}">
-                  <a16:creationId xmlns:a16="http://schemas.microsoft.com/office/drawing/2014/main" id="{6E3A426F-EFDC-C667-19A8-43465B8D9BC7}"/>
+                  <a16:creationId xmlns:a16="http://schemas.microsoft.com/office/drawing/2014/main" id="{7649813D-CA82-CA39-1B5E-CEA211DA719E}"/>
                 </a:ext>
               </a:extLst>
             </p:cNvPr>
@@ -19857,7 +19857,7 @@
             <p:cNvPr id="38" name="TextBox 37">
               <a:extLst>
                 <a:ext uri="{FF2B5EF4-FFF2-40B4-BE49-F238E27FC236}">
-                  <a16:creationId xmlns:a16="http://schemas.microsoft.com/office/drawing/2014/main" id="{50B67026-3773-9D8A-A7D4-CDA7C07747D9}"/>
+                  <a16:creationId xmlns:a16="http://schemas.microsoft.com/office/drawing/2014/main" id="{9B9FA212-A737-77F2-4FE2-C6B140A42DC3}"/>
                 </a:ext>
               </a:extLst>
             </p:cNvPr>
@@ -19904,7 +19904,7 @@
           <p:cNvPr id="40" name="Rectangle 39">
             <a:extLst>
               <a:ext uri="{FF2B5EF4-FFF2-40B4-BE49-F238E27FC236}">
-                <a16:creationId xmlns:a16="http://schemas.microsoft.com/office/drawing/2014/main" id="{78B37276-F935-5063-5045-17D3881BDEC4}"/>
+                <a16:creationId xmlns:a16="http://schemas.microsoft.com/office/drawing/2014/main" id="{44DA07BE-304B-B8E7-577F-752FAFFCAD58}"/>
               </a:ext>
             </a:extLst>
           </p:cNvPr>
@@ -19972,7 +19972,7 @@
           <p:cNvPr id="41" name="TextBox 40">
             <a:extLst>
               <a:ext uri="{FF2B5EF4-FFF2-40B4-BE49-F238E27FC236}">
-                <a16:creationId xmlns:a16="http://schemas.microsoft.com/office/drawing/2014/main" id="{88E47D38-09ED-C108-F575-849B67B49C66}"/>
+                <a16:creationId xmlns:a16="http://schemas.microsoft.com/office/drawing/2014/main" id="{3F75CBF1-B093-D3A2-B0A7-E5F123100CAF}"/>
               </a:ext>
             </a:extLst>
           </p:cNvPr>
@@ -20012,7 +20012,7 @@
           <p:cNvPr id="42" name="TextBox 41">
             <a:extLst>
               <a:ext uri="{FF2B5EF4-FFF2-40B4-BE49-F238E27FC236}">
-                <a16:creationId xmlns:a16="http://schemas.microsoft.com/office/drawing/2014/main" id="{039CBB3D-0CF0-648F-DE4A-8F1BC106A41D}"/>
+                <a16:creationId xmlns:a16="http://schemas.microsoft.com/office/drawing/2014/main" id="{8278923B-FC3C-B0E5-F858-4B47C1549298}"/>
               </a:ext>
             </a:extLst>
           </p:cNvPr>
@@ -20053,7 +20053,7 @@
           <p:cNvPr id="43" name="TextBox 42">
             <a:extLst>
               <a:ext uri="{FF2B5EF4-FFF2-40B4-BE49-F238E27FC236}">
-                <a16:creationId xmlns:a16="http://schemas.microsoft.com/office/drawing/2014/main" id="{AEECD283-1396-F836-AEBA-BF845F19A4D8}"/>
+                <a16:creationId xmlns:a16="http://schemas.microsoft.com/office/drawing/2014/main" id="{53F3FE58-0526-E0E4-FDF7-79877D80E55A}"/>
               </a:ext>
             </a:extLst>
           </p:cNvPr>
@@ -20092,7 +20092,7 @@
     </p:spTree>
     <p:extLst>
       <p:ext uri="{BB962C8B-B14F-4D97-AF65-F5344CB8AC3E}">
-        <p14:creationId xmlns:p14="http://schemas.microsoft.com/office/powerpoint/2010/main" val="3395915436"/>
+        <p14:creationId xmlns:p14="http://schemas.microsoft.com/office/powerpoint/2010/main" val="2461527576"/>
       </p:ext>
     </p:extLst>
   </p:cSld>
@@ -20392,7 +20392,7 @@
           <p:cNvPr id="2" name="Rectangle 1">
             <a:extLst>
               <a:ext uri="{FF2B5EF4-FFF2-40B4-BE49-F238E27FC236}">
-                <a16:creationId xmlns:a16="http://schemas.microsoft.com/office/drawing/2014/main" id="{DED00D5D-7FAC-A71B-2431-BC2F61B0E982}"/>
+                <a16:creationId xmlns:a16="http://schemas.microsoft.com/office/drawing/2014/main" id="{27D9F3A1-9015-1DAC-A405-DBBC1BC231F5}"/>
               </a:ext>
             </a:extLst>
           </p:cNvPr>
@@ -20460,7 +20460,7 @@
           <p:cNvPr id="3" name="Rectangle: Rounded Corners 2">
             <a:extLst>
               <a:ext uri="{FF2B5EF4-FFF2-40B4-BE49-F238E27FC236}">
-                <a16:creationId xmlns:a16="http://schemas.microsoft.com/office/drawing/2014/main" id="{822B1D23-88F6-B3C4-F2F1-A33CA0F42FD3}"/>
+                <a16:creationId xmlns:a16="http://schemas.microsoft.com/office/drawing/2014/main" id="{717B4A86-5ABA-171D-DB42-542282A9FC68}"/>
               </a:ext>
             </a:extLst>
           </p:cNvPr>
@@ -20514,7 +20514,7 @@
           <p:cNvPr id="4" name="Rectangle: Rounded Corners 3">
             <a:extLst>
               <a:ext uri="{FF2B5EF4-FFF2-40B4-BE49-F238E27FC236}">
-                <a16:creationId xmlns:a16="http://schemas.microsoft.com/office/drawing/2014/main" id="{A518AD2C-8CD3-5C22-0CF7-C7F21DD7369D}"/>
+                <a16:creationId xmlns:a16="http://schemas.microsoft.com/office/drawing/2014/main" id="{29C5D81E-6EF4-80C8-3802-55E6A4E5C855}"/>
               </a:ext>
             </a:extLst>
           </p:cNvPr>
@@ -20565,7 +20565,7 @@
           <p:cNvPr id="5" name="TextBox 4">
             <a:extLst>
               <a:ext uri="{FF2B5EF4-FFF2-40B4-BE49-F238E27FC236}">
-                <a16:creationId xmlns:a16="http://schemas.microsoft.com/office/drawing/2014/main" id="{BC5B6146-D8B1-FF64-D981-BC9D45A08CCB}"/>
+                <a16:creationId xmlns:a16="http://schemas.microsoft.com/office/drawing/2014/main" id="{4319669D-27B0-5F5A-6E76-9CFF598989A7}"/>
               </a:ext>
             </a:extLst>
           </p:cNvPr>
@@ -20605,7 +20605,7 @@
           <p:cNvPr id="6" name="TextBox 5">
             <a:extLst>
               <a:ext uri="{FF2B5EF4-FFF2-40B4-BE49-F238E27FC236}">
-                <a16:creationId xmlns:a16="http://schemas.microsoft.com/office/drawing/2014/main" id="{B7588B60-BC5C-E569-7320-8DD148A23242}"/>
+                <a16:creationId xmlns:a16="http://schemas.microsoft.com/office/drawing/2014/main" id="{11F2E649-B110-836A-4FF2-658362CA19BC}"/>
               </a:ext>
             </a:extLst>
           </p:cNvPr>
@@ -20645,7 +20645,7 @@
           <p:cNvPr id="7" name="TextBox 6">
             <a:extLst>
               <a:ext uri="{FF2B5EF4-FFF2-40B4-BE49-F238E27FC236}">
-                <a16:creationId xmlns:a16="http://schemas.microsoft.com/office/drawing/2014/main" id="{F83D63A6-381C-9913-10AB-B03193267CD4}"/>
+                <a16:creationId xmlns:a16="http://schemas.microsoft.com/office/drawing/2014/main" id="{C34E1C95-4DF5-9E49-3D73-4F8F3060DE6A}"/>
               </a:ext>
             </a:extLst>
           </p:cNvPr>
@@ -20685,7 +20685,7 @@
           <p:cNvPr id="8" name="TextBox 7">
             <a:extLst>
               <a:ext uri="{FF2B5EF4-FFF2-40B4-BE49-F238E27FC236}">
-                <a16:creationId xmlns:a16="http://schemas.microsoft.com/office/drawing/2014/main" id="{42727C48-3945-DC5A-667C-3C1EFF5EE04C}"/>
+                <a16:creationId xmlns:a16="http://schemas.microsoft.com/office/drawing/2014/main" id="{71BCE93B-27C0-D833-095C-26B19489496E}"/>
               </a:ext>
             </a:extLst>
           </p:cNvPr>
@@ -20725,7 +20725,7 @@
           <p:cNvPr id="9" name="TextBox 8">
             <a:extLst>
               <a:ext uri="{FF2B5EF4-FFF2-40B4-BE49-F238E27FC236}">
-                <a16:creationId xmlns:a16="http://schemas.microsoft.com/office/drawing/2014/main" id="{15C1A860-8016-B0AF-39C8-9E1ED7BADDAB}"/>
+                <a16:creationId xmlns:a16="http://schemas.microsoft.com/office/drawing/2014/main" id="{E4E9A772-82F5-B443-10E9-5BF0B263588A}"/>
               </a:ext>
             </a:extLst>
           </p:cNvPr>
@@ -20765,7 +20765,7 @@
           <p:cNvPr id="10" name="Rectangle: Rounded Corners 9">
             <a:extLst>
               <a:ext uri="{FF2B5EF4-FFF2-40B4-BE49-F238E27FC236}">
-                <a16:creationId xmlns:a16="http://schemas.microsoft.com/office/drawing/2014/main" id="{AE9836BD-F544-C3EF-1E10-E5E0B32C7172}"/>
+                <a16:creationId xmlns:a16="http://schemas.microsoft.com/office/drawing/2014/main" id="{BB3FF37F-DA34-2FF5-715E-D57D9187B541}"/>
               </a:ext>
             </a:extLst>
           </p:cNvPr>
@@ -20827,7 +20827,7 @@
           <p:cNvPr id="11" name="TextBox 10">
             <a:extLst>
               <a:ext uri="{FF2B5EF4-FFF2-40B4-BE49-F238E27FC236}">
-                <a16:creationId xmlns:a16="http://schemas.microsoft.com/office/drawing/2014/main" id="{F311637B-50FB-7727-706A-713072C7DDAC}"/>
+                <a16:creationId xmlns:a16="http://schemas.microsoft.com/office/drawing/2014/main" id="{072CF7A3-F530-DEDD-A272-2E279694CCE4}"/>
               </a:ext>
             </a:extLst>
           </p:cNvPr>
@@ -20873,7 +20873,7 @@
           <p:cNvPr id="12" name="Rectangle 11">
             <a:extLst>
               <a:ext uri="{FF2B5EF4-FFF2-40B4-BE49-F238E27FC236}">
-                <a16:creationId xmlns:a16="http://schemas.microsoft.com/office/drawing/2014/main" id="{8A49D0B7-0193-9B36-5470-C908F95CB56B}"/>
+                <a16:creationId xmlns:a16="http://schemas.microsoft.com/office/drawing/2014/main" id="{9BAF4E3D-5B20-0C38-DB94-2045FA087273}"/>
               </a:ext>
             </a:extLst>
           </p:cNvPr>
@@ -20941,7 +20941,7 @@
           <p:cNvPr id="13" name="TextBox 12">
             <a:extLst>
               <a:ext uri="{FF2B5EF4-FFF2-40B4-BE49-F238E27FC236}">
-                <a16:creationId xmlns:a16="http://schemas.microsoft.com/office/drawing/2014/main" id="{AE209BBF-13B6-4CB9-1408-258F0E9E5F1C}"/>
+                <a16:creationId xmlns:a16="http://schemas.microsoft.com/office/drawing/2014/main" id="{A9758414-BA4E-2B24-F64A-5B9C425FA3BD}"/>
               </a:ext>
             </a:extLst>
           </p:cNvPr>
@@ -20987,7 +20987,7 @@
           <p:cNvPr id="14" name="Rectangle: Rounded Corners 13">
             <a:extLst>
               <a:ext uri="{FF2B5EF4-FFF2-40B4-BE49-F238E27FC236}">
-                <a16:creationId xmlns:a16="http://schemas.microsoft.com/office/drawing/2014/main" id="{C0415D00-6858-5E44-3314-1E8D1CC43CA6}"/>
+                <a16:creationId xmlns:a16="http://schemas.microsoft.com/office/drawing/2014/main" id="{1496C5A2-A42B-0670-4314-6BC783B51973}"/>
               </a:ext>
             </a:extLst>
           </p:cNvPr>
@@ -21041,7 +21041,7 @@
           <p:cNvPr id="15" name="Pentagon 14">
             <a:extLst>
               <a:ext uri="{FF2B5EF4-FFF2-40B4-BE49-F238E27FC236}">
-                <a16:creationId xmlns:a16="http://schemas.microsoft.com/office/drawing/2014/main" id="{3713948D-7D0D-AC2C-D552-1772D7010E9F}"/>
+                <a16:creationId xmlns:a16="http://schemas.microsoft.com/office/drawing/2014/main" id="{78AA2857-E3C4-26B1-CE2C-534F61489CC3}"/>
               </a:ext>
             </a:extLst>
           </p:cNvPr>
@@ -21095,7 +21095,7 @@
           <p:cNvPr id="16" name="Pentagon 15">
             <a:extLst>
               <a:ext uri="{FF2B5EF4-FFF2-40B4-BE49-F238E27FC236}">
-                <a16:creationId xmlns:a16="http://schemas.microsoft.com/office/drawing/2014/main" id="{5BF755BF-BE3C-795A-47FD-74CC805A8192}"/>
+                <a16:creationId xmlns:a16="http://schemas.microsoft.com/office/drawing/2014/main" id="{A04B34CD-B55A-B709-EDEC-EF354E8CD06C}"/>
               </a:ext>
             </a:extLst>
           </p:cNvPr>
@@ -21149,7 +21149,7 @@
           <p:cNvPr id="17" name="Pentagon 16">
             <a:extLst>
               <a:ext uri="{FF2B5EF4-FFF2-40B4-BE49-F238E27FC236}">
-                <a16:creationId xmlns:a16="http://schemas.microsoft.com/office/drawing/2014/main" id="{0110BAC2-C285-0488-A23B-0839A6C0F1E9}"/>
+                <a16:creationId xmlns:a16="http://schemas.microsoft.com/office/drawing/2014/main" id="{D1956B1F-0EE8-4E67-5B6B-2D64EEBBA958}"/>
               </a:ext>
             </a:extLst>
           </p:cNvPr>
@@ -21203,7 +21203,7 @@
           <p:cNvPr id="18" name="Pentagon 17">
             <a:extLst>
               <a:ext uri="{FF2B5EF4-FFF2-40B4-BE49-F238E27FC236}">
-                <a16:creationId xmlns:a16="http://schemas.microsoft.com/office/drawing/2014/main" id="{9AC64A84-0EDA-4A8E-64C7-02E70E17D2AF}"/>
+                <a16:creationId xmlns:a16="http://schemas.microsoft.com/office/drawing/2014/main" id="{BE7533F7-D569-844C-1A5D-FE553A9E5E22}"/>
               </a:ext>
             </a:extLst>
           </p:cNvPr>
@@ -21257,7 +21257,7 @@
           <p:cNvPr id="20" name="Picture 19">
             <a:extLst>
               <a:ext uri="{FF2B5EF4-FFF2-40B4-BE49-F238E27FC236}">
-                <a16:creationId xmlns:a16="http://schemas.microsoft.com/office/drawing/2014/main" id="{14437663-4AFB-9DE5-E404-87971DE09A27}"/>
+                <a16:creationId xmlns:a16="http://schemas.microsoft.com/office/drawing/2014/main" id="{AC405B0F-026C-FCBB-8A96-76EE99481B36}"/>
               </a:ext>
             </a:extLst>
           </p:cNvPr>
@@ -21293,7 +21293,7 @@
           <p:cNvPr id="21" name="Rectangle: Rounded Corners 20">
             <a:extLst>
               <a:ext uri="{FF2B5EF4-FFF2-40B4-BE49-F238E27FC236}">
-                <a16:creationId xmlns:a16="http://schemas.microsoft.com/office/drawing/2014/main" id="{9230990D-1B80-23AD-A0EC-10375C02E6B7}"/>
+                <a16:creationId xmlns:a16="http://schemas.microsoft.com/office/drawing/2014/main" id="{D15DF9D5-1FFD-FDB4-856B-6C8ED97D8326}"/>
               </a:ext>
             </a:extLst>
           </p:cNvPr>
@@ -21355,7 +21355,7 @@
           <p:cNvPr id="22" name="TextBox 21">
             <a:extLst>
               <a:ext uri="{FF2B5EF4-FFF2-40B4-BE49-F238E27FC236}">
-                <a16:creationId xmlns:a16="http://schemas.microsoft.com/office/drawing/2014/main" id="{4FB0DB10-B07A-E33A-3BEB-F2F11CF4B99E}"/>
+                <a16:creationId xmlns:a16="http://schemas.microsoft.com/office/drawing/2014/main" id="{638D4005-127A-BEFB-0A71-84AF2CF2F69B}"/>
               </a:ext>
             </a:extLst>
           </p:cNvPr>
@@ -21401,7 +21401,7 @@
           <p:cNvPr id="23" name="Rectangle: Rounded Corners 22">
             <a:extLst>
               <a:ext uri="{FF2B5EF4-FFF2-40B4-BE49-F238E27FC236}">
-                <a16:creationId xmlns:a16="http://schemas.microsoft.com/office/drawing/2014/main" id="{C631343F-BF8A-A1E7-2821-9AED04519040}"/>
+                <a16:creationId xmlns:a16="http://schemas.microsoft.com/office/drawing/2014/main" id="{2FA79E4C-6043-8C8C-2D42-FECD96AD3BD4}"/>
               </a:ext>
             </a:extLst>
           </p:cNvPr>
@@ -21479,7 +21479,7 @@
           <p:cNvPr id="27" name="Group 26">
             <a:extLst>
               <a:ext uri="{FF2B5EF4-FFF2-40B4-BE49-F238E27FC236}">
-                <a16:creationId xmlns:a16="http://schemas.microsoft.com/office/drawing/2014/main" id="{771555FF-46E8-FA87-6618-952EE854D479}"/>
+                <a16:creationId xmlns:a16="http://schemas.microsoft.com/office/drawing/2014/main" id="{639AE680-62C0-3A51-95DF-BFEE4EF8D164}"/>
               </a:ext>
             </a:extLst>
           </p:cNvPr>
@@ -21499,7 +21499,7 @@
             <p:cNvPr id="24" name="Rectangle: Rounded Corners 23">
               <a:extLst>
                 <a:ext uri="{FF2B5EF4-FFF2-40B4-BE49-F238E27FC236}">
-                  <a16:creationId xmlns:a16="http://schemas.microsoft.com/office/drawing/2014/main" id="{28B295AE-68CD-EE4E-C5D0-86713DF16B75}"/>
+                  <a16:creationId xmlns:a16="http://schemas.microsoft.com/office/drawing/2014/main" id="{9CD759B4-30B6-700C-A9A6-1A3D52DEFDE5}"/>
                 </a:ext>
               </a:extLst>
             </p:cNvPr>
@@ -21553,7 +21553,7 @@
             <p:cNvPr id="25" name="Rectangle: Rounded Corners 24">
               <a:extLst>
                 <a:ext uri="{FF2B5EF4-FFF2-40B4-BE49-F238E27FC236}">
-                  <a16:creationId xmlns:a16="http://schemas.microsoft.com/office/drawing/2014/main" id="{A569399E-7416-60CA-E264-838AA9C183FC}"/>
+                  <a16:creationId xmlns:a16="http://schemas.microsoft.com/office/drawing/2014/main" id="{48E87906-4361-F0B6-AA25-73DB7D59C355}"/>
                 </a:ext>
               </a:extLst>
             </p:cNvPr>
@@ -21615,7 +21615,7 @@
             <p:cNvPr id="26" name="TextBox 25">
               <a:extLst>
                 <a:ext uri="{FF2B5EF4-FFF2-40B4-BE49-F238E27FC236}">
-                  <a16:creationId xmlns:a16="http://schemas.microsoft.com/office/drawing/2014/main" id="{7A4FFB99-9820-E501-D5F4-5533A372B4A0}"/>
+                  <a16:creationId xmlns:a16="http://schemas.microsoft.com/office/drawing/2014/main" id="{EE5F6A85-50E6-4112-AEFB-0DAA31D53E81}"/>
                 </a:ext>
               </a:extLst>
             </p:cNvPr>
@@ -21662,7 +21662,7 @@
           <p:cNvPr id="31" name="Group 30">
             <a:extLst>
               <a:ext uri="{FF2B5EF4-FFF2-40B4-BE49-F238E27FC236}">
-                <a16:creationId xmlns:a16="http://schemas.microsoft.com/office/drawing/2014/main" id="{0DE3C9CC-B605-8CB3-8245-9EF1A1A78320}"/>
+                <a16:creationId xmlns:a16="http://schemas.microsoft.com/office/drawing/2014/main" id="{1C9FA3BC-3F97-D1E1-7EB3-1ADA7144E51E}"/>
               </a:ext>
             </a:extLst>
           </p:cNvPr>
@@ -21682,7 +21682,7 @@
             <p:cNvPr id="28" name="Rectangle: Rounded Corners 27">
               <a:extLst>
                 <a:ext uri="{FF2B5EF4-FFF2-40B4-BE49-F238E27FC236}">
-                  <a16:creationId xmlns:a16="http://schemas.microsoft.com/office/drawing/2014/main" id="{EC4C6FE9-2D87-3683-F9AD-3076786CB78F}"/>
+                  <a16:creationId xmlns:a16="http://schemas.microsoft.com/office/drawing/2014/main" id="{C29D464A-459E-8EF3-59B1-CBE323C75550}"/>
                 </a:ext>
               </a:extLst>
             </p:cNvPr>
@@ -21736,7 +21736,7 @@
             <p:cNvPr id="29" name="Rectangle: Rounded Corners 28">
               <a:extLst>
                 <a:ext uri="{FF2B5EF4-FFF2-40B4-BE49-F238E27FC236}">
-                  <a16:creationId xmlns:a16="http://schemas.microsoft.com/office/drawing/2014/main" id="{8716404F-C8EB-55CF-8AA0-66FCDF298D5C}"/>
+                  <a16:creationId xmlns:a16="http://schemas.microsoft.com/office/drawing/2014/main" id="{47D2AF82-BDFF-9B5F-C26D-7B3DA1ECCC64}"/>
                 </a:ext>
               </a:extLst>
             </p:cNvPr>
@@ -21798,7 +21798,7 @@
             <p:cNvPr id="30" name="TextBox 29">
               <a:extLst>
                 <a:ext uri="{FF2B5EF4-FFF2-40B4-BE49-F238E27FC236}">
-                  <a16:creationId xmlns:a16="http://schemas.microsoft.com/office/drawing/2014/main" id="{0507A841-C784-F372-1498-59004B6922D2}"/>
+                  <a16:creationId xmlns:a16="http://schemas.microsoft.com/office/drawing/2014/main" id="{A8D2AB49-4C0E-5990-E287-3685947F8852}"/>
                 </a:ext>
               </a:extLst>
             </p:cNvPr>
@@ -21845,7 +21845,7 @@
           <p:cNvPr id="35" name="Group 34">
             <a:extLst>
               <a:ext uri="{FF2B5EF4-FFF2-40B4-BE49-F238E27FC236}">
-                <a16:creationId xmlns:a16="http://schemas.microsoft.com/office/drawing/2014/main" id="{F9C487DD-18E7-53F6-667F-8D4C9BF6CC78}"/>
+                <a16:creationId xmlns:a16="http://schemas.microsoft.com/office/drawing/2014/main" id="{81882FBE-3212-0813-9A10-64841761C535}"/>
               </a:ext>
             </a:extLst>
           </p:cNvPr>
@@ -21865,7 +21865,7 @@
             <p:cNvPr id="32" name="Rectangle: Rounded Corners 31">
               <a:extLst>
                 <a:ext uri="{FF2B5EF4-FFF2-40B4-BE49-F238E27FC236}">
-                  <a16:creationId xmlns:a16="http://schemas.microsoft.com/office/drawing/2014/main" id="{89B531CD-A8F8-1E82-CB4B-3B54DB76DE7C}"/>
+                  <a16:creationId xmlns:a16="http://schemas.microsoft.com/office/drawing/2014/main" id="{AF4B1764-707D-3611-662D-FADCF126B97A}"/>
                 </a:ext>
               </a:extLst>
             </p:cNvPr>
@@ -21919,7 +21919,7 @@
             <p:cNvPr id="33" name="Rectangle: Rounded Corners 32">
               <a:extLst>
                 <a:ext uri="{FF2B5EF4-FFF2-40B4-BE49-F238E27FC236}">
-                  <a16:creationId xmlns:a16="http://schemas.microsoft.com/office/drawing/2014/main" id="{0E08CDE7-6650-4FF7-881A-FF414443240B}"/>
+                  <a16:creationId xmlns:a16="http://schemas.microsoft.com/office/drawing/2014/main" id="{C2E9D7AE-9450-4E18-298F-715A2D27423A}"/>
                 </a:ext>
               </a:extLst>
             </p:cNvPr>
@@ -21981,7 +21981,7 @@
             <p:cNvPr id="34" name="TextBox 33">
               <a:extLst>
                 <a:ext uri="{FF2B5EF4-FFF2-40B4-BE49-F238E27FC236}">
-                  <a16:creationId xmlns:a16="http://schemas.microsoft.com/office/drawing/2014/main" id="{1511FE25-A5E1-1A4A-AFE3-BB911057CA68}"/>
+                  <a16:creationId xmlns:a16="http://schemas.microsoft.com/office/drawing/2014/main" id="{B99D081F-2C63-82EA-7EE9-9283D7CBD26A}"/>
                 </a:ext>
               </a:extLst>
             </p:cNvPr>
@@ -22028,7 +22028,7 @@
           <p:cNvPr id="36" name="Rectangle 35">
             <a:extLst>
               <a:ext uri="{FF2B5EF4-FFF2-40B4-BE49-F238E27FC236}">
-                <a16:creationId xmlns:a16="http://schemas.microsoft.com/office/drawing/2014/main" id="{52E74800-606F-CE9D-F080-4A0514E58A83}"/>
+                <a16:creationId xmlns:a16="http://schemas.microsoft.com/office/drawing/2014/main" id="{1DDDE9BC-2C62-C335-07DC-F0CF2917739F}"/>
               </a:ext>
             </a:extLst>
           </p:cNvPr>
@@ -22096,7 +22096,7 @@
           <p:cNvPr id="37" name="TextBox 36">
             <a:extLst>
               <a:ext uri="{FF2B5EF4-FFF2-40B4-BE49-F238E27FC236}">
-                <a16:creationId xmlns:a16="http://schemas.microsoft.com/office/drawing/2014/main" id="{B7444485-9DAC-533D-C785-55C978D5FE3F}"/>
+                <a16:creationId xmlns:a16="http://schemas.microsoft.com/office/drawing/2014/main" id="{B169C247-BBD8-0FC6-F916-D9CAFFF882A6}"/>
               </a:ext>
             </a:extLst>
           </p:cNvPr>
@@ -22136,7 +22136,7 @@
           <p:cNvPr id="38" name="TextBox 37">
             <a:extLst>
               <a:ext uri="{FF2B5EF4-FFF2-40B4-BE49-F238E27FC236}">
-                <a16:creationId xmlns:a16="http://schemas.microsoft.com/office/drawing/2014/main" id="{9C5E6125-6C0B-F6D4-F70D-BD937F023525}"/>
+                <a16:creationId xmlns:a16="http://schemas.microsoft.com/office/drawing/2014/main" id="{95025A48-BC63-18BC-E07F-46DC6F59B5AC}"/>
               </a:ext>
             </a:extLst>
           </p:cNvPr>
@@ -22177,7 +22177,7 @@
           <p:cNvPr id="39" name="TextBox 38">
             <a:extLst>
               <a:ext uri="{FF2B5EF4-FFF2-40B4-BE49-F238E27FC236}">
-                <a16:creationId xmlns:a16="http://schemas.microsoft.com/office/drawing/2014/main" id="{364C69D5-6648-ED7E-B2BD-057A2474A4AA}"/>
+                <a16:creationId xmlns:a16="http://schemas.microsoft.com/office/drawing/2014/main" id="{966EE616-F8B9-5972-E40E-16A3A5453BFB}"/>
               </a:ext>
             </a:extLst>
           </p:cNvPr>
@@ -22216,7 +22216,7 @@
     </p:spTree>
     <p:extLst>
       <p:ext uri="{BB962C8B-B14F-4D97-AF65-F5344CB8AC3E}">
-        <p14:creationId xmlns:p14="http://schemas.microsoft.com/office/powerpoint/2010/main" val="1329577056"/>
+        <p14:creationId xmlns:p14="http://schemas.microsoft.com/office/powerpoint/2010/main" val="3362297244"/>
       </p:ext>
     </p:extLst>
   </p:cSld>
@@ -22472,7 +22472,7 @@
           <p:cNvPr id="2" name="Rectangle 1">
             <a:extLst>
               <a:ext uri="{FF2B5EF4-FFF2-40B4-BE49-F238E27FC236}">
-                <a16:creationId xmlns:a16="http://schemas.microsoft.com/office/drawing/2014/main" id="{DF00833B-0FB6-F114-CD2D-1BB9C8B8C4C9}"/>
+                <a16:creationId xmlns:a16="http://schemas.microsoft.com/office/drawing/2014/main" id="{1490F33F-EE4C-C8AC-3809-F2E13FD6E5A1}"/>
               </a:ext>
             </a:extLst>
           </p:cNvPr>
@@ -22540,7 +22540,7 @@
           <p:cNvPr id="3" name="Rectangle: Rounded Corners 2">
             <a:extLst>
               <a:ext uri="{FF2B5EF4-FFF2-40B4-BE49-F238E27FC236}">
-                <a16:creationId xmlns:a16="http://schemas.microsoft.com/office/drawing/2014/main" id="{B2B913DA-9377-DF67-B8F4-9C3709BEF063}"/>
+                <a16:creationId xmlns:a16="http://schemas.microsoft.com/office/drawing/2014/main" id="{7170F5F8-6D38-55B7-B22B-71EFB78B41E6}"/>
               </a:ext>
             </a:extLst>
           </p:cNvPr>
@@ -22594,7 +22594,7 @@
           <p:cNvPr id="4" name="Rectangle: Rounded Corners 3">
             <a:extLst>
               <a:ext uri="{FF2B5EF4-FFF2-40B4-BE49-F238E27FC236}">
-                <a16:creationId xmlns:a16="http://schemas.microsoft.com/office/drawing/2014/main" id="{9EB30012-BE62-D938-5BE9-B81E5BBFCB43}"/>
+                <a16:creationId xmlns:a16="http://schemas.microsoft.com/office/drawing/2014/main" id="{65ECE89E-26A4-81D1-9AED-3B63F9000D82}"/>
               </a:ext>
             </a:extLst>
           </p:cNvPr>
@@ -22645,7 +22645,7 @@
           <p:cNvPr id="5" name="TextBox 4">
             <a:extLst>
               <a:ext uri="{FF2B5EF4-FFF2-40B4-BE49-F238E27FC236}">
-                <a16:creationId xmlns:a16="http://schemas.microsoft.com/office/drawing/2014/main" id="{3BAD93CB-3063-B6FB-E3A5-4E50E0E80C37}"/>
+                <a16:creationId xmlns:a16="http://schemas.microsoft.com/office/drawing/2014/main" id="{BE0D4DC1-F527-AFE0-FF49-443B229D6290}"/>
               </a:ext>
             </a:extLst>
           </p:cNvPr>
@@ -22685,7 +22685,7 @@
           <p:cNvPr id="6" name="TextBox 5">
             <a:extLst>
               <a:ext uri="{FF2B5EF4-FFF2-40B4-BE49-F238E27FC236}">
-                <a16:creationId xmlns:a16="http://schemas.microsoft.com/office/drawing/2014/main" id="{70629593-E69D-AE8D-FCC2-A7B3069ACE77}"/>
+                <a16:creationId xmlns:a16="http://schemas.microsoft.com/office/drawing/2014/main" id="{45530300-9B44-0E70-A5FF-B05706283952}"/>
               </a:ext>
             </a:extLst>
           </p:cNvPr>
@@ -22725,7 +22725,7 @@
           <p:cNvPr id="7" name="TextBox 6">
             <a:extLst>
               <a:ext uri="{FF2B5EF4-FFF2-40B4-BE49-F238E27FC236}">
-                <a16:creationId xmlns:a16="http://schemas.microsoft.com/office/drawing/2014/main" id="{E382B04D-33AA-84E6-534C-1A843A5630D4}"/>
+                <a16:creationId xmlns:a16="http://schemas.microsoft.com/office/drawing/2014/main" id="{56E29BE3-5377-DE22-A94D-225D0513AF49}"/>
               </a:ext>
             </a:extLst>
           </p:cNvPr>
@@ -22765,7 +22765,7 @@
           <p:cNvPr id="8" name="TextBox 7">
             <a:extLst>
               <a:ext uri="{FF2B5EF4-FFF2-40B4-BE49-F238E27FC236}">
-                <a16:creationId xmlns:a16="http://schemas.microsoft.com/office/drawing/2014/main" id="{93B2E012-DA82-F662-21C3-C4404E588565}"/>
+                <a16:creationId xmlns:a16="http://schemas.microsoft.com/office/drawing/2014/main" id="{9A44C1C9-D09C-CDA7-2AFB-51B390731820}"/>
               </a:ext>
             </a:extLst>
           </p:cNvPr>
@@ -22805,7 +22805,7 @@
           <p:cNvPr id="9" name="TextBox 8">
             <a:extLst>
               <a:ext uri="{FF2B5EF4-FFF2-40B4-BE49-F238E27FC236}">
-                <a16:creationId xmlns:a16="http://schemas.microsoft.com/office/drawing/2014/main" id="{9E0F2572-531C-A0F3-395A-8CD16CC10520}"/>
+                <a16:creationId xmlns:a16="http://schemas.microsoft.com/office/drawing/2014/main" id="{4BC96EC6-D4E3-7C7F-EB40-708891863483}"/>
               </a:ext>
             </a:extLst>
           </p:cNvPr>
@@ -22845,7 +22845,7 @@
           <p:cNvPr id="10" name="Rectangle: Rounded Corners 9">
             <a:extLst>
               <a:ext uri="{FF2B5EF4-FFF2-40B4-BE49-F238E27FC236}">
-                <a16:creationId xmlns:a16="http://schemas.microsoft.com/office/drawing/2014/main" id="{55BBC14E-1FED-1D54-2516-DA572BA0BFBC}"/>
+                <a16:creationId xmlns:a16="http://schemas.microsoft.com/office/drawing/2014/main" id="{A41C2928-3087-F633-2715-C9F77F7DC753}"/>
               </a:ext>
             </a:extLst>
           </p:cNvPr>
@@ -22907,7 +22907,7 @@
           <p:cNvPr id="11" name="TextBox 10">
             <a:extLst>
               <a:ext uri="{FF2B5EF4-FFF2-40B4-BE49-F238E27FC236}">
-                <a16:creationId xmlns:a16="http://schemas.microsoft.com/office/drawing/2014/main" id="{DDC5E802-EA90-7A26-A384-ABD175B01C46}"/>
+                <a16:creationId xmlns:a16="http://schemas.microsoft.com/office/drawing/2014/main" id="{1128F297-BA16-2D94-191D-9E6701D8AEF3}"/>
               </a:ext>
             </a:extLst>
           </p:cNvPr>
@@ -22947,7 +22947,7 @@
           <p:cNvPr id="12" name="Rectangle 11">
             <a:extLst>
               <a:ext uri="{FF2B5EF4-FFF2-40B4-BE49-F238E27FC236}">
-                <a16:creationId xmlns:a16="http://schemas.microsoft.com/office/drawing/2014/main" id="{089C0C1E-CF6B-28FA-8877-0A826BC53738}"/>
+                <a16:creationId xmlns:a16="http://schemas.microsoft.com/office/drawing/2014/main" id="{C67AABB3-7EFE-F28F-D722-6DD0CE0E619B}"/>
               </a:ext>
             </a:extLst>
           </p:cNvPr>
@@ -23015,7 +23015,7 @@
           <p:cNvPr id="13" name="TextBox 12">
             <a:extLst>
               <a:ext uri="{FF2B5EF4-FFF2-40B4-BE49-F238E27FC236}">
-                <a16:creationId xmlns:a16="http://schemas.microsoft.com/office/drawing/2014/main" id="{2E755B44-E5BD-98ED-4FC8-C6CF3ED00E5D}"/>
+                <a16:creationId xmlns:a16="http://schemas.microsoft.com/office/drawing/2014/main" id="{7CF8E8F9-5708-B285-3022-5B53D0E8A55E}"/>
               </a:ext>
             </a:extLst>
           </p:cNvPr>
@@ -23061,7 +23061,7 @@
           <p:cNvPr id="14" name="Rectangle: Rounded Corners 13">
             <a:extLst>
               <a:ext uri="{FF2B5EF4-FFF2-40B4-BE49-F238E27FC236}">
-                <a16:creationId xmlns:a16="http://schemas.microsoft.com/office/drawing/2014/main" id="{C2A03F1E-2F6B-7273-E6FF-60C6D811B337}"/>
+                <a16:creationId xmlns:a16="http://schemas.microsoft.com/office/drawing/2014/main" id="{56D3D2FB-7729-CCBA-2CB7-510DED0D9193}"/>
               </a:ext>
             </a:extLst>
           </p:cNvPr>
@@ -23115,7 +23115,7 @@
           <p:cNvPr id="15" name="Pentagon 14">
             <a:extLst>
               <a:ext uri="{FF2B5EF4-FFF2-40B4-BE49-F238E27FC236}">
-                <a16:creationId xmlns:a16="http://schemas.microsoft.com/office/drawing/2014/main" id="{126EF868-853E-BBCC-7477-5BCA29675E90}"/>
+                <a16:creationId xmlns:a16="http://schemas.microsoft.com/office/drawing/2014/main" id="{FC2AFC5F-E507-BDFC-77FE-ACC5AA306246}"/>
               </a:ext>
             </a:extLst>
           </p:cNvPr>
@@ -23169,7 +23169,7 @@
           <p:cNvPr id="16" name="Pentagon 15">
             <a:extLst>
               <a:ext uri="{FF2B5EF4-FFF2-40B4-BE49-F238E27FC236}">
-                <a16:creationId xmlns:a16="http://schemas.microsoft.com/office/drawing/2014/main" id="{B74E8E9E-1EA8-8049-EF94-1D53741C6647}"/>
+                <a16:creationId xmlns:a16="http://schemas.microsoft.com/office/drawing/2014/main" id="{74D016EF-4951-6A1D-25CF-8C35864C955F}"/>
               </a:ext>
             </a:extLst>
           </p:cNvPr>
@@ -23223,7 +23223,7 @@
           <p:cNvPr id="17" name="Pentagon 16">
             <a:extLst>
               <a:ext uri="{FF2B5EF4-FFF2-40B4-BE49-F238E27FC236}">
-                <a16:creationId xmlns:a16="http://schemas.microsoft.com/office/drawing/2014/main" id="{6D010245-25EA-45C6-0B85-321F5FF1B049}"/>
+                <a16:creationId xmlns:a16="http://schemas.microsoft.com/office/drawing/2014/main" id="{3BC86E9C-F0F8-A0CF-80A2-ADD2F73D88E6}"/>
               </a:ext>
             </a:extLst>
           </p:cNvPr>
@@ -23277,7 +23277,7 @@
           <p:cNvPr id="18" name="Pentagon 17">
             <a:extLst>
               <a:ext uri="{FF2B5EF4-FFF2-40B4-BE49-F238E27FC236}">
-                <a16:creationId xmlns:a16="http://schemas.microsoft.com/office/drawing/2014/main" id="{F44AC082-59D2-5C1F-7F5B-C022480CC788}"/>
+                <a16:creationId xmlns:a16="http://schemas.microsoft.com/office/drawing/2014/main" id="{C54FC23C-4C85-58BA-3673-31244DA3E937}"/>
               </a:ext>
             </a:extLst>
           </p:cNvPr>
@@ -23331,7 +23331,7 @@
           <p:cNvPr id="20" name="Picture 19">
             <a:extLst>
               <a:ext uri="{FF2B5EF4-FFF2-40B4-BE49-F238E27FC236}">
-                <a16:creationId xmlns:a16="http://schemas.microsoft.com/office/drawing/2014/main" id="{60783C27-8421-7453-8F6E-D47AC683FEC5}"/>
+                <a16:creationId xmlns:a16="http://schemas.microsoft.com/office/drawing/2014/main" id="{BAA43D81-FF66-1F5C-2F43-DDA9921A135F}"/>
               </a:ext>
             </a:extLst>
           </p:cNvPr>
@@ -23367,7 +23367,7 @@
           <p:cNvPr id="21" name="Rectangle: Rounded Corners 20">
             <a:extLst>
               <a:ext uri="{FF2B5EF4-FFF2-40B4-BE49-F238E27FC236}">
-                <a16:creationId xmlns:a16="http://schemas.microsoft.com/office/drawing/2014/main" id="{C4F0CBEB-CD45-5C81-6B7C-9545918838F8}"/>
+                <a16:creationId xmlns:a16="http://schemas.microsoft.com/office/drawing/2014/main" id="{E538ABE7-ECD4-4B9F-FEE4-06779D695902}"/>
               </a:ext>
             </a:extLst>
           </p:cNvPr>
@@ -23429,7 +23429,7 @@
           <p:cNvPr id="22" name="TextBox 21">
             <a:extLst>
               <a:ext uri="{FF2B5EF4-FFF2-40B4-BE49-F238E27FC236}">
-                <a16:creationId xmlns:a16="http://schemas.microsoft.com/office/drawing/2014/main" id="{6662BC93-2F28-19DA-DBEA-F2D5EC3080FB}"/>
+                <a16:creationId xmlns:a16="http://schemas.microsoft.com/office/drawing/2014/main" id="{63A44139-5125-95C4-287E-9A1DF23076A5}"/>
               </a:ext>
             </a:extLst>
           </p:cNvPr>
@@ -23469,7 +23469,7 @@
           <p:cNvPr id="23" name="Rectangle: Rounded Corners 22">
             <a:extLst>
               <a:ext uri="{FF2B5EF4-FFF2-40B4-BE49-F238E27FC236}">
-                <a16:creationId xmlns:a16="http://schemas.microsoft.com/office/drawing/2014/main" id="{59E93530-30DE-7D3D-5FFE-9B319206C909}"/>
+                <a16:creationId xmlns:a16="http://schemas.microsoft.com/office/drawing/2014/main" id="{4B4ECA7B-CC74-D037-5587-23F43CEB44FE}"/>
               </a:ext>
             </a:extLst>
           </p:cNvPr>
@@ -23547,7 +23547,7 @@
           <p:cNvPr id="27" name="Group 26">
             <a:extLst>
               <a:ext uri="{FF2B5EF4-FFF2-40B4-BE49-F238E27FC236}">
-                <a16:creationId xmlns:a16="http://schemas.microsoft.com/office/drawing/2014/main" id="{31FD0E78-34EA-0352-A776-0604902954D3}"/>
+                <a16:creationId xmlns:a16="http://schemas.microsoft.com/office/drawing/2014/main" id="{9C184BE6-3E2F-96C0-5F51-B7DF01E37CD3}"/>
               </a:ext>
             </a:extLst>
           </p:cNvPr>
@@ -23567,7 +23567,7 @@
             <p:cNvPr id="24" name="Rectangle: Rounded Corners 23">
               <a:extLst>
                 <a:ext uri="{FF2B5EF4-FFF2-40B4-BE49-F238E27FC236}">
-                  <a16:creationId xmlns:a16="http://schemas.microsoft.com/office/drawing/2014/main" id="{D5EA6691-594D-087F-35D1-BB5436A0B118}"/>
+                  <a16:creationId xmlns:a16="http://schemas.microsoft.com/office/drawing/2014/main" id="{30D6594E-1922-CABC-1365-C9CEE9C2C8DD}"/>
                 </a:ext>
               </a:extLst>
             </p:cNvPr>
@@ -23621,7 +23621,7 @@
             <p:cNvPr id="25" name="Rectangle: Rounded Corners 24">
               <a:extLst>
                 <a:ext uri="{FF2B5EF4-FFF2-40B4-BE49-F238E27FC236}">
-                  <a16:creationId xmlns:a16="http://schemas.microsoft.com/office/drawing/2014/main" id="{C63D0FBF-71E5-1077-773A-888E57710435}"/>
+                  <a16:creationId xmlns:a16="http://schemas.microsoft.com/office/drawing/2014/main" id="{539DF804-D691-F818-994B-A97EF9B0D7CD}"/>
                 </a:ext>
               </a:extLst>
             </p:cNvPr>
@@ -23683,7 +23683,7 @@
             <p:cNvPr id="26" name="TextBox 25">
               <a:extLst>
                 <a:ext uri="{FF2B5EF4-FFF2-40B4-BE49-F238E27FC236}">
-                  <a16:creationId xmlns:a16="http://schemas.microsoft.com/office/drawing/2014/main" id="{3C43AD9C-C0D7-292D-3635-BCB7DFB5078C}"/>
+                  <a16:creationId xmlns:a16="http://schemas.microsoft.com/office/drawing/2014/main" id="{F3AAAA6A-DFA1-BCF1-6EE7-F056F0018546}"/>
                 </a:ext>
               </a:extLst>
             </p:cNvPr>
@@ -23730,7 +23730,7 @@
           <p:cNvPr id="31" name="Group 30">
             <a:extLst>
               <a:ext uri="{FF2B5EF4-FFF2-40B4-BE49-F238E27FC236}">
-                <a16:creationId xmlns:a16="http://schemas.microsoft.com/office/drawing/2014/main" id="{684D2F58-EF00-8B48-7095-E8095445B67C}"/>
+                <a16:creationId xmlns:a16="http://schemas.microsoft.com/office/drawing/2014/main" id="{5D58E1D8-F2CC-4396-4376-A8D3F0DF1EE0}"/>
               </a:ext>
             </a:extLst>
           </p:cNvPr>
@@ -23750,7 +23750,7 @@
             <p:cNvPr id="28" name="Rectangle: Rounded Corners 27">
               <a:extLst>
                 <a:ext uri="{FF2B5EF4-FFF2-40B4-BE49-F238E27FC236}">
-                  <a16:creationId xmlns:a16="http://schemas.microsoft.com/office/drawing/2014/main" id="{E6AE1C4B-5829-45F1-17E5-8F691963E641}"/>
+                  <a16:creationId xmlns:a16="http://schemas.microsoft.com/office/drawing/2014/main" id="{EE83CCDD-1252-CE54-E524-558EAC6406C2}"/>
                 </a:ext>
               </a:extLst>
             </p:cNvPr>
@@ -23804,7 +23804,7 @@
             <p:cNvPr id="29" name="Rectangle: Rounded Corners 28">
               <a:extLst>
                 <a:ext uri="{FF2B5EF4-FFF2-40B4-BE49-F238E27FC236}">
-                  <a16:creationId xmlns:a16="http://schemas.microsoft.com/office/drawing/2014/main" id="{9B69584C-BC12-2EE8-C756-79D24320BF2D}"/>
+                  <a16:creationId xmlns:a16="http://schemas.microsoft.com/office/drawing/2014/main" id="{45B60D92-72E0-AC60-E46D-8A49BB2FF7EB}"/>
                 </a:ext>
               </a:extLst>
             </p:cNvPr>
@@ -23866,7 +23866,7 @@
             <p:cNvPr id="30" name="TextBox 29">
               <a:extLst>
                 <a:ext uri="{FF2B5EF4-FFF2-40B4-BE49-F238E27FC236}">
-                  <a16:creationId xmlns:a16="http://schemas.microsoft.com/office/drawing/2014/main" id="{207297E5-3D14-8C9B-848D-1CDBA2741410}"/>
+                  <a16:creationId xmlns:a16="http://schemas.microsoft.com/office/drawing/2014/main" id="{EAE08A22-0D83-1680-C3E6-F035354081A8}"/>
                 </a:ext>
               </a:extLst>
             </p:cNvPr>
@@ -23913,7 +23913,7 @@
           <p:cNvPr id="35" name="Group 34">
             <a:extLst>
               <a:ext uri="{FF2B5EF4-FFF2-40B4-BE49-F238E27FC236}">
-                <a16:creationId xmlns:a16="http://schemas.microsoft.com/office/drawing/2014/main" id="{FA74A4A9-3BA9-069B-F8DB-B0ED344CD4A1}"/>
+                <a16:creationId xmlns:a16="http://schemas.microsoft.com/office/drawing/2014/main" id="{26AED955-B628-CBA1-ADBE-BC013EAFAA0E}"/>
               </a:ext>
             </a:extLst>
           </p:cNvPr>
@@ -23933,7 +23933,7 @@
             <p:cNvPr id="32" name="Rectangle: Rounded Corners 31">
               <a:extLst>
                 <a:ext uri="{FF2B5EF4-FFF2-40B4-BE49-F238E27FC236}">
-                  <a16:creationId xmlns:a16="http://schemas.microsoft.com/office/drawing/2014/main" id="{4857E086-2CC1-BCF3-2DE7-B096F05300EB}"/>
+                  <a16:creationId xmlns:a16="http://schemas.microsoft.com/office/drawing/2014/main" id="{8AD69129-991F-4D02-5B70-BFFA8B6C4DC8}"/>
                 </a:ext>
               </a:extLst>
             </p:cNvPr>
@@ -23987,7 +23987,7 @@
             <p:cNvPr id="33" name="Rectangle: Rounded Corners 32">
               <a:extLst>
                 <a:ext uri="{FF2B5EF4-FFF2-40B4-BE49-F238E27FC236}">
-                  <a16:creationId xmlns:a16="http://schemas.microsoft.com/office/drawing/2014/main" id="{615FECC7-DA29-3AD0-C077-CC15BE8BC0CE}"/>
+                  <a16:creationId xmlns:a16="http://schemas.microsoft.com/office/drawing/2014/main" id="{F191823C-D44E-4D90-939E-9E7BC9F97684}"/>
                 </a:ext>
               </a:extLst>
             </p:cNvPr>
@@ -24049,7 +24049,7 @@
             <p:cNvPr id="34" name="TextBox 33">
               <a:extLst>
                 <a:ext uri="{FF2B5EF4-FFF2-40B4-BE49-F238E27FC236}">
-                  <a16:creationId xmlns:a16="http://schemas.microsoft.com/office/drawing/2014/main" id="{6BA9F8FD-FB06-8029-F21B-4940EB5B2922}"/>
+                  <a16:creationId xmlns:a16="http://schemas.microsoft.com/office/drawing/2014/main" id="{516305A1-CD86-3061-4FD3-AB5E67E1E970}"/>
                 </a:ext>
               </a:extLst>
             </p:cNvPr>
@@ -24096,7 +24096,7 @@
           <p:cNvPr id="39" name="Group 38">
             <a:extLst>
               <a:ext uri="{FF2B5EF4-FFF2-40B4-BE49-F238E27FC236}">
-                <a16:creationId xmlns:a16="http://schemas.microsoft.com/office/drawing/2014/main" id="{995996E7-19E2-7E06-03AD-3F007332DCAB}"/>
+                <a16:creationId xmlns:a16="http://schemas.microsoft.com/office/drawing/2014/main" id="{12586B2A-906D-FEC6-5A0F-C91F3D3AD25B}"/>
               </a:ext>
             </a:extLst>
           </p:cNvPr>
@@ -24116,7 +24116,7 @@
             <p:cNvPr id="36" name="Rectangle: Rounded Corners 35">
               <a:extLst>
                 <a:ext uri="{FF2B5EF4-FFF2-40B4-BE49-F238E27FC236}">
-                  <a16:creationId xmlns:a16="http://schemas.microsoft.com/office/drawing/2014/main" id="{63E4DCB7-6968-0878-B763-FAD1BC861B57}"/>
+                  <a16:creationId xmlns:a16="http://schemas.microsoft.com/office/drawing/2014/main" id="{3ABE9BDA-69B4-86FB-8D62-435F3E40818D}"/>
                 </a:ext>
               </a:extLst>
             </p:cNvPr>
@@ -24170,7 +24170,7 @@
             <p:cNvPr id="37" name="Rectangle: Rounded Corners 36">
               <a:extLst>
                 <a:ext uri="{FF2B5EF4-FFF2-40B4-BE49-F238E27FC236}">
-                  <a16:creationId xmlns:a16="http://schemas.microsoft.com/office/drawing/2014/main" id="{F4EECF19-0FB3-F056-79C2-03EF8B5B92DC}"/>
+                  <a16:creationId xmlns:a16="http://schemas.microsoft.com/office/drawing/2014/main" id="{CAE737ED-432A-1153-05EF-81483A691325}"/>
                 </a:ext>
               </a:extLst>
             </p:cNvPr>
@@ -24232,7 +24232,7 @@
             <p:cNvPr id="38" name="TextBox 37">
               <a:extLst>
                 <a:ext uri="{FF2B5EF4-FFF2-40B4-BE49-F238E27FC236}">
-                  <a16:creationId xmlns:a16="http://schemas.microsoft.com/office/drawing/2014/main" id="{E01549AF-2200-E323-55CD-37A15D11D98E}"/>
+                  <a16:creationId xmlns:a16="http://schemas.microsoft.com/office/drawing/2014/main" id="{D4529CC1-8D44-BC37-A32E-6E4BCD1CA9D6}"/>
                 </a:ext>
               </a:extLst>
             </p:cNvPr>
@@ -24279,7 +24279,7 @@
           <p:cNvPr id="40" name="Rectangle 39">
             <a:extLst>
               <a:ext uri="{FF2B5EF4-FFF2-40B4-BE49-F238E27FC236}">
-                <a16:creationId xmlns:a16="http://schemas.microsoft.com/office/drawing/2014/main" id="{ACBF6D8A-5D34-93B5-E21B-39105C460AD0}"/>
+                <a16:creationId xmlns:a16="http://schemas.microsoft.com/office/drawing/2014/main" id="{75EF83B9-A7C6-A036-EBBB-1B3320297B4C}"/>
               </a:ext>
             </a:extLst>
           </p:cNvPr>
@@ -24347,7 +24347,7 @@
           <p:cNvPr id="41" name="TextBox 40">
             <a:extLst>
               <a:ext uri="{FF2B5EF4-FFF2-40B4-BE49-F238E27FC236}">
-                <a16:creationId xmlns:a16="http://schemas.microsoft.com/office/drawing/2014/main" id="{948D95CF-35D2-43CA-494E-2BDA9A7DDB33}"/>
+                <a16:creationId xmlns:a16="http://schemas.microsoft.com/office/drawing/2014/main" id="{AFF53B7E-0150-9481-7E62-51F9024D3465}"/>
               </a:ext>
             </a:extLst>
           </p:cNvPr>
@@ -24387,7 +24387,7 @@
           <p:cNvPr id="42" name="TextBox 41">
             <a:extLst>
               <a:ext uri="{FF2B5EF4-FFF2-40B4-BE49-F238E27FC236}">
-                <a16:creationId xmlns:a16="http://schemas.microsoft.com/office/drawing/2014/main" id="{77B671E7-A194-25A5-1D77-1CD2F3C06B7C}"/>
+                <a16:creationId xmlns:a16="http://schemas.microsoft.com/office/drawing/2014/main" id="{C662E388-CBB2-0DED-AC6A-91C9C5424C27}"/>
               </a:ext>
             </a:extLst>
           </p:cNvPr>
@@ -24428,7 +24428,7 @@
           <p:cNvPr id="43" name="TextBox 42">
             <a:extLst>
               <a:ext uri="{FF2B5EF4-FFF2-40B4-BE49-F238E27FC236}">
-                <a16:creationId xmlns:a16="http://schemas.microsoft.com/office/drawing/2014/main" id="{988CF987-61DF-229E-6201-721F93968856}"/>
+                <a16:creationId xmlns:a16="http://schemas.microsoft.com/office/drawing/2014/main" id="{92C28C9B-FFCA-BAD5-6DA9-0CD7E682E20C}"/>
               </a:ext>
             </a:extLst>
           </p:cNvPr>
@@ -24467,7 +24467,7 @@
     </p:spTree>
     <p:extLst>
       <p:ext uri="{BB962C8B-B14F-4D97-AF65-F5344CB8AC3E}">
-        <p14:creationId xmlns:p14="http://schemas.microsoft.com/office/powerpoint/2010/main" val="2087430808"/>
+        <p14:creationId xmlns:p14="http://schemas.microsoft.com/office/powerpoint/2010/main" val="1358393892"/>
       </p:ext>
     </p:extLst>
   </p:cSld>
@@ -24767,7 +24767,7 @@
           <p:cNvPr id="2" name="Rectangle 1">
             <a:extLst>
               <a:ext uri="{FF2B5EF4-FFF2-40B4-BE49-F238E27FC236}">
-                <a16:creationId xmlns:a16="http://schemas.microsoft.com/office/drawing/2014/main" id="{01B026E5-964D-3259-CEC5-4AB986D22AB9}"/>
+                <a16:creationId xmlns:a16="http://schemas.microsoft.com/office/drawing/2014/main" id="{DFE78458-2C11-2F47-CE21-8DB7BB73692D}"/>
               </a:ext>
             </a:extLst>
           </p:cNvPr>
@@ -24835,7 +24835,7 @@
           <p:cNvPr id="3" name="Rectangle: Rounded Corners 2">
             <a:extLst>
               <a:ext uri="{FF2B5EF4-FFF2-40B4-BE49-F238E27FC236}">
-                <a16:creationId xmlns:a16="http://schemas.microsoft.com/office/drawing/2014/main" id="{84DE9CC9-2FEB-FAAD-1C76-53904DBFA5F8}"/>
+                <a16:creationId xmlns:a16="http://schemas.microsoft.com/office/drawing/2014/main" id="{9ACB4571-024E-96C1-B388-3641002DFDAC}"/>
               </a:ext>
             </a:extLst>
           </p:cNvPr>
@@ -24889,7 +24889,7 @@
           <p:cNvPr id="4" name="Rectangle: Rounded Corners 3">
             <a:extLst>
               <a:ext uri="{FF2B5EF4-FFF2-40B4-BE49-F238E27FC236}">
-                <a16:creationId xmlns:a16="http://schemas.microsoft.com/office/drawing/2014/main" id="{1BDD7997-1C34-2C5E-8833-F2AEA7655D7E}"/>
+                <a16:creationId xmlns:a16="http://schemas.microsoft.com/office/drawing/2014/main" id="{2AD8738E-CD2C-4F53-F231-E8985D1383FC}"/>
               </a:ext>
             </a:extLst>
           </p:cNvPr>
@@ -24940,7 +24940,7 @@
           <p:cNvPr id="5" name="TextBox 4">
             <a:extLst>
               <a:ext uri="{FF2B5EF4-FFF2-40B4-BE49-F238E27FC236}">
-                <a16:creationId xmlns:a16="http://schemas.microsoft.com/office/drawing/2014/main" id="{54345E65-50F5-455E-09B3-8EBB60E0E24E}"/>
+                <a16:creationId xmlns:a16="http://schemas.microsoft.com/office/drawing/2014/main" id="{27CE1EBF-65B9-1CD8-07BE-974837BF10B2}"/>
               </a:ext>
             </a:extLst>
           </p:cNvPr>
@@ -24980,7 +24980,7 @@
           <p:cNvPr id="6" name="TextBox 5">
             <a:extLst>
               <a:ext uri="{FF2B5EF4-FFF2-40B4-BE49-F238E27FC236}">
-                <a16:creationId xmlns:a16="http://schemas.microsoft.com/office/drawing/2014/main" id="{305BD8AC-FAE3-7964-2854-6A00C8E3F9B9}"/>
+                <a16:creationId xmlns:a16="http://schemas.microsoft.com/office/drawing/2014/main" id="{A558D256-8617-B727-74B0-D53AAAF6D6A1}"/>
               </a:ext>
             </a:extLst>
           </p:cNvPr>
@@ -25020,7 +25020,7 @@
           <p:cNvPr id="7" name="TextBox 6">
             <a:extLst>
               <a:ext uri="{FF2B5EF4-FFF2-40B4-BE49-F238E27FC236}">
-                <a16:creationId xmlns:a16="http://schemas.microsoft.com/office/drawing/2014/main" id="{BDF7E839-7DA0-8B17-88A3-4A65EC65C79D}"/>
+                <a16:creationId xmlns:a16="http://schemas.microsoft.com/office/drawing/2014/main" id="{32BAD10C-3126-71D1-1781-0748326DF731}"/>
               </a:ext>
             </a:extLst>
           </p:cNvPr>
@@ -25060,7 +25060,7 @@
           <p:cNvPr id="8" name="TextBox 7">
             <a:extLst>
               <a:ext uri="{FF2B5EF4-FFF2-40B4-BE49-F238E27FC236}">
-                <a16:creationId xmlns:a16="http://schemas.microsoft.com/office/drawing/2014/main" id="{5FD6A533-C9F5-FE4E-7609-0ABC01ACA69C}"/>
+                <a16:creationId xmlns:a16="http://schemas.microsoft.com/office/drawing/2014/main" id="{DEFD3B53-14BE-343A-1C16-63B6C1518055}"/>
               </a:ext>
             </a:extLst>
           </p:cNvPr>
@@ -25100,7 +25100,7 @@
           <p:cNvPr id="9" name="TextBox 8">
             <a:extLst>
               <a:ext uri="{FF2B5EF4-FFF2-40B4-BE49-F238E27FC236}">
-                <a16:creationId xmlns:a16="http://schemas.microsoft.com/office/drawing/2014/main" id="{B69A36A8-BD60-3E3C-109C-3D3235EDD160}"/>
+                <a16:creationId xmlns:a16="http://schemas.microsoft.com/office/drawing/2014/main" id="{FFD9226A-D5F2-B41B-9599-771B601B1AF4}"/>
               </a:ext>
             </a:extLst>
           </p:cNvPr>
@@ -25140,7 +25140,7 @@
           <p:cNvPr id="10" name="Rectangle: Rounded Corners 9">
             <a:extLst>
               <a:ext uri="{FF2B5EF4-FFF2-40B4-BE49-F238E27FC236}">
-                <a16:creationId xmlns:a16="http://schemas.microsoft.com/office/drawing/2014/main" id="{34EAEF97-1E78-060B-5636-B5CE108DDA92}"/>
+                <a16:creationId xmlns:a16="http://schemas.microsoft.com/office/drawing/2014/main" id="{9FFC0B50-4CE1-9A30-D71A-0A154F2E38C8}"/>
               </a:ext>
             </a:extLst>
           </p:cNvPr>
@@ -25202,7 +25202,7 @@
           <p:cNvPr id="11" name="TextBox 10">
             <a:extLst>
               <a:ext uri="{FF2B5EF4-FFF2-40B4-BE49-F238E27FC236}">
-                <a16:creationId xmlns:a16="http://schemas.microsoft.com/office/drawing/2014/main" id="{64B4397E-086D-A9EC-B1BA-13DAFB8B204A}"/>
+                <a16:creationId xmlns:a16="http://schemas.microsoft.com/office/drawing/2014/main" id="{3CED4A69-8388-D9D8-0D5C-A78C5F9353E3}"/>
               </a:ext>
             </a:extLst>
           </p:cNvPr>
@@ -25242,7 +25242,7 @@
           <p:cNvPr id="12" name="Rectangle 11">
             <a:extLst>
               <a:ext uri="{FF2B5EF4-FFF2-40B4-BE49-F238E27FC236}">
-                <a16:creationId xmlns:a16="http://schemas.microsoft.com/office/drawing/2014/main" id="{F821320C-A2F6-8F95-B346-E7165F5F8FA7}"/>
+                <a16:creationId xmlns:a16="http://schemas.microsoft.com/office/drawing/2014/main" id="{EC3B0924-E7F5-E8DE-9723-8B5AFCC5D437}"/>
               </a:ext>
             </a:extLst>
           </p:cNvPr>
@@ -25310,7 +25310,7 @@
           <p:cNvPr id="13" name="TextBox 12">
             <a:extLst>
               <a:ext uri="{FF2B5EF4-FFF2-40B4-BE49-F238E27FC236}">
-                <a16:creationId xmlns:a16="http://schemas.microsoft.com/office/drawing/2014/main" id="{022442D2-4CAC-08BA-30B0-8B20DC29C510}"/>
+                <a16:creationId xmlns:a16="http://schemas.microsoft.com/office/drawing/2014/main" id="{F1B6E344-F79A-644F-890E-87C1AE7F5DE5}"/>
               </a:ext>
             </a:extLst>
           </p:cNvPr>
@@ -25356,7 +25356,7 @@
           <p:cNvPr id="14" name="Rectangle: Rounded Corners 13">
             <a:extLst>
               <a:ext uri="{FF2B5EF4-FFF2-40B4-BE49-F238E27FC236}">
-                <a16:creationId xmlns:a16="http://schemas.microsoft.com/office/drawing/2014/main" id="{EBB370AE-FCB7-13B7-B693-CF9C7A7526F0}"/>
+                <a16:creationId xmlns:a16="http://schemas.microsoft.com/office/drawing/2014/main" id="{2D89F54A-396A-33A6-BC77-286BB4685E1B}"/>
               </a:ext>
             </a:extLst>
           </p:cNvPr>
@@ -25410,7 +25410,7 @@
           <p:cNvPr id="15" name="Pentagon 14">
             <a:extLst>
               <a:ext uri="{FF2B5EF4-FFF2-40B4-BE49-F238E27FC236}">
-                <a16:creationId xmlns:a16="http://schemas.microsoft.com/office/drawing/2014/main" id="{0444575E-F1DA-B9CD-7FF2-1D39BD40C59B}"/>
+                <a16:creationId xmlns:a16="http://schemas.microsoft.com/office/drawing/2014/main" id="{8FB1A6DF-AC61-4C88-F36F-D748BEFDE8F6}"/>
               </a:ext>
             </a:extLst>
           </p:cNvPr>
@@ -25464,7 +25464,7 @@
           <p:cNvPr id="16" name="Pentagon 15">
             <a:extLst>
               <a:ext uri="{FF2B5EF4-FFF2-40B4-BE49-F238E27FC236}">
-                <a16:creationId xmlns:a16="http://schemas.microsoft.com/office/drawing/2014/main" id="{3EF20085-1F7A-526F-DBF1-53D31EFE5678}"/>
+                <a16:creationId xmlns:a16="http://schemas.microsoft.com/office/drawing/2014/main" id="{2EC31EFE-A93C-6D42-9D14-EB35CBA66FA4}"/>
               </a:ext>
             </a:extLst>
           </p:cNvPr>
@@ -25518,7 +25518,7 @@
           <p:cNvPr id="17" name="Pentagon 16">
             <a:extLst>
               <a:ext uri="{FF2B5EF4-FFF2-40B4-BE49-F238E27FC236}">
-                <a16:creationId xmlns:a16="http://schemas.microsoft.com/office/drawing/2014/main" id="{5511321D-0BC2-4BDA-7F5F-99DEC3BC7B5F}"/>
+                <a16:creationId xmlns:a16="http://schemas.microsoft.com/office/drawing/2014/main" id="{4DDDF5FD-822C-2C38-2297-9148A7C33487}"/>
               </a:ext>
             </a:extLst>
           </p:cNvPr>
@@ -25572,7 +25572,7 @@
           <p:cNvPr id="18" name="Pentagon 17">
             <a:extLst>
               <a:ext uri="{FF2B5EF4-FFF2-40B4-BE49-F238E27FC236}">
-                <a16:creationId xmlns:a16="http://schemas.microsoft.com/office/drawing/2014/main" id="{7AD011D2-0C25-7E13-4ECC-CEF8574323A1}"/>
+                <a16:creationId xmlns:a16="http://schemas.microsoft.com/office/drawing/2014/main" id="{7155E85C-D332-0667-CA25-299202ADB156}"/>
               </a:ext>
             </a:extLst>
           </p:cNvPr>
@@ -25626,7 +25626,7 @@
           <p:cNvPr id="20" name="Picture 19">
             <a:extLst>
               <a:ext uri="{FF2B5EF4-FFF2-40B4-BE49-F238E27FC236}">
-                <a16:creationId xmlns:a16="http://schemas.microsoft.com/office/drawing/2014/main" id="{737660D5-5F8C-D7A4-68BD-CB73D30F5DA5}"/>
+                <a16:creationId xmlns:a16="http://schemas.microsoft.com/office/drawing/2014/main" id="{4FDC865E-163A-F8F2-F35A-61B5E8620A42}"/>
               </a:ext>
             </a:extLst>
           </p:cNvPr>
@@ -25662,7 +25662,7 @@
           <p:cNvPr id="21" name="Rectangle: Rounded Corners 20">
             <a:extLst>
               <a:ext uri="{FF2B5EF4-FFF2-40B4-BE49-F238E27FC236}">
-                <a16:creationId xmlns:a16="http://schemas.microsoft.com/office/drawing/2014/main" id="{F6A3DF06-6C44-4AAE-52C0-B0A3FB536996}"/>
+                <a16:creationId xmlns:a16="http://schemas.microsoft.com/office/drawing/2014/main" id="{82CC56BA-B07B-ABE8-3D26-61552D32271E}"/>
               </a:ext>
             </a:extLst>
           </p:cNvPr>
@@ -25724,7 +25724,7 @@
           <p:cNvPr id="22" name="TextBox 21">
             <a:extLst>
               <a:ext uri="{FF2B5EF4-FFF2-40B4-BE49-F238E27FC236}">
-                <a16:creationId xmlns:a16="http://schemas.microsoft.com/office/drawing/2014/main" id="{8F07858A-32A3-4CDD-DBE1-14B5400EE8D3}"/>
+                <a16:creationId xmlns:a16="http://schemas.microsoft.com/office/drawing/2014/main" id="{7BE72059-E6F0-0464-A236-BEAD6BF44C1E}"/>
               </a:ext>
             </a:extLst>
           </p:cNvPr>
@@ -25764,7 +25764,7 @@
           <p:cNvPr id="23" name="Rectangle: Rounded Corners 22">
             <a:extLst>
               <a:ext uri="{FF2B5EF4-FFF2-40B4-BE49-F238E27FC236}">
-                <a16:creationId xmlns:a16="http://schemas.microsoft.com/office/drawing/2014/main" id="{B9C8798F-8D21-139D-EDAB-51464A3EC18D}"/>
+                <a16:creationId xmlns:a16="http://schemas.microsoft.com/office/drawing/2014/main" id="{214797DA-0490-B894-6DB8-5428A2EA3F7C}"/>
               </a:ext>
             </a:extLst>
           </p:cNvPr>
@@ -25842,7 +25842,7 @@
           <p:cNvPr id="27" name="Group 26">
             <a:extLst>
               <a:ext uri="{FF2B5EF4-FFF2-40B4-BE49-F238E27FC236}">
-                <a16:creationId xmlns:a16="http://schemas.microsoft.com/office/drawing/2014/main" id="{7DF2AF0D-66CC-FE73-D8BE-C7170EBD4D37}"/>
+                <a16:creationId xmlns:a16="http://schemas.microsoft.com/office/drawing/2014/main" id="{D6B74432-061C-1877-0A6D-B3A42D214331}"/>
               </a:ext>
             </a:extLst>
           </p:cNvPr>
@@ -25862,7 +25862,7 @@
             <p:cNvPr id="24" name="Rectangle: Rounded Corners 23">
               <a:extLst>
                 <a:ext uri="{FF2B5EF4-FFF2-40B4-BE49-F238E27FC236}">
-                  <a16:creationId xmlns:a16="http://schemas.microsoft.com/office/drawing/2014/main" id="{E3A1E4F8-57AA-8AB2-D54A-5A69F67B66CC}"/>
+                  <a16:creationId xmlns:a16="http://schemas.microsoft.com/office/drawing/2014/main" id="{39470109-6A8B-6423-7005-078E1A5F3E1D}"/>
                 </a:ext>
               </a:extLst>
             </p:cNvPr>
@@ -25916,7 +25916,7 @@
             <p:cNvPr id="25" name="Rectangle: Rounded Corners 24">
               <a:extLst>
                 <a:ext uri="{FF2B5EF4-FFF2-40B4-BE49-F238E27FC236}">
-                  <a16:creationId xmlns:a16="http://schemas.microsoft.com/office/drawing/2014/main" id="{19C2DA16-CE34-0FB4-45FB-77A2F09BA574}"/>
+                  <a16:creationId xmlns:a16="http://schemas.microsoft.com/office/drawing/2014/main" id="{7EB1FCB0-DD96-38F9-324E-31B0EE6EACAA}"/>
                 </a:ext>
               </a:extLst>
             </p:cNvPr>
@@ -25978,7 +25978,7 @@
             <p:cNvPr id="26" name="TextBox 25">
               <a:extLst>
                 <a:ext uri="{FF2B5EF4-FFF2-40B4-BE49-F238E27FC236}">
-                  <a16:creationId xmlns:a16="http://schemas.microsoft.com/office/drawing/2014/main" id="{6BA1254D-35E0-2DED-8FE2-360E19BB3DD2}"/>
+                  <a16:creationId xmlns:a16="http://schemas.microsoft.com/office/drawing/2014/main" id="{E6F031FA-460A-24F0-936D-432643B4FD46}"/>
                 </a:ext>
               </a:extLst>
             </p:cNvPr>
@@ -26025,7 +26025,7 @@
           <p:cNvPr id="31" name="Group 30">
             <a:extLst>
               <a:ext uri="{FF2B5EF4-FFF2-40B4-BE49-F238E27FC236}">
-                <a16:creationId xmlns:a16="http://schemas.microsoft.com/office/drawing/2014/main" id="{1431A966-9B13-399D-DCAA-9613F9940B48}"/>
+                <a16:creationId xmlns:a16="http://schemas.microsoft.com/office/drawing/2014/main" id="{F3AD7BAD-367A-EB9C-E159-037E43F30F7A}"/>
               </a:ext>
             </a:extLst>
           </p:cNvPr>
@@ -26045,7 +26045,7 @@
             <p:cNvPr id="28" name="Rectangle: Rounded Corners 27">
               <a:extLst>
                 <a:ext uri="{FF2B5EF4-FFF2-40B4-BE49-F238E27FC236}">
-                  <a16:creationId xmlns:a16="http://schemas.microsoft.com/office/drawing/2014/main" id="{83F2DC36-2791-E0F1-FCB4-6BFCEE9C763B}"/>
+                  <a16:creationId xmlns:a16="http://schemas.microsoft.com/office/drawing/2014/main" id="{9B389802-5D73-1F44-179A-F3DDF9C76786}"/>
                 </a:ext>
               </a:extLst>
             </p:cNvPr>
@@ -26099,7 +26099,7 @@
             <p:cNvPr id="29" name="Rectangle: Rounded Corners 28">
               <a:extLst>
                 <a:ext uri="{FF2B5EF4-FFF2-40B4-BE49-F238E27FC236}">
-                  <a16:creationId xmlns:a16="http://schemas.microsoft.com/office/drawing/2014/main" id="{00FDC02B-E8FD-9B49-591D-BC99D6BD33A9}"/>
+                  <a16:creationId xmlns:a16="http://schemas.microsoft.com/office/drawing/2014/main" id="{27447B4E-1FC7-A9C1-AF38-344CD6EA3B26}"/>
                 </a:ext>
               </a:extLst>
             </p:cNvPr>
@@ -26161,7 +26161,7 @@
             <p:cNvPr id="30" name="TextBox 29">
               <a:extLst>
                 <a:ext uri="{FF2B5EF4-FFF2-40B4-BE49-F238E27FC236}">
-                  <a16:creationId xmlns:a16="http://schemas.microsoft.com/office/drawing/2014/main" id="{2BE888BE-CC8B-29B8-BB31-0D9D39C3C09E}"/>
+                  <a16:creationId xmlns:a16="http://schemas.microsoft.com/office/drawing/2014/main" id="{5EA2931B-46BD-0865-5EA8-940A55DD7F65}"/>
                 </a:ext>
               </a:extLst>
             </p:cNvPr>
@@ -26208,7 +26208,7 @@
           <p:cNvPr id="35" name="Group 34">
             <a:extLst>
               <a:ext uri="{FF2B5EF4-FFF2-40B4-BE49-F238E27FC236}">
-                <a16:creationId xmlns:a16="http://schemas.microsoft.com/office/drawing/2014/main" id="{3A6B815F-A823-FDAA-3AAC-A2FFAF4C9483}"/>
+                <a16:creationId xmlns:a16="http://schemas.microsoft.com/office/drawing/2014/main" id="{B00ED497-CD75-F184-E0A5-18D1C5CBDB68}"/>
               </a:ext>
             </a:extLst>
           </p:cNvPr>
@@ -26228,7 +26228,7 @@
             <p:cNvPr id="32" name="Rectangle: Rounded Corners 31">
               <a:extLst>
                 <a:ext uri="{FF2B5EF4-FFF2-40B4-BE49-F238E27FC236}">
-                  <a16:creationId xmlns:a16="http://schemas.microsoft.com/office/drawing/2014/main" id="{E34A9216-7098-34FA-ABF5-7FB5E0F1F201}"/>
+                  <a16:creationId xmlns:a16="http://schemas.microsoft.com/office/drawing/2014/main" id="{4F8A83E8-4500-C799-FCDB-F4E19F3E41DB}"/>
                 </a:ext>
               </a:extLst>
             </p:cNvPr>
@@ -26282,7 +26282,7 @@
             <p:cNvPr id="33" name="Rectangle: Rounded Corners 32">
               <a:extLst>
                 <a:ext uri="{FF2B5EF4-FFF2-40B4-BE49-F238E27FC236}">
-                  <a16:creationId xmlns:a16="http://schemas.microsoft.com/office/drawing/2014/main" id="{CEC06ACD-390E-0C76-9DD6-765D89B1A2F7}"/>
+                  <a16:creationId xmlns:a16="http://schemas.microsoft.com/office/drawing/2014/main" id="{54011E15-36EF-7658-BCA4-93CACC387950}"/>
                 </a:ext>
               </a:extLst>
             </p:cNvPr>
@@ -26344,7 +26344,7 @@
             <p:cNvPr id="34" name="TextBox 33">
               <a:extLst>
                 <a:ext uri="{FF2B5EF4-FFF2-40B4-BE49-F238E27FC236}">
-                  <a16:creationId xmlns:a16="http://schemas.microsoft.com/office/drawing/2014/main" id="{222A4172-FADE-33BE-6E5C-B5F143C09744}"/>
+                  <a16:creationId xmlns:a16="http://schemas.microsoft.com/office/drawing/2014/main" id="{D8408222-1984-B889-A904-F92DB1741A6C}"/>
                 </a:ext>
               </a:extLst>
             </p:cNvPr>
@@ -26391,7 +26391,7 @@
           <p:cNvPr id="36" name="Rectangle 35">
             <a:extLst>
               <a:ext uri="{FF2B5EF4-FFF2-40B4-BE49-F238E27FC236}">
-                <a16:creationId xmlns:a16="http://schemas.microsoft.com/office/drawing/2014/main" id="{475CE760-A4FA-082B-E1FE-808A3D18EE06}"/>
+                <a16:creationId xmlns:a16="http://schemas.microsoft.com/office/drawing/2014/main" id="{9C21B2E1-1137-234C-7C3C-375A6359091F}"/>
               </a:ext>
             </a:extLst>
           </p:cNvPr>
@@ -26459,7 +26459,7 @@
           <p:cNvPr id="37" name="TextBox 36">
             <a:extLst>
               <a:ext uri="{FF2B5EF4-FFF2-40B4-BE49-F238E27FC236}">
-                <a16:creationId xmlns:a16="http://schemas.microsoft.com/office/drawing/2014/main" id="{7683C9E9-3A33-770F-48C0-4A21933484DE}"/>
+                <a16:creationId xmlns:a16="http://schemas.microsoft.com/office/drawing/2014/main" id="{BB33B981-E6A4-ACC0-B00F-3CD209A3AEE1}"/>
               </a:ext>
             </a:extLst>
           </p:cNvPr>
@@ -26499,7 +26499,7 @@
           <p:cNvPr id="38" name="TextBox 37">
             <a:extLst>
               <a:ext uri="{FF2B5EF4-FFF2-40B4-BE49-F238E27FC236}">
-                <a16:creationId xmlns:a16="http://schemas.microsoft.com/office/drawing/2014/main" id="{D50A6592-078C-8B84-1F77-2EF72E56A896}"/>
+                <a16:creationId xmlns:a16="http://schemas.microsoft.com/office/drawing/2014/main" id="{9FC92F06-11D0-A8F8-A247-62F544F23754}"/>
               </a:ext>
             </a:extLst>
           </p:cNvPr>
@@ -26540,7 +26540,7 @@
           <p:cNvPr id="39" name="TextBox 38">
             <a:extLst>
               <a:ext uri="{FF2B5EF4-FFF2-40B4-BE49-F238E27FC236}">
-                <a16:creationId xmlns:a16="http://schemas.microsoft.com/office/drawing/2014/main" id="{A9609F37-18CB-F6C2-8F6F-5FDA69387EA6}"/>
+                <a16:creationId xmlns:a16="http://schemas.microsoft.com/office/drawing/2014/main" id="{E202551C-2541-63F6-9001-DD4010440522}"/>
               </a:ext>
             </a:extLst>
           </p:cNvPr>
@@ -26579,7 +26579,7 @@
     </p:spTree>
     <p:extLst>
       <p:ext uri="{BB962C8B-B14F-4D97-AF65-F5344CB8AC3E}">
-        <p14:creationId xmlns:p14="http://schemas.microsoft.com/office/powerpoint/2010/main" val="677967278"/>
+        <p14:creationId xmlns:p14="http://schemas.microsoft.com/office/powerpoint/2010/main" val="2972630314"/>
       </p:ext>
     </p:extLst>
   </p:cSld>

</xml_diff>